<commit_message>
Update V11 STQC agent capabilities slide
Co-authored-by: Shyam <shyam.nexus@gmail.com>
</commit_message>
<xml_diff>
--- a/AI-Driven Embedded Product Lifecycle OrchestratorV11.pptx
+++ b/AI-Driven Embedded Product Lifecycle OrchestratorV11.pptx
@@ -26259,7 +26259,7 @@
             <a:avLst/>
           </a:prstGeom>
           <a:solidFill>
-            <a:srgbClr val="111111"/>
+            <a:srgbClr val="020A1A"/>
           </a:solidFill>
           <a:ln>
             <a:noFill/>
@@ -26284,7 +26284,6 @@
           <a:lstStyle/>
           <a:p>
             <a:pPr algn="ctr"/>
-            <a:endParaRPr/>
           </a:p>
         </p:txBody>
       </p:sp>
@@ -26303,7 +26302,7 @@
             <a:avLst/>
           </a:prstGeom>
           <a:solidFill>
-            <a:srgbClr val="D71920"/>
+            <a:srgbClr val="F5C518"/>
           </a:solidFill>
           <a:ln>
             <a:noFill/>
@@ -26328,7 +26327,6 @@
           <a:lstStyle/>
           <a:p>
             <a:pPr algn="ctr"/>
-            <a:endParaRPr/>
           </a:p>
         </p:txBody>
       </p:sp>
@@ -26341,13 +26339,13 @@
         <p:spPr>
           <a:xfrm>
             <a:off x="347472" y="438912"/>
-            <a:ext cx="2011680" cy="274320"/>
+            <a:ext cx="2057400" cy="274320"/>
           </a:xfrm>
           <a:prstGeom prst="roundRect">
             <a:avLst/>
           </a:prstGeom>
           <a:solidFill>
-            <a:srgbClr val="D71920"/>
+            <a:srgbClr val="F5C518"/>
           </a:solidFill>
           <a:ln>
             <a:noFill/>
@@ -26372,7 +26370,6 @@
           <a:lstStyle/>
           <a:p>
             <a:pPr algn="ctr"/>
-            <a:endParaRPr/>
           </a:p>
         </p:txBody>
       </p:sp>
@@ -26384,28 +26381,27 @@
         </p:nvSpPr>
         <p:spPr>
           <a:xfrm>
-            <a:off x="347472" y="438912"/>
-            <a:ext cx="2011680" cy="274320"/>
+            <a:off x="347472" y="484632"/>
+            <a:ext cx="2057400" cy="109728"/>
           </a:xfrm>
           <a:prstGeom prst="rect">
             <a:avLst/>
           </a:prstGeom>
           <a:noFill/>
-          <a:ln/>
-        </p:spPr>
-        <p:txBody>
-          <a:bodyPr wrap="square">
+        </p:spPr>
+        <p:txBody>
+          <a:bodyPr wrap="square" lIns="36576" rIns="36576" tIns="18288" bIns="18288">
             <a:spAutoFit/>
           </a:bodyPr>
           <a:lstStyle/>
           <a:p>
             <a:pPr algn="ctr"/>
             <a:r>
-              <a:rPr sz="900" b="1" i="0">
+              <a:rPr sz="850" b="1" i="0">
                 <a:solidFill>
                   <a:srgbClr val="FFFFFF"/>
                 </a:solidFill>
-                <a:latin typeface="Arial"/>
+                <a:latin typeface="Segoe UI"/>
               </a:rPr>
               <a:t>PG5 STQC AGENT</a:t>
             </a:r>
@@ -26421,29 +26417,28 @@
         <p:spPr>
           <a:xfrm>
             <a:off x="347472" y="749808"/>
-            <a:ext cx="8229600" cy="461665"/>
+            <a:ext cx="8458200" cy="475488"/>
           </a:xfrm>
           <a:prstGeom prst="rect">
             <a:avLst/>
           </a:prstGeom>
           <a:noFill/>
-          <a:ln/>
-        </p:spPr>
-        <p:txBody>
-          <a:bodyPr wrap="square">
+        </p:spPr>
+        <p:txBody>
+          <a:bodyPr wrap="square" lIns="36576" rIns="36576" tIns="18288" bIns="18288">
             <a:spAutoFit/>
           </a:bodyPr>
           <a:lstStyle/>
           <a:p>
             <a:pPr algn="l"/>
             <a:r>
-              <a:rPr sz="2400" b="1" i="0">
+              <a:rPr sz="2250" b="1" i="0">
                 <a:solidFill>
                   <a:srgbClr val="FFFFFF"/>
                 </a:solidFill>
-                <a:latin typeface="Arial"/>
+                <a:latin typeface="Segoe UI"/>
               </a:rPr>
-              <a:t>STQC Agent for BIS Certification</a:t>
+              <a:t>STQC Agent: Memory, Indexing and Certification Evidence</a:t>
             </a:r>
           </a:p>
         </p:txBody>
@@ -26456,14 +26451,14 @@
         </p:nvSpPr>
         <p:spPr>
           <a:xfrm>
-            <a:off x="365760" y="1325880"/>
-            <a:ext cx="8412480" cy="14630"/>
+            <a:off x="347472" y="1325880"/>
+            <a:ext cx="8449056" cy="14630"/>
           </a:xfrm>
           <a:prstGeom prst="rect">
             <a:avLst/>
           </a:prstGeom>
           <a:solidFill>
-            <a:srgbClr val="D71920"/>
+            <a:srgbClr val="F5C518"/>
           </a:solidFill>
           <a:ln>
             <a:noFill/>
@@ -26488,7 +26483,6 @@
           <a:lstStyle/>
           <a:p>
             <a:pPr algn="ctr"/>
-            <a:endParaRPr/>
           </a:p>
         </p:txBody>
       </p:sp>
@@ -26501,29 +26495,28 @@
         <p:spPr>
           <a:xfrm>
             <a:off x="347472" y="1417320"/>
-            <a:ext cx="8503920" cy="461665"/>
+            <a:ext cx="8503920" cy="384048"/>
           </a:xfrm>
           <a:prstGeom prst="rect">
             <a:avLst/>
           </a:prstGeom>
           <a:noFill/>
-          <a:ln/>
-        </p:spPr>
-        <p:txBody>
-          <a:bodyPr wrap="square">
+        </p:spPr>
+        <p:txBody>
+          <a:bodyPr wrap="square" lIns="36576" rIns="36576" tIns="18288" bIns="18288">
             <a:spAutoFit/>
           </a:bodyPr>
           <a:lstStyle/>
           <a:p>
             <a:pPr algn="l"/>
             <a:r>
-              <a:rPr sz="1200" b="0" i="1" dirty="0">
+              <a:rPr sz="1050" b="0" i="1">
                 <a:solidFill>
-                  <a:srgbClr val="E8E8E8"/>
+                  <a:srgbClr val="B8D0EC"/>
                 </a:solidFill>
-                <a:latin typeface="Arial"/>
+                <a:latin typeface="Segoe UI"/>
               </a:rPr>
-              <a:t>IoT security and surveillance devices need BIS certification governed by STQC guidelines for in-house designs and BTS sales.</a:t>
+              <a:t>Extends PG5 beyond evidence generation: agents preserve task memory, execute Jira plans through Q&amp;A, index the codebase, and produce STQC-ready TCF/compliance artifacts.</a:t>
             </a:r>
           </a:p>
         </p:txBody>
@@ -26536,17 +26529,19 @@
         </p:nvSpPr>
         <p:spPr>
           <a:xfrm>
-            <a:off x="320040" y="2011680"/>
-            <a:ext cx="5029200" cy="1353312"/>
+            <a:off x="347472" y="1993392"/>
+            <a:ext cx="2029968" cy="1664208"/>
           </a:xfrm>
           <a:prstGeom prst="roundRect">
             <a:avLst/>
           </a:prstGeom>
           <a:solidFill>
-            <a:srgbClr val="333333"/>
-          </a:solidFill>
-          <a:ln>
-            <a:noFill/>
+            <a:srgbClr val="0F2845"/>
+          </a:solidFill>
+          <a:ln>
+            <a:solidFill>
+              <a:srgbClr val="144A70"/>
+            </a:solidFill>
           </a:ln>
         </p:spPr>
         <p:style>
@@ -26568,7 +26563,6 @@
           <a:lstStyle/>
           <a:p>
             <a:pPr algn="ctr"/>
-            <a:endParaRPr/>
           </a:p>
         </p:txBody>
       </p:sp>
@@ -26580,14 +26574,14 @@
         </p:nvSpPr>
         <p:spPr>
           <a:xfrm>
-            <a:off x="320040" y="2011680"/>
-            <a:ext cx="50292" cy="1353312"/>
+            <a:off x="347472" y="1993392"/>
+            <a:ext cx="2029968" cy="50292"/>
           </a:xfrm>
           <a:prstGeom prst="rect">
             <a:avLst/>
           </a:prstGeom>
           <a:solidFill>
-            <a:srgbClr val="2E7D32"/>
+            <a:srgbClr val="00C8F0"/>
           </a:solidFill>
           <a:ln>
             <a:noFill/>
@@ -26612,26 +26606,25 @@
           <a:lstStyle/>
           <a:p>
             <a:pPr algn="ctr"/>
-            <a:endParaRPr/>
-          </a:p>
-        </p:txBody>
-      </p:sp>
-      <p:sp>
-        <p:nvSpPr>
-          <p:cNvPr id="11" name="Rounded Rectangle 10"/>
-          <p:cNvSpPr/>
-          <p:nvPr/>
-        </p:nvSpPr>
-        <p:spPr>
-          <a:xfrm>
-            <a:off x="475488" y="2395728"/>
-            <a:ext cx="502920" cy="502920"/>
-          </a:xfrm>
-          <a:prstGeom prst="roundRect">
-            <a:avLst/>
-          </a:prstGeom>
-          <a:solidFill>
-            <a:srgbClr val="2E7D32"/>
+          </a:p>
+        </p:txBody>
+      </p:sp>
+      <p:sp>
+        <p:nvSpPr>
+          <p:cNvPr id="11" name="Oval 10"/>
+          <p:cNvSpPr/>
+          <p:nvPr/>
+        </p:nvSpPr>
+        <p:spPr>
+          <a:xfrm>
+            <a:off x="457200" y="2176272"/>
+            <a:ext cx="384048" cy="384048"/>
+          </a:xfrm>
+          <a:prstGeom prst="ellipse">
+            <a:avLst/>
+          </a:prstGeom>
+          <a:solidFill>
+            <a:srgbClr val="00C8F0"/>
           </a:solidFill>
           <a:ln>
             <a:noFill/>
@@ -26656,7 +26649,6 @@
           <a:lstStyle/>
           <a:p>
             <a:pPr algn="ctr"/>
-            <a:endParaRPr/>
           </a:p>
         </p:txBody>
       </p:sp>
@@ -26668,30 +26660,29 @@
         </p:nvSpPr>
         <p:spPr>
           <a:xfrm>
-            <a:off x="475488" y="2395728"/>
-            <a:ext cx="502920" cy="502920"/>
+            <a:off x="457200" y="2276856"/>
+            <a:ext cx="384048" cy="91440"/>
           </a:xfrm>
           <a:prstGeom prst="rect">
             <a:avLst/>
           </a:prstGeom>
           <a:noFill/>
-          <a:ln/>
-        </p:spPr>
-        <p:txBody>
-          <a:bodyPr wrap="square">
+        </p:spPr>
+        <p:txBody>
+          <a:bodyPr wrap="square" lIns="36576" rIns="36576" tIns="18288" bIns="18288">
             <a:spAutoFit/>
           </a:bodyPr>
           <a:lstStyle/>
           <a:p>
             <a:pPr algn="ctr"/>
             <a:r>
-              <a:rPr sz="1600" b="1" i="0">
+              <a:rPr sz="819" b="1" i="0">
                 <a:solidFill>
                   <a:srgbClr val="FFFFFF"/>
                 </a:solidFill>
-                <a:latin typeface="Arial"/>
+                <a:latin typeface="Segoe UI"/>
               </a:rPr>
-              <a:t>✓</a:t>
+              <a:t>01</a:t>
             </a:r>
           </a:p>
         </p:txBody>
@@ -26704,90 +26695,132 @@
         </p:nvSpPr>
         <p:spPr>
           <a:xfrm>
-            <a:off x="1115568" y="2084832"/>
-            <a:ext cx="4114800" cy="502920"/>
+            <a:off x="914400" y="2103120"/>
+            <a:ext cx="1335024" cy="329184"/>
           </a:xfrm>
           <a:prstGeom prst="rect">
             <a:avLst/>
           </a:prstGeom>
           <a:noFill/>
-          <a:ln/>
-        </p:spPr>
-        <p:txBody>
-          <a:bodyPr wrap="square">
+        </p:spPr>
+        <p:txBody>
+          <a:bodyPr wrap="square" lIns="36576" rIns="36576" tIns="18288" bIns="18288">
             <a:spAutoFit/>
           </a:bodyPr>
           <a:lstStyle/>
           <a:p>
             <a:pPr algn="l"/>
             <a:r>
-              <a:rPr sz="1300" b="1" i="0">
+              <a:rPr sz="1000" b="1" i="0">
                 <a:solidFill>
-                  <a:srgbClr val="2E7D32"/>
+                  <a:srgbClr val="00C8F0"/>
                 </a:solidFill>
-                <a:latin typeface="Arial"/>
+                <a:latin typeface="Segoe UI"/>
               </a:rPr>
-              <a:t>Creates STQC
-Audit Evidence</a:t>
+              <a:t>Task Memory</a:t>
             </a:r>
           </a:p>
         </p:txBody>
       </p:sp>
       <p:sp>
         <p:nvSpPr>
-          <p:cNvPr id="14" name="TextBox 13"/>
+          <p:cNvPr id="14" name="Rectangle 13"/>
+          <p:cNvSpPr/>
+          <p:nvPr/>
+        </p:nvSpPr>
+        <p:spPr>
+          <a:xfrm>
+            <a:off x="493776" y="2615184"/>
+            <a:ext cx="1737360" cy="10972"/>
+          </a:xfrm>
+          <a:prstGeom prst="rect">
+            <a:avLst/>
+          </a:prstGeom>
+          <a:solidFill>
+            <a:srgbClr val="00C8F0"/>
+          </a:solidFill>
+          <a:ln>
+            <a:noFill/>
+          </a:ln>
+        </p:spPr>
+        <p:style>
+          <a:lnRef idx="1">
+            <a:schemeClr val="accent1"/>
+          </a:lnRef>
+          <a:fillRef idx="3">
+            <a:schemeClr val="accent1"/>
+          </a:fillRef>
+          <a:effectRef idx="2">
+            <a:schemeClr val="accent1"/>
+          </a:effectRef>
+          <a:fontRef idx="minor">
+            <a:schemeClr val="lt1"/>
+          </a:fontRef>
+        </p:style>
+        <p:txBody>
+          <a:bodyPr rtlCol="0" anchor="ctr"/>
+          <a:lstStyle/>
+          <a:p>
+            <a:pPr algn="ctr"/>
+          </a:p>
+        </p:txBody>
+      </p:sp>
+      <p:sp>
+        <p:nvSpPr>
+          <p:cNvPr id="15" name="TextBox 14"/>
           <p:cNvSpPr txBox="1"/>
           <p:nvPr/>
         </p:nvSpPr>
         <p:spPr>
           <a:xfrm>
-            <a:off x="1115568" y="2606040"/>
-            <a:ext cx="4069080" cy="685800"/>
+            <a:off x="493776" y="2743200"/>
+            <a:ext cx="1737360" cy="658368"/>
           </a:xfrm>
           <a:prstGeom prst="rect">
             <a:avLst/>
           </a:prstGeom>
           <a:noFill/>
-          <a:ln/>
-        </p:spPr>
-        <p:txBody>
-          <a:bodyPr wrap="square">
+        </p:spPr>
+        <p:txBody>
+          <a:bodyPr wrap="square" lIns="36576" rIns="36576" tIns="18288" bIns="18288">
             <a:spAutoFit/>
           </a:bodyPr>
           <a:lstStyle/>
           <a:p>
             <a:pPr algn="l"/>
             <a:r>
-              <a:rPr sz="1150" b="0" i="0">
+              <a:rPr sz="819" b="0" i="0">
                 <a:solidFill>
-                  <a:srgbClr val="E8E8E8"/>
+                  <a:srgbClr val="B8D0EC"/>
                 </a:solidFill>
-                <a:latin typeface="Arial"/>
+                <a:latin typeface="Segoe UI"/>
               </a:rPr>
-              <a:t>Crawls code, configuration and evidence sources to prepare auditor-ready STQC artifacts.</a:t>
+              <a:t>Agents auto-generate context dump files after each task so future agents resume with full awareness.</a:t>
             </a:r>
           </a:p>
         </p:txBody>
       </p:sp>
       <p:sp>
         <p:nvSpPr>
-          <p:cNvPr id="15" name="Rounded Rectangle 14"/>
-          <p:cNvSpPr/>
-          <p:nvPr/>
-        </p:nvSpPr>
-        <p:spPr>
-          <a:xfrm>
-            <a:off x="320040" y="3520440"/>
-            <a:ext cx="5029200" cy="1353312"/>
+          <p:cNvPr id="16" name="Rounded Rectangle 15"/>
+          <p:cNvSpPr/>
+          <p:nvPr/>
+        </p:nvSpPr>
+        <p:spPr>
+          <a:xfrm>
+            <a:off x="2560320" y="1993392"/>
+            <a:ext cx="2029968" cy="1664208"/>
           </a:xfrm>
           <a:prstGeom prst="roundRect">
             <a:avLst/>
           </a:prstGeom>
           <a:solidFill>
-            <a:srgbClr val="333333"/>
-          </a:solidFill>
-          <a:ln>
-            <a:noFill/>
+            <a:srgbClr val="0F2845"/>
+          </a:solidFill>
+          <a:ln>
+            <a:solidFill>
+              <a:srgbClr val="144A70"/>
+            </a:solidFill>
           </a:ln>
         </p:spPr>
         <p:style>
@@ -26809,26 +26842,25 @@
           <a:lstStyle/>
           <a:p>
             <a:pPr algn="ctr"/>
-            <a:endParaRPr/>
-          </a:p>
-        </p:txBody>
-      </p:sp>
-      <p:sp>
-        <p:nvSpPr>
-          <p:cNvPr id="16" name="Rectangle 15"/>
-          <p:cNvSpPr/>
-          <p:nvPr/>
-        </p:nvSpPr>
-        <p:spPr>
-          <a:xfrm>
-            <a:off x="320040" y="3520440"/>
-            <a:ext cx="50292" cy="1353312"/>
+          </a:p>
+        </p:txBody>
+      </p:sp>
+      <p:sp>
+        <p:nvSpPr>
+          <p:cNvPr id="17" name="Rectangle 16"/>
+          <p:cNvSpPr/>
+          <p:nvPr/>
+        </p:nvSpPr>
+        <p:spPr>
+          <a:xfrm>
+            <a:off x="2560320" y="1993392"/>
+            <a:ext cx="2029968" cy="50292"/>
           </a:xfrm>
           <a:prstGeom prst="rect">
             <a:avLst/>
           </a:prstGeom>
           <a:solidFill>
-            <a:srgbClr val="D71920"/>
+            <a:srgbClr val="0072C6"/>
           </a:solidFill>
           <a:ln>
             <a:noFill/>
@@ -26853,26 +26885,25 @@
           <a:lstStyle/>
           <a:p>
             <a:pPr algn="ctr"/>
-            <a:endParaRPr/>
-          </a:p>
-        </p:txBody>
-      </p:sp>
-      <p:sp>
-        <p:nvSpPr>
-          <p:cNvPr id="17" name="Rounded Rectangle 16"/>
-          <p:cNvSpPr/>
-          <p:nvPr/>
-        </p:nvSpPr>
-        <p:spPr>
-          <a:xfrm>
-            <a:off x="475488" y="3904488"/>
-            <a:ext cx="502920" cy="502920"/>
-          </a:xfrm>
-          <a:prstGeom prst="roundRect">
-            <a:avLst/>
-          </a:prstGeom>
-          <a:solidFill>
-            <a:srgbClr val="D71920"/>
+          </a:p>
+        </p:txBody>
+      </p:sp>
+      <p:sp>
+        <p:nvSpPr>
+          <p:cNvPr id="18" name="Oval 17"/>
+          <p:cNvSpPr/>
+          <p:nvPr/>
+        </p:nvSpPr>
+        <p:spPr>
+          <a:xfrm>
+            <a:off x="2670048" y="2176272"/>
+            <a:ext cx="384048" cy="384048"/>
+          </a:xfrm>
+          <a:prstGeom prst="ellipse">
+            <a:avLst/>
+          </a:prstGeom>
+          <a:solidFill>
+            <a:srgbClr val="0072C6"/>
           </a:solidFill>
           <a:ln>
             <a:noFill/>
@@ -26897,138 +26928,178 @@
           <a:lstStyle/>
           <a:p>
             <a:pPr algn="ctr"/>
-            <a:endParaRPr/>
-          </a:p>
-        </p:txBody>
-      </p:sp>
-      <p:sp>
-        <p:nvSpPr>
-          <p:cNvPr id="18" name="TextBox 17"/>
+          </a:p>
+        </p:txBody>
+      </p:sp>
+      <p:sp>
+        <p:nvSpPr>
+          <p:cNvPr id="19" name="TextBox 18"/>
           <p:cNvSpPr txBox="1"/>
           <p:nvPr/>
         </p:nvSpPr>
         <p:spPr>
           <a:xfrm>
-            <a:off x="475488" y="3904488"/>
-            <a:ext cx="502920" cy="502920"/>
+            <a:off x="2670048" y="2276856"/>
+            <a:ext cx="384048" cy="91440"/>
           </a:xfrm>
           <a:prstGeom prst="rect">
             <a:avLst/>
           </a:prstGeom>
           <a:noFill/>
-          <a:ln/>
-        </p:spPr>
-        <p:txBody>
-          <a:bodyPr wrap="square">
+        </p:spPr>
+        <p:txBody>
+          <a:bodyPr wrap="square" lIns="36576" rIns="36576" tIns="18288" bIns="18288">
             <a:spAutoFit/>
           </a:bodyPr>
           <a:lstStyle/>
           <a:p>
             <a:pPr algn="ctr"/>
             <a:r>
-              <a:rPr sz="1600" b="1" i="0">
+              <a:rPr sz="819" b="1" i="0">
                 <a:solidFill>
                   <a:srgbClr val="FFFFFF"/>
                 </a:solidFill>
-                <a:latin typeface="Arial"/>
+                <a:latin typeface="Segoe UI"/>
               </a:rPr>
-              <a:t>◈</a:t>
+              <a:t>02</a:t>
             </a:r>
           </a:p>
         </p:txBody>
       </p:sp>
       <p:sp>
         <p:nvSpPr>
-          <p:cNvPr id="19" name="TextBox 18"/>
+          <p:cNvPr id="20" name="TextBox 19"/>
           <p:cNvSpPr txBox="1"/>
           <p:nvPr/>
         </p:nvSpPr>
         <p:spPr>
           <a:xfrm>
-            <a:off x="1115568" y="3593592"/>
-            <a:ext cx="4114800" cy="502920"/>
+            <a:off x="3127248" y="2103120"/>
+            <a:ext cx="1335024" cy="329184"/>
           </a:xfrm>
           <a:prstGeom prst="rect">
             <a:avLst/>
           </a:prstGeom>
           <a:noFill/>
-          <a:ln/>
-        </p:spPr>
-        <p:txBody>
-          <a:bodyPr wrap="square">
+        </p:spPr>
+        <p:txBody>
+          <a:bodyPr wrap="square" lIns="36576" rIns="36576" tIns="18288" bIns="18288">
             <a:spAutoFit/>
           </a:bodyPr>
           <a:lstStyle/>
           <a:p>
             <a:pPr algn="l"/>
             <a:r>
-              <a:rPr sz="1300" b="1" i="0">
+              <a:rPr sz="1000" b="1" i="0">
                 <a:solidFill>
-                  <a:srgbClr val="D71920"/>
+                  <a:srgbClr val="0072C6"/>
                 </a:solidFill>
-                <a:latin typeface="Arial"/>
+                <a:latin typeface="Segoe UI"/>
               </a:rPr>
-              <a:t>Guideline Verdict:
-READY / NOT_READY</a:t>
+              <a:t>Plan-Driven Execution</a:t>
             </a:r>
           </a:p>
         </p:txBody>
       </p:sp>
       <p:sp>
         <p:nvSpPr>
-          <p:cNvPr id="20" name="TextBox 19"/>
+          <p:cNvPr id="21" name="Rectangle 20"/>
+          <p:cNvSpPr/>
+          <p:nvPr/>
+        </p:nvSpPr>
+        <p:spPr>
+          <a:xfrm>
+            <a:off x="2706624" y="2615184"/>
+            <a:ext cx="1737360" cy="10972"/>
+          </a:xfrm>
+          <a:prstGeom prst="rect">
+            <a:avLst/>
+          </a:prstGeom>
+          <a:solidFill>
+            <a:srgbClr val="0072C6"/>
+          </a:solidFill>
+          <a:ln>
+            <a:noFill/>
+          </a:ln>
+        </p:spPr>
+        <p:style>
+          <a:lnRef idx="1">
+            <a:schemeClr val="accent1"/>
+          </a:lnRef>
+          <a:fillRef idx="3">
+            <a:schemeClr val="accent1"/>
+          </a:fillRef>
+          <a:effectRef idx="2">
+            <a:schemeClr val="accent1"/>
+          </a:effectRef>
+          <a:fontRef idx="minor">
+            <a:schemeClr val="lt1"/>
+          </a:fontRef>
+        </p:style>
+        <p:txBody>
+          <a:bodyPr rtlCol="0" anchor="ctr"/>
+          <a:lstStyle/>
+          <a:p>
+            <a:pPr algn="ctr"/>
+          </a:p>
+        </p:txBody>
+      </p:sp>
+      <p:sp>
+        <p:nvSpPr>
+          <p:cNvPr id="22" name="TextBox 21"/>
           <p:cNvSpPr txBox="1"/>
           <p:nvPr/>
         </p:nvSpPr>
         <p:spPr>
           <a:xfrm>
-            <a:off x="1115568" y="4114800"/>
-            <a:ext cx="4069080" cy="685800"/>
+            <a:off x="2706624" y="2743200"/>
+            <a:ext cx="1737360" cy="658368"/>
           </a:xfrm>
           <a:prstGeom prst="rect">
             <a:avLst/>
           </a:prstGeom>
           <a:noFill/>
-          <a:ln/>
-        </p:spPr>
-        <p:txBody>
-          <a:bodyPr wrap="square">
+        </p:spPr>
+        <p:txBody>
+          <a:bodyPr wrap="square" lIns="36576" rIns="36576" tIns="18288" bIns="18288">
             <a:spAutoFit/>
           </a:bodyPr>
           <a:lstStyle/>
           <a:p>
             <a:pPr algn="l"/>
             <a:r>
-              <a:rPr sz="1150" b="0" i="0">
+              <a:rPr sz="819" b="0" i="0">
                 <a:solidFill>
-                  <a:srgbClr val="E8E8E8"/>
+                  <a:srgbClr val="B8D0EC"/>
                 </a:solidFill>
-                <a:latin typeface="Arial"/>
+                <a:latin typeface="Segoe UI"/>
               </a:rPr>
-              <a:t>Checks STQC ER guidance, hard rules such as no foreign characters, and submission completeness.</a:t>
+              <a:t>Jira stories run through interactive Q&amp;A to refine scope and ensure precise definition.</a:t>
             </a:r>
           </a:p>
         </p:txBody>
       </p:sp>
       <p:sp>
         <p:nvSpPr>
-          <p:cNvPr id="21" name="Rounded Rectangle 20"/>
-          <p:cNvSpPr/>
-          <p:nvPr/>
-        </p:nvSpPr>
-        <p:spPr>
-          <a:xfrm>
-            <a:off x="320040" y="5029200"/>
-            <a:ext cx="5029200" cy="1353312"/>
+          <p:cNvPr id="23" name="Rounded Rectangle 22"/>
+          <p:cNvSpPr/>
+          <p:nvPr/>
+        </p:nvSpPr>
+        <p:spPr>
+          <a:xfrm>
+            <a:off x="4773168" y="1993392"/>
+            <a:ext cx="2029968" cy="1664208"/>
           </a:xfrm>
           <a:prstGeom prst="roundRect">
             <a:avLst/>
           </a:prstGeom>
           <a:solidFill>
-            <a:srgbClr val="333333"/>
-          </a:solidFill>
-          <a:ln>
-            <a:noFill/>
+            <a:srgbClr val="0F2845"/>
+          </a:solidFill>
+          <a:ln>
+            <a:solidFill>
+              <a:srgbClr val="144A70"/>
+            </a:solidFill>
           </a:ln>
         </p:spPr>
         <p:style>
@@ -27050,26 +27121,25 @@
           <a:lstStyle/>
           <a:p>
             <a:pPr algn="ctr"/>
-            <a:endParaRPr/>
-          </a:p>
-        </p:txBody>
-      </p:sp>
-      <p:sp>
-        <p:nvSpPr>
-          <p:cNvPr id="22" name="Rectangle 21"/>
-          <p:cNvSpPr/>
-          <p:nvPr/>
-        </p:nvSpPr>
-        <p:spPr>
-          <a:xfrm>
-            <a:off x="320040" y="5029200"/>
-            <a:ext cx="50292" cy="1353312"/>
+          </a:p>
+        </p:txBody>
+      </p:sp>
+      <p:sp>
+        <p:nvSpPr>
+          <p:cNvPr id="24" name="Rectangle 23"/>
+          <p:cNvSpPr/>
+          <p:nvPr/>
+        </p:nvSpPr>
+        <p:spPr>
+          <a:xfrm>
+            <a:off x="4773168" y="1993392"/>
+            <a:ext cx="2029968" cy="50292"/>
           </a:xfrm>
           <a:prstGeom prst="rect">
             <a:avLst/>
           </a:prstGeom>
           <a:solidFill>
-            <a:srgbClr val="D71920"/>
+            <a:srgbClr val="00A89A"/>
           </a:solidFill>
           <a:ln>
             <a:noFill/>
@@ -27094,26 +27164,25 @@
           <a:lstStyle/>
           <a:p>
             <a:pPr algn="ctr"/>
-            <a:endParaRPr/>
-          </a:p>
-        </p:txBody>
-      </p:sp>
-      <p:sp>
-        <p:nvSpPr>
-          <p:cNvPr id="23" name="Rounded Rectangle 22"/>
-          <p:cNvSpPr/>
-          <p:nvPr/>
-        </p:nvSpPr>
-        <p:spPr>
-          <a:xfrm>
-            <a:off x="475488" y="5413248"/>
-            <a:ext cx="502920" cy="502920"/>
-          </a:xfrm>
-          <a:prstGeom prst="roundRect">
-            <a:avLst/>
-          </a:prstGeom>
-          <a:solidFill>
-            <a:srgbClr val="D71920"/>
+          </a:p>
+        </p:txBody>
+      </p:sp>
+      <p:sp>
+        <p:nvSpPr>
+          <p:cNvPr id="25" name="Oval 24"/>
+          <p:cNvSpPr/>
+          <p:nvPr/>
+        </p:nvSpPr>
+        <p:spPr>
+          <a:xfrm>
+            <a:off x="4882896" y="2176272"/>
+            <a:ext cx="384048" cy="384048"/>
+          </a:xfrm>
+          <a:prstGeom prst="ellipse">
+            <a:avLst/>
+          </a:prstGeom>
+          <a:solidFill>
+            <a:srgbClr val="00A89A"/>
           </a:solidFill>
           <a:ln>
             <a:noFill/>
@@ -27138,138 +27207,178 @@
           <a:lstStyle/>
           <a:p>
             <a:pPr algn="ctr"/>
-            <a:endParaRPr/>
-          </a:p>
-        </p:txBody>
-      </p:sp>
-      <p:sp>
-        <p:nvSpPr>
-          <p:cNvPr id="24" name="TextBox 23"/>
+          </a:p>
+        </p:txBody>
+      </p:sp>
+      <p:sp>
+        <p:nvSpPr>
+          <p:cNvPr id="26" name="TextBox 25"/>
           <p:cNvSpPr txBox="1"/>
           <p:nvPr/>
         </p:nvSpPr>
         <p:spPr>
           <a:xfrm>
-            <a:off x="475488" y="5413248"/>
-            <a:ext cx="502920" cy="502920"/>
+            <a:off x="4882896" y="2276856"/>
+            <a:ext cx="384048" cy="91440"/>
           </a:xfrm>
           <a:prstGeom prst="rect">
             <a:avLst/>
           </a:prstGeom>
           <a:noFill/>
-          <a:ln/>
-        </p:spPr>
-        <p:txBody>
-          <a:bodyPr wrap="square">
+        </p:spPr>
+        <p:txBody>
+          <a:bodyPr wrap="square" lIns="36576" rIns="36576" tIns="18288" bIns="18288">
             <a:spAutoFit/>
           </a:bodyPr>
           <a:lstStyle/>
           <a:p>
             <a:pPr algn="ctr"/>
             <a:r>
-              <a:rPr sz="1600" b="1" i="0">
+              <a:rPr sz="819" b="1" i="0">
                 <a:solidFill>
                   <a:srgbClr val="FFFFFF"/>
                 </a:solidFill>
-                <a:latin typeface="Arial"/>
+                <a:latin typeface="Segoe UI"/>
               </a:rPr>
-              <a:t>→</a:t>
+              <a:t>03</a:t>
             </a:r>
           </a:p>
         </p:txBody>
       </p:sp>
       <p:sp>
         <p:nvSpPr>
-          <p:cNvPr id="25" name="TextBox 24"/>
+          <p:cNvPr id="27" name="TextBox 26"/>
           <p:cNvSpPr txBox="1"/>
           <p:nvPr/>
         </p:nvSpPr>
         <p:spPr>
           <a:xfrm>
-            <a:off x="1115568" y="5102352"/>
-            <a:ext cx="4114800" cy="502920"/>
+            <a:off x="5340096" y="2103120"/>
+            <a:ext cx="1335024" cy="329184"/>
           </a:xfrm>
           <a:prstGeom prst="rect">
             <a:avLst/>
           </a:prstGeom>
           <a:noFill/>
-          <a:ln/>
-        </p:spPr>
-        <p:txBody>
-          <a:bodyPr wrap="square">
+        </p:spPr>
+        <p:txBody>
+          <a:bodyPr wrap="square" lIns="36576" rIns="36576" tIns="18288" bIns="18288">
             <a:spAutoFit/>
           </a:bodyPr>
           <a:lstStyle/>
           <a:p>
             <a:pPr algn="l"/>
             <a:r>
-              <a:rPr sz="1300" b="1" i="0">
+              <a:rPr sz="1000" b="1" i="0">
                 <a:solidFill>
-                  <a:srgbClr val="D71920"/>
+                  <a:srgbClr val="00A89A"/>
                 </a:solidFill>
-                <a:latin typeface="Arial"/>
+                <a:latin typeface="Segoe UI"/>
               </a:rPr>
-              <a:t>Jira Remediation
-Actions</a:t>
+              <a:t>Codebase Indexer</a:t>
             </a:r>
           </a:p>
         </p:txBody>
       </p:sp>
       <p:sp>
         <p:nvSpPr>
-          <p:cNvPr id="26" name="TextBox 25"/>
+          <p:cNvPr id="28" name="Rectangle 27"/>
+          <p:cNvSpPr/>
+          <p:nvPr/>
+        </p:nvSpPr>
+        <p:spPr>
+          <a:xfrm>
+            <a:off x="4919472" y="2615184"/>
+            <a:ext cx="1737360" cy="10972"/>
+          </a:xfrm>
+          <a:prstGeom prst="rect">
+            <a:avLst/>
+          </a:prstGeom>
+          <a:solidFill>
+            <a:srgbClr val="00A89A"/>
+          </a:solidFill>
+          <a:ln>
+            <a:noFill/>
+          </a:ln>
+        </p:spPr>
+        <p:style>
+          <a:lnRef idx="1">
+            <a:schemeClr val="accent1"/>
+          </a:lnRef>
+          <a:fillRef idx="3">
+            <a:schemeClr val="accent1"/>
+          </a:fillRef>
+          <a:effectRef idx="2">
+            <a:schemeClr val="accent1"/>
+          </a:effectRef>
+          <a:fontRef idx="minor">
+            <a:schemeClr val="lt1"/>
+          </a:fontRef>
+        </p:style>
+        <p:txBody>
+          <a:bodyPr rtlCol="0" anchor="ctr"/>
+          <a:lstStyle/>
+          <a:p>
+            <a:pPr algn="ctr"/>
+          </a:p>
+        </p:txBody>
+      </p:sp>
+      <p:sp>
+        <p:nvSpPr>
+          <p:cNvPr id="29" name="TextBox 28"/>
           <p:cNvSpPr txBox="1"/>
           <p:nvPr/>
         </p:nvSpPr>
         <p:spPr>
           <a:xfrm>
-            <a:off x="1115568" y="5623560"/>
-            <a:ext cx="4069080" cy="685800"/>
+            <a:off x="4919472" y="2743200"/>
+            <a:ext cx="1737360" cy="658368"/>
           </a:xfrm>
           <a:prstGeom prst="rect">
             <a:avLst/>
           </a:prstGeom>
           <a:noFill/>
-          <a:ln/>
-        </p:spPr>
-        <p:txBody>
-          <a:bodyPr wrap="square">
+        </p:spPr>
+        <p:txBody>
+          <a:bodyPr wrap="square" lIns="36576" rIns="36576" tIns="18288" bIns="18288">
             <a:spAutoFit/>
           </a:bodyPr>
           <a:lstStyle/>
           <a:p>
             <a:pPr algn="l"/>
             <a:r>
-              <a:rPr sz="1150" b="0" i="0">
+              <a:rPr sz="819" b="0" i="0">
                 <a:solidFill>
-                  <a:srgbClr val="E8E8E8"/>
+                  <a:srgbClr val="B8D0EC"/>
                 </a:solidFill>
-                <a:latin typeface="Arial"/>
+                <a:latin typeface="Segoe UI"/>
               </a:rPr>
-              <a:t>Every NOT_READY result highlights the failing section and creates stories or defects to fix it.</a:t>
+              <a:t>Rust backend generates knowledge, indexing and analysis across the codebase.</a:t>
             </a:r>
           </a:p>
         </p:txBody>
       </p:sp>
       <p:sp>
         <p:nvSpPr>
-          <p:cNvPr id="27" name="Rounded Rectangle 26"/>
-          <p:cNvSpPr/>
-          <p:nvPr/>
-        </p:nvSpPr>
-        <p:spPr>
-          <a:xfrm>
-            <a:off x="5623560" y="1965960"/>
-            <a:ext cx="3182112" cy="4498848"/>
+          <p:cNvPr id="30" name="Rounded Rectangle 29"/>
+          <p:cNvSpPr/>
+          <p:nvPr/>
+        </p:nvSpPr>
+        <p:spPr>
+          <a:xfrm>
+            <a:off x="6986016" y="1993392"/>
+            <a:ext cx="2029968" cy="1664208"/>
           </a:xfrm>
           <a:prstGeom prst="roundRect">
             <a:avLst/>
           </a:prstGeom>
           <a:solidFill>
-            <a:srgbClr val="2B2B2B"/>
-          </a:solidFill>
-          <a:ln>
-            <a:noFill/>
+            <a:srgbClr val="0F2845"/>
+          </a:solidFill>
+          <a:ln>
+            <a:solidFill>
+              <a:srgbClr val="144A70"/>
+            </a:solidFill>
           </a:ln>
         </p:spPr>
         <p:style>
@@ -27291,26 +27400,25 @@
           <a:lstStyle/>
           <a:p>
             <a:pPr algn="ctr"/>
-            <a:endParaRPr/>
-          </a:p>
-        </p:txBody>
-      </p:sp>
-      <p:sp>
-        <p:nvSpPr>
-          <p:cNvPr id="28" name="Rectangle 27"/>
-          <p:cNvSpPr/>
-          <p:nvPr/>
-        </p:nvSpPr>
-        <p:spPr>
-          <a:xfrm>
-            <a:off x="5623560" y="1965960"/>
-            <a:ext cx="3182112" cy="50292"/>
+          </a:p>
+        </p:txBody>
+      </p:sp>
+      <p:sp>
+        <p:nvSpPr>
+          <p:cNvPr id="31" name="Rectangle 30"/>
+          <p:cNvSpPr/>
+          <p:nvPr/>
+        </p:nvSpPr>
+        <p:spPr>
+          <a:xfrm>
+            <a:off x="6986016" y="1993392"/>
+            <a:ext cx="2029968" cy="50292"/>
           </a:xfrm>
           <a:prstGeom prst="rect">
             <a:avLst/>
           </a:prstGeom>
           <a:solidFill>
-            <a:srgbClr val="D71920"/>
+            <a:srgbClr val="8B5CF6"/>
           </a:solidFill>
           <a:ln>
             <a:noFill/>
@@ -27335,291 +27443,162 @@
           <a:lstStyle/>
           <a:p>
             <a:pPr algn="ctr"/>
-            <a:endParaRPr/>
-          </a:p>
-        </p:txBody>
-      </p:sp>
-      <p:sp>
-        <p:nvSpPr>
-          <p:cNvPr id="29" name="TextBox 28"/>
+          </a:p>
+        </p:txBody>
+      </p:sp>
+      <p:sp>
+        <p:nvSpPr>
+          <p:cNvPr id="32" name="Oval 31"/>
+          <p:cNvSpPr/>
+          <p:nvPr/>
+        </p:nvSpPr>
+        <p:spPr>
+          <a:xfrm>
+            <a:off x="7095744" y="2176272"/>
+            <a:ext cx="384048" cy="384048"/>
+          </a:xfrm>
+          <a:prstGeom prst="ellipse">
+            <a:avLst/>
+          </a:prstGeom>
+          <a:solidFill>
+            <a:srgbClr val="8B5CF6"/>
+          </a:solidFill>
+          <a:ln>
+            <a:noFill/>
+          </a:ln>
+        </p:spPr>
+        <p:style>
+          <a:lnRef idx="1">
+            <a:schemeClr val="accent1"/>
+          </a:lnRef>
+          <a:fillRef idx="3">
+            <a:schemeClr val="accent1"/>
+          </a:fillRef>
+          <a:effectRef idx="2">
+            <a:schemeClr val="accent1"/>
+          </a:effectRef>
+          <a:fontRef idx="minor">
+            <a:schemeClr val="lt1"/>
+          </a:fontRef>
+        </p:style>
+        <p:txBody>
+          <a:bodyPr rtlCol="0" anchor="ctr"/>
+          <a:lstStyle/>
+          <a:p>
+            <a:pPr algn="ctr"/>
+          </a:p>
+        </p:txBody>
+      </p:sp>
+      <p:sp>
+        <p:nvSpPr>
+          <p:cNvPr id="33" name="TextBox 32"/>
           <p:cNvSpPr txBox="1"/>
           <p:nvPr/>
         </p:nvSpPr>
         <p:spPr>
           <a:xfrm>
-            <a:off x="5623560" y="2029968"/>
-            <a:ext cx="3182112" cy="347472"/>
+            <a:off x="7095744" y="2276856"/>
+            <a:ext cx="384048" cy="91440"/>
           </a:xfrm>
           <a:prstGeom prst="rect">
             <a:avLst/>
           </a:prstGeom>
           <a:noFill/>
-          <a:ln/>
-        </p:spPr>
-        <p:txBody>
-          <a:bodyPr wrap="square">
+        </p:spPr>
+        <p:txBody>
+          <a:bodyPr wrap="square" lIns="36576" rIns="36576" tIns="18288" bIns="18288">
             <a:spAutoFit/>
           </a:bodyPr>
           <a:lstStyle/>
           <a:p>
             <a:pPr algn="ctr"/>
             <a:r>
-              <a:rPr sz="1200" b="1" i="0">
-                <a:solidFill>
-                  <a:srgbClr val="D71920"/>
-                </a:solidFill>
-                <a:latin typeface="Arial"/>
-              </a:rPr>
-              <a:t>STQC SUBMISSION GATE</a:t>
-            </a:r>
-          </a:p>
-        </p:txBody>
-      </p:sp>
-      <p:sp>
-        <p:nvSpPr>
-          <p:cNvPr id="30" name="Rectangle 29"/>
-          <p:cNvSpPr/>
-          <p:nvPr/>
-        </p:nvSpPr>
-        <p:spPr>
-          <a:xfrm>
-            <a:off x="5623560" y="2423160"/>
-            <a:ext cx="3182112" cy="14630"/>
-          </a:xfrm>
-          <a:prstGeom prst="rect">
-            <a:avLst/>
-          </a:prstGeom>
-          <a:solidFill>
-            <a:srgbClr val="D71920"/>
-          </a:solidFill>
-          <a:ln>
-            <a:noFill/>
-          </a:ln>
-        </p:spPr>
-        <p:style>
-          <a:lnRef idx="1">
-            <a:schemeClr val="accent1"/>
-          </a:lnRef>
-          <a:fillRef idx="3">
-            <a:schemeClr val="accent1"/>
-          </a:fillRef>
-          <a:effectRef idx="2">
-            <a:schemeClr val="accent1"/>
-          </a:effectRef>
-          <a:fontRef idx="minor">
-            <a:schemeClr val="lt1"/>
-          </a:fontRef>
-        </p:style>
-        <p:txBody>
-          <a:bodyPr rtlCol="0" anchor="ctr"/>
-          <a:lstStyle/>
-          <a:p>
-            <a:pPr algn="ctr"/>
-            <a:endParaRPr/>
-          </a:p>
-        </p:txBody>
-      </p:sp>
-      <p:sp>
-        <p:nvSpPr>
-          <p:cNvPr id="31" name="Rounded Rectangle 30"/>
-          <p:cNvSpPr/>
-          <p:nvPr/>
-        </p:nvSpPr>
-        <p:spPr>
-          <a:xfrm>
-            <a:off x="5824728" y="2542032"/>
-            <a:ext cx="2779776" cy="1536192"/>
-          </a:xfrm>
-          <a:prstGeom prst="roundRect">
-            <a:avLst/>
-          </a:prstGeom>
-          <a:solidFill>
-            <a:srgbClr val="2B2B2B"/>
-          </a:solidFill>
-          <a:ln>
-            <a:noFill/>
-          </a:ln>
-        </p:spPr>
-        <p:style>
-          <a:lnRef idx="1">
-            <a:schemeClr val="accent1"/>
-          </a:lnRef>
-          <a:fillRef idx="3">
-            <a:schemeClr val="accent1"/>
-          </a:fillRef>
-          <a:effectRef idx="2">
-            <a:schemeClr val="accent1"/>
-          </a:effectRef>
-          <a:fontRef idx="minor">
-            <a:schemeClr val="lt1"/>
-          </a:fontRef>
-        </p:style>
-        <p:txBody>
-          <a:bodyPr rtlCol="0" anchor="ctr"/>
-          <a:lstStyle/>
-          <a:p>
-            <a:pPr algn="ctr"/>
-            <a:endParaRPr/>
-          </a:p>
-        </p:txBody>
-      </p:sp>
-      <p:sp>
-        <p:nvSpPr>
-          <p:cNvPr id="32" name="Rectangle 31"/>
-          <p:cNvSpPr/>
-          <p:nvPr/>
-        </p:nvSpPr>
-        <p:spPr>
-          <a:xfrm>
-            <a:off x="5824728" y="2542032"/>
-            <a:ext cx="2779776" cy="45720"/>
-          </a:xfrm>
-          <a:prstGeom prst="rect">
-            <a:avLst/>
-          </a:prstGeom>
-          <a:solidFill>
-            <a:srgbClr val="2E7D32"/>
-          </a:solidFill>
-          <a:ln>
-            <a:noFill/>
-          </a:ln>
-        </p:spPr>
-        <p:style>
-          <a:lnRef idx="1">
-            <a:schemeClr val="accent1"/>
-          </a:lnRef>
-          <a:fillRef idx="3">
-            <a:schemeClr val="accent1"/>
-          </a:fillRef>
-          <a:effectRef idx="2">
-            <a:schemeClr val="accent1"/>
-          </a:effectRef>
-          <a:fontRef idx="minor">
-            <a:schemeClr val="lt1"/>
-          </a:fontRef>
-        </p:style>
-        <p:txBody>
-          <a:bodyPr rtlCol="0" anchor="ctr"/>
-          <a:lstStyle/>
-          <a:p>
-            <a:pPr algn="ctr"/>
-            <a:endParaRPr/>
-          </a:p>
-        </p:txBody>
-      </p:sp>
-      <p:sp>
-        <p:nvSpPr>
-          <p:cNvPr id="33" name="Oval 32"/>
-          <p:cNvSpPr/>
-          <p:nvPr/>
-        </p:nvSpPr>
-        <p:spPr>
-          <a:xfrm>
-            <a:off x="6629400" y="2706624"/>
-            <a:ext cx="621792" cy="621792"/>
-          </a:xfrm>
-          <a:prstGeom prst="ellipse">
-            <a:avLst/>
-          </a:prstGeom>
-          <a:solidFill>
-            <a:srgbClr val="2E7D32"/>
-          </a:solidFill>
-          <a:ln>
-            <a:noFill/>
-          </a:ln>
-        </p:spPr>
-        <p:style>
-          <a:lnRef idx="1">
-            <a:schemeClr val="accent1"/>
-          </a:lnRef>
-          <a:fillRef idx="3">
-            <a:schemeClr val="accent1"/>
-          </a:fillRef>
-          <a:effectRef idx="2">
-            <a:schemeClr val="accent1"/>
-          </a:effectRef>
-          <a:fontRef idx="minor">
-            <a:schemeClr val="lt1"/>
-          </a:fontRef>
-        </p:style>
-        <p:txBody>
-          <a:bodyPr rtlCol="0" anchor="ctr"/>
-          <a:lstStyle/>
-          <a:p>
-            <a:pPr algn="ctr"/>
-            <a:endParaRPr/>
-          </a:p>
-        </p:txBody>
-      </p:sp>
-      <p:sp>
-        <p:nvSpPr>
-          <p:cNvPr id="34" name="TextBox 33"/>
-          <p:cNvSpPr txBox="1"/>
-          <p:nvPr/>
-        </p:nvSpPr>
-        <p:spPr>
-          <a:xfrm>
-            <a:off x="6629400" y="2706624"/>
-            <a:ext cx="621792" cy="621792"/>
-          </a:xfrm>
-          <a:prstGeom prst="rect">
-            <a:avLst/>
-          </a:prstGeom>
-          <a:noFill/>
-          <a:ln/>
-        </p:spPr>
-        <p:txBody>
-          <a:bodyPr wrap="square">
-            <a:spAutoFit/>
-          </a:bodyPr>
-          <a:lstStyle/>
-          <a:p>
-            <a:pPr algn="ctr"/>
-            <a:r>
-              <a:rPr sz="2200" b="1" i="0">
+              <a:rPr sz="819" b="1" i="0">
                 <a:solidFill>
                   <a:srgbClr val="FFFFFF"/>
                 </a:solidFill>
-                <a:latin typeface="Arial"/>
+                <a:latin typeface="Segoe UI"/>
               </a:rPr>
-              <a:t>✓</a:t>
+              <a:t>04</a:t>
             </a:r>
           </a:p>
         </p:txBody>
       </p:sp>
       <p:sp>
         <p:nvSpPr>
-          <p:cNvPr id="35" name="TextBox 34"/>
+          <p:cNvPr id="34" name="TextBox 33"/>
           <p:cNvSpPr txBox="1"/>
           <p:nvPr/>
         </p:nvSpPr>
         <p:spPr>
           <a:xfrm>
-            <a:off x="7287768" y="2743200"/>
-            <a:ext cx="1316736" cy="461665"/>
+            <a:off x="7552944" y="2103120"/>
+            <a:ext cx="1335024" cy="329184"/>
           </a:xfrm>
           <a:prstGeom prst="rect">
             <a:avLst/>
           </a:prstGeom>
           <a:noFill/>
-          <a:ln/>
-        </p:spPr>
-        <p:txBody>
-          <a:bodyPr wrap="square">
+        </p:spPr>
+        <p:txBody>
+          <a:bodyPr wrap="square" lIns="36576" rIns="36576" tIns="18288" bIns="18288">
             <a:spAutoFit/>
           </a:bodyPr>
           <a:lstStyle/>
           <a:p>
             <a:pPr algn="l"/>
             <a:r>
-              <a:rPr sz="2400" b="1" i="0">
+              <a:rPr sz="1000" b="1" i="0">
                 <a:solidFill>
-                  <a:srgbClr val="2E7D32"/>
+                  <a:srgbClr val="8B5CF6"/>
                 </a:solidFill>
-                <a:latin typeface="Arial"/>
+                <a:latin typeface="Segoe UI"/>
               </a:rPr>
-              <a:t>READY</a:t>
+              <a:t>Agent Index Files</a:t>
             </a:r>
+          </a:p>
+        </p:txBody>
+      </p:sp>
+      <p:sp>
+        <p:nvSpPr>
+          <p:cNvPr id="35" name="Rectangle 34"/>
+          <p:cNvSpPr/>
+          <p:nvPr/>
+        </p:nvSpPr>
+        <p:spPr>
+          <a:xfrm>
+            <a:off x="7132320" y="2615184"/>
+            <a:ext cx="1737360" cy="10972"/>
+          </a:xfrm>
+          <a:prstGeom prst="rect">
+            <a:avLst/>
+          </a:prstGeom>
+          <a:solidFill>
+            <a:srgbClr val="8B5CF6"/>
+          </a:solidFill>
+          <a:ln>
+            <a:noFill/>
+          </a:ln>
+        </p:spPr>
+        <p:style>
+          <a:lnRef idx="1">
+            <a:schemeClr val="accent1"/>
+          </a:lnRef>
+          <a:fillRef idx="3">
+            <a:schemeClr val="accent1"/>
+          </a:fillRef>
+          <a:effectRef idx="2">
+            <a:schemeClr val="accent1"/>
+          </a:effectRef>
+          <a:fontRef idx="minor">
+            <a:schemeClr val="lt1"/>
+          </a:fontRef>
+        </p:style>
+        <p:txBody>
+          <a:bodyPr rtlCol="0" anchor="ctr"/>
+          <a:lstStyle/>
+          <a:p>
+            <a:pPr algn="ctr"/>
           </a:p>
         </p:txBody>
       </p:sp>
@@ -27631,31 +27610,29 @@
         </p:nvSpPr>
         <p:spPr>
           <a:xfrm>
-            <a:off x="5879592" y="3337453"/>
-            <a:ext cx="2651760" cy="685800"/>
+            <a:off x="7132320" y="2743200"/>
+            <a:ext cx="1737360" cy="658368"/>
           </a:xfrm>
           <a:prstGeom prst="rect">
             <a:avLst/>
           </a:prstGeom>
           <a:noFill/>
-          <a:ln/>
-        </p:spPr>
-        <p:txBody>
-          <a:bodyPr wrap="square">
+        </p:spPr>
+        <p:txBody>
+          <a:bodyPr wrap="square" lIns="36576" rIns="36576" tIns="18288" bIns="18288">
             <a:spAutoFit/>
           </a:bodyPr>
           <a:lstStyle/>
           <a:p>
             <a:pPr algn="l"/>
             <a:r>
-              <a:rPr sz="1100" b="0" i="0">
+              <a:rPr sz="819" b="0" i="0">
                 <a:solidFill>
-                  <a:srgbClr val="E8E8E8"/>
+                  <a:srgbClr val="B8D0EC"/>
                 </a:solidFill>
-                <a:latin typeface="Arial"/>
+                <a:latin typeface="Segoe UI"/>
               </a:rPr>
-              <a:t>Evidence pack ready.
-Cleared for auditor review.</a:t>
+              <a:t>Agents create index files during execution to improve codebase structural understanding.</a:t>
             </a:r>
           </a:p>
         </p:txBody>
@@ -27668,17 +27645,19 @@
         </p:nvSpPr>
         <p:spPr>
           <a:xfrm>
-            <a:off x="5824728" y="4224528"/>
-            <a:ext cx="2779776" cy="1536192"/>
+            <a:off x="347472" y="3913632"/>
+            <a:ext cx="2029968" cy="1664208"/>
           </a:xfrm>
           <a:prstGeom prst="roundRect">
             <a:avLst/>
           </a:prstGeom>
           <a:solidFill>
-            <a:srgbClr val="2B2B2B"/>
-          </a:solidFill>
-          <a:ln>
-            <a:noFill/>
+            <a:srgbClr val="0F2845"/>
+          </a:solidFill>
+          <a:ln>
+            <a:solidFill>
+              <a:srgbClr val="144A70"/>
+            </a:solidFill>
           </a:ln>
         </p:spPr>
         <p:style>
@@ -27700,7 +27679,6 @@
           <a:lstStyle/>
           <a:p>
             <a:pPr algn="ctr"/>
-            <a:endParaRPr/>
           </a:p>
         </p:txBody>
       </p:sp>
@@ -27712,14 +27690,14 @@
         </p:nvSpPr>
         <p:spPr>
           <a:xfrm>
-            <a:off x="5824728" y="4224528"/>
-            <a:ext cx="2779776" cy="45720"/>
+            <a:off x="347472" y="3913632"/>
+            <a:ext cx="2029968" cy="50292"/>
           </a:xfrm>
           <a:prstGeom prst="rect">
             <a:avLst/>
           </a:prstGeom>
           <a:solidFill>
-            <a:srgbClr val="D71920"/>
+            <a:srgbClr val="F5C518"/>
           </a:solidFill>
           <a:ln>
             <a:noFill/>
@@ -27744,7 +27722,6 @@
           <a:lstStyle/>
           <a:p>
             <a:pPr algn="ctr"/>
-            <a:endParaRPr/>
           </a:p>
         </p:txBody>
       </p:sp>
@@ -27756,14 +27733,14 @@
         </p:nvSpPr>
         <p:spPr>
           <a:xfrm>
-            <a:off x="6629400" y="4389120"/>
-            <a:ext cx="621792" cy="621792"/>
+            <a:off x="457200" y="4096512"/>
+            <a:ext cx="384048" cy="384048"/>
           </a:xfrm>
           <a:prstGeom prst="ellipse">
             <a:avLst/>
           </a:prstGeom>
           <a:solidFill>
-            <a:srgbClr val="D71920"/>
+            <a:srgbClr val="F5C518"/>
           </a:solidFill>
           <a:ln>
             <a:noFill/>
@@ -27788,7 +27765,6 @@
           <a:lstStyle/>
           <a:p>
             <a:pPr algn="ctr"/>
-            <a:endParaRPr/>
           </a:p>
         </p:txBody>
       </p:sp>
@@ -27800,30 +27776,29 @@
         </p:nvSpPr>
         <p:spPr>
           <a:xfrm>
-            <a:off x="6629400" y="4389120"/>
-            <a:ext cx="621792" cy="621792"/>
+            <a:off x="457200" y="4197096"/>
+            <a:ext cx="384048" cy="91440"/>
           </a:xfrm>
           <a:prstGeom prst="rect">
             <a:avLst/>
           </a:prstGeom>
           <a:noFill/>
-          <a:ln/>
-        </p:spPr>
-        <p:txBody>
-          <a:bodyPr wrap="square">
+        </p:spPr>
+        <p:txBody>
+          <a:bodyPr wrap="square" lIns="36576" rIns="36576" tIns="18288" bIns="18288">
             <a:spAutoFit/>
           </a:bodyPr>
           <a:lstStyle/>
           <a:p>
             <a:pPr algn="ctr"/>
             <a:r>
-              <a:rPr sz="2200" b="1" i="0">
+              <a:rPr sz="819" b="1" i="0">
                 <a:solidFill>
                   <a:srgbClr val="FFFFFF"/>
                 </a:solidFill>
-                <a:latin typeface="Arial"/>
+                <a:latin typeface="Segoe UI"/>
               </a:rPr>
-              <a:t>✕</a:t>
+              <a:t>05</a:t>
             </a:r>
           </a:p>
         </p:txBody>
@@ -27836,74 +27811,1072 @@
         </p:nvSpPr>
         <p:spPr>
           <a:xfrm>
-            <a:off x="7287768" y="4425696"/>
-            <a:ext cx="1417320" cy="384048"/>
+            <a:off x="914400" y="4023360"/>
+            <a:ext cx="1335024" cy="329184"/>
           </a:xfrm>
           <a:prstGeom prst="rect">
             <a:avLst/>
           </a:prstGeom>
           <a:noFill/>
-          <a:ln/>
-        </p:spPr>
-        <p:txBody>
-          <a:bodyPr wrap="square">
+        </p:spPr>
+        <p:txBody>
+          <a:bodyPr wrap="square" lIns="36576" rIns="36576" tIns="18288" bIns="18288">
             <a:spAutoFit/>
           </a:bodyPr>
           <a:lstStyle/>
           <a:p>
             <a:pPr algn="l"/>
             <a:r>
-              <a:rPr sz="1800" b="1" i="0">
+              <a:rPr sz="1000" b="1" i="0">
                 <a:solidFill>
-                  <a:srgbClr val="D71920"/>
+                  <a:srgbClr val="F5C518"/>
                 </a:solidFill>
-                <a:latin typeface="Arial"/>
+                <a:latin typeface="Segoe UI"/>
               </a:rPr>
-              <a:t>NOT READY</a:t>
+              <a:t>Certification Module</a:t>
             </a:r>
           </a:p>
         </p:txBody>
       </p:sp>
       <p:sp>
         <p:nvSpPr>
-          <p:cNvPr id="42" name="TextBox 41"/>
+          <p:cNvPr id="42" name="Rectangle 41"/>
+          <p:cNvSpPr/>
+          <p:nvPr/>
+        </p:nvSpPr>
+        <p:spPr>
+          <a:xfrm>
+            <a:off x="493776" y="4535424"/>
+            <a:ext cx="1737360" cy="10972"/>
+          </a:xfrm>
+          <a:prstGeom prst="rect">
+            <a:avLst/>
+          </a:prstGeom>
+          <a:solidFill>
+            <a:srgbClr val="F5C518"/>
+          </a:solidFill>
+          <a:ln>
+            <a:noFill/>
+          </a:ln>
+        </p:spPr>
+        <p:style>
+          <a:lnRef idx="1">
+            <a:schemeClr val="accent1"/>
+          </a:lnRef>
+          <a:fillRef idx="3">
+            <a:schemeClr val="accent1"/>
+          </a:fillRef>
+          <a:effectRef idx="2">
+            <a:schemeClr val="accent1"/>
+          </a:effectRef>
+          <a:fontRef idx="minor">
+            <a:schemeClr val="lt1"/>
+          </a:fontRef>
+        </p:style>
+        <p:txBody>
+          <a:bodyPr rtlCol="0" anchor="ctr"/>
+          <a:lstStyle/>
+          <a:p>
+            <a:pPr algn="ctr"/>
+          </a:p>
+        </p:txBody>
+      </p:sp>
+      <p:sp>
+        <p:nvSpPr>
+          <p:cNvPr id="43" name="TextBox 42"/>
           <p:cNvSpPr txBox="1"/>
           <p:nvPr/>
         </p:nvSpPr>
         <p:spPr>
           <a:xfrm>
-            <a:off x="5888736" y="5060357"/>
-            <a:ext cx="2651760" cy="685800"/>
+            <a:off x="493776" y="4663440"/>
+            <a:ext cx="1737360" cy="658368"/>
           </a:xfrm>
           <a:prstGeom prst="rect">
             <a:avLst/>
           </a:prstGeom>
           <a:noFill/>
-          <a:ln/>
-        </p:spPr>
-        <p:txBody>
-          <a:bodyPr wrap="square">
+        </p:spPr>
+        <p:txBody>
+          <a:bodyPr wrap="square" lIns="36576" rIns="36576" tIns="18288" bIns="18288">
             <a:spAutoFit/>
           </a:bodyPr>
           <a:lstStyle/>
           <a:p>
             <a:pPr algn="l"/>
             <a:r>
-              <a:rPr sz="1100" b="0" i="0">
+              <a:rPr sz="819" b="0" i="0">
                 <a:solidFill>
-                  <a:srgbClr val="E8E8E8"/>
+                  <a:srgbClr val="B8D0EC"/>
                 </a:solidFill>
-                <a:latin typeface="Arial"/>
+                <a:latin typeface="Segoe UI"/>
               </a:rPr>
-              <a:t>Guideline gaps found.
-Create Jira stories.</a:t>
+              <a:t>Pluggable framework extendible beyond STQC to certifications such as DO178C.</a:t>
             </a:r>
           </a:p>
         </p:txBody>
       </p:sp>
       <p:sp>
         <p:nvSpPr>
-          <p:cNvPr id="43" name="Rectangle 42"/>
+          <p:cNvPr id="44" name="Rounded Rectangle 43"/>
+          <p:cNvSpPr/>
+          <p:nvPr/>
+        </p:nvSpPr>
+        <p:spPr>
+          <a:xfrm>
+            <a:off x="2560320" y="3913632"/>
+            <a:ext cx="2029968" cy="1664208"/>
+          </a:xfrm>
+          <a:prstGeom prst="roundRect">
+            <a:avLst/>
+          </a:prstGeom>
+          <a:solidFill>
+            <a:srgbClr val="0F2845"/>
+          </a:solidFill>
+          <a:ln>
+            <a:solidFill>
+              <a:srgbClr val="144A70"/>
+            </a:solidFill>
+          </a:ln>
+        </p:spPr>
+        <p:style>
+          <a:lnRef idx="1">
+            <a:schemeClr val="accent1"/>
+          </a:lnRef>
+          <a:fillRef idx="3">
+            <a:schemeClr val="accent1"/>
+          </a:fillRef>
+          <a:effectRef idx="2">
+            <a:schemeClr val="accent1"/>
+          </a:effectRef>
+          <a:fontRef idx="minor">
+            <a:schemeClr val="lt1"/>
+          </a:fontRef>
+        </p:style>
+        <p:txBody>
+          <a:bodyPr rtlCol="0" anchor="ctr"/>
+          <a:lstStyle/>
+          <a:p>
+            <a:pPr algn="ctr"/>
+          </a:p>
+        </p:txBody>
+      </p:sp>
+      <p:sp>
+        <p:nvSpPr>
+          <p:cNvPr id="45" name="Rectangle 44"/>
+          <p:cNvSpPr/>
+          <p:nvPr/>
+        </p:nvSpPr>
+        <p:spPr>
+          <a:xfrm>
+            <a:off x="2560320" y="3913632"/>
+            <a:ext cx="2029968" cy="50292"/>
+          </a:xfrm>
+          <a:prstGeom prst="rect">
+            <a:avLst/>
+          </a:prstGeom>
+          <a:solidFill>
+            <a:srgbClr val="00D48A"/>
+          </a:solidFill>
+          <a:ln>
+            <a:noFill/>
+          </a:ln>
+        </p:spPr>
+        <p:style>
+          <a:lnRef idx="1">
+            <a:schemeClr val="accent1"/>
+          </a:lnRef>
+          <a:fillRef idx="3">
+            <a:schemeClr val="accent1"/>
+          </a:fillRef>
+          <a:effectRef idx="2">
+            <a:schemeClr val="accent1"/>
+          </a:effectRef>
+          <a:fontRef idx="minor">
+            <a:schemeClr val="lt1"/>
+          </a:fontRef>
+        </p:style>
+        <p:txBody>
+          <a:bodyPr rtlCol="0" anchor="ctr"/>
+          <a:lstStyle/>
+          <a:p>
+            <a:pPr algn="ctr"/>
+          </a:p>
+        </p:txBody>
+      </p:sp>
+      <p:sp>
+        <p:nvSpPr>
+          <p:cNvPr id="46" name="Oval 45"/>
+          <p:cNvSpPr/>
+          <p:nvPr/>
+        </p:nvSpPr>
+        <p:spPr>
+          <a:xfrm>
+            <a:off x="2670048" y="4096512"/>
+            <a:ext cx="384048" cy="384048"/>
+          </a:xfrm>
+          <a:prstGeom prst="ellipse">
+            <a:avLst/>
+          </a:prstGeom>
+          <a:solidFill>
+            <a:srgbClr val="00D48A"/>
+          </a:solidFill>
+          <a:ln>
+            <a:noFill/>
+          </a:ln>
+        </p:spPr>
+        <p:style>
+          <a:lnRef idx="1">
+            <a:schemeClr val="accent1"/>
+          </a:lnRef>
+          <a:fillRef idx="3">
+            <a:schemeClr val="accent1"/>
+          </a:fillRef>
+          <a:effectRef idx="2">
+            <a:schemeClr val="accent1"/>
+          </a:effectRef>
+          <a:fontRef idx="minor">
+            <a:schemeClr val="lt1"/>
+          </a:fontRef>
+        </p:style>
+        <p:txBody>
+          <a:bodyPr rtlCol="0" anchor="ctr"/>
+          <a:lstStyle/>
+          <a:p>
+            <a:pPr algn="ctr"/>
+          </a:p>
+        </p:txBody>
+      </p:sp>
+      <p:sp>
+        <p:nvSpPr>
+          <p:cNvPr id="47" name="TextBox 46"/>
+          <p:cNvSpPr txBox="1"/>
+          <p:nvPr/>
+        </p:nvSpPr>
+        <p:spPr>
+          <a:xfrm>
+            <a:off x="2670048" y="4197096"/>
+            <a:ext cx="384048" cy="91440"/>
+          </a:xfrm>
+          <a:prstGeom prst="rect">
+            <a:avLst/>
+          </a:prstGeom>
+          <a:noFill/>
+        </p:spPr>
+        <p:txBody>
+          <a:bodyPr wrap="square" lIns="36576" rIns="36576" tIns="18288" bIns="18288">
+            <a:spAutoFit/>
+          </a:bodyPr>
+          <a:lstStyle/>
+          <a:p>
+            <a:pPr algn="ctr"/>
+            <a:r>
+              <a:rPr sz="819" b="1" i="0">
+                <a:solidFill>
+                  <a:srgbClr val="FFFFFF"/>
+                </a:solidFill>
+                <a:latin typeface="Segoe UI"/>
+              </a:rPr>
+              <a:t>06</a:t>
+            </a:r>
+          </a:p>
+        </p:txBody>
+      </p:sp>
+      <p:sp>
+        <p:nvSpPr>
+          <p:cNvPr id="48" name="TextBox 47"/>
+          <p:cNvSpPr txBox="1"/>
+          <p:nvPr/>
+        </p:nvSpPr>
+        <p:spPr>
+          <a:xfrm>
+            <a:off x="3127248" y="4023360"/>
+            <a:ext cx="1335024" cy="329184"/>
+          </a:xfrm>
+          <a:prstGeom prst="rect">
+            <a:avLst/>
+          </a:prstGeom>
+          <a:noFill/>
+        </p:spPr>
+        <p:txBody>
+          <a:bodyPr wrap="square" lIns="36576" rIns="36576" tIns="18288" bIns="18288">
+            <a:spAutoFit/>
+          </a:bodyPr>
+          <a:lstStyle/>
+          <a:p>
+            <a:pPr algn="l"/>
+            <a:r>
+              <a:rPr sz="1000" b="1" i="0">
+                <a:solidFill>
+                  <a:srgbClr val="00D48A"/>
+                </a:solidFill>
+                <a:latin typeface="Segoe UI"/>
+              </a:rPr>
+              <a:t>STQC Evidence Docs</a:t>
+            </a:r>
+          </a:p>
+        </p:txBody>
+      </p:sp>
+      <p:sp>
+        <p:nvSpPr>
+          <p:cNvPr id="49" name="Rectangle 48"/>
+          <p:cNvSpPr/>
+          <p:nvPr/>
+        </p:nvSpPr>
+        <p:spPr>
+          <a:xfrm>
+            <a:off x="2706624" y="4535424"/>
+            <a:ext cx="1737360" cy="10972"/>
+          </a:xfrm>
+          <a:prstGeom prst="rect">
+            <a:avLst/>
+          </a:prstGeom>
+          <a:solidFill>
+            <a:srgbClr val="00D48A"/>
+          </a:solidFill>
+          <a:ln>
+            <a:noFill/>
+          </a:ln>
+        </p:spPr>
+        <p:style>
+          <a:lnRef idx="1">
+            <a:schemeClr val="accent1"/>
+          </a:lnRef>
+          <a:fillRef idx="3">
+            <a:schemeClr val="accent1"/>
+          </a:fillRef>
+          <a:effectRef idx="2">
+            <a:schemeClr val="accent1"/>
+          </a:effectRef>
+          <a:fontRef idx="minor">
+            <a:schemeClr val="lt1"/>
+          </a:fontRef>
+        </p:style>
+        <p:txBody>
+          <a:bodyPr rtlCol="0" anchor="ctr"/>
+          <a:lstStyle/>
+          <a:p>
+            <a:pPr algn="ctr"/>
+          </a:p>
+        </p:txBody>
+      </p:sp>
+      <p:sp>
+        <p:nvSpPr>
+          <p:cNvPr id="50" name="TextBox 49"/>
+          <p:cNvSpPr txBox="1"/>
+          <p:nvPr/>
+        </p:nvSpPr>
+        <p:spPr>
+          <a:xfrm>
+            <a:off x="2706624" y="4663440"/>
+            <a:ext cx="1737360" cy="658368"/>
+          </a:xfrm>
+          <a:prstGeom prst="rect">
+            <a:avLst/>
+          </a:prstGeom>
+          <a:noFill/>
+        </p:spPr>
+        <p:txBody>
+          <a:bodyPr wrap="square" lIns="36576" rIns="36576" tIns="18288" bIns="18288">
+            <a:spAutoFit/>
+          </a:bodyPr>
+          <a:lstStyle/>
+          <a:p>
+            <a:pPr algn="l"/>
+            <a:r>
+              <a:rPr sz="819" b="0" i="0">
+                <a:solidFill>
+                  <a:srgbClr val="B8D0EC"/>
+                </a:solidFill>
+                <a:latin typeface="Segoe UI"/>
+              </a:rPr>
+              <a:t>Reads the codebase and produces evidence in ready-to-use document format.</a:t>
+            </a:r>
+          </a:p>
+        </p:txBody>
+      </p:sp>
+      <p:sp>
+        <p:nvSpPr>
+          <p:cNvPr id="51" name="Rounded Rectangle 50"/>
+          <p:cNvSpPr/>
+          <p:nvPr/>
+        </p:nvSpPr>
+        <p:spPr>
+          <a:xfrm>
+            <a:off x="4773168" y="3913632"/>
+            <a:ext cx="2029968" cy="1664208"/>
+          </a:xfrm>
+          <a:prstGeom prst="roundRect">
+            <a:avLst/>
+          </a:prstGeom>
+          <a:solidFill>
+            <a:srgbClr val="0F2845"/>
+          </a:solidFill>
+          <a:ln>
+            <a:solidFill>
+              <a:srgbClr val="144A70"/>
+            </a:solidFill>
+          </a:ln>
+        </p:spPr>
+        <p:style>
+          <a:lnRef idx="1">
+            <a:schemeClr val="accent1"/>
+          </a:lnRef>
+          <a:fillRef idx="3">
+            <a:schemeClr val="accent1"/>
+          </a:fillRef>
+          <a:effectRef idx="2">
+            <a:schemeClr val="accent1"/>
+          </a:effectRef>
+          <a:fontRef idx="minor">
+            <a:schemeClr val="lt1"/>
+          </a:fontRef>
+        </p:style>
+        <p:txBody>
+          <a:bodyPr rtlCol="0" anchor="ctr"/>
+          <a:lstStyle/>
+          <a:p>
+            <a:pPr algn="ctr"/>
+          </a:p>
+        </p:txBody>
+      </p:sp>
+      <p:sp>
+        <p:nvSpPr>
+          <p:cNvPr id="52" name="Rectangle 51"/>
+          <p:cNvSpPr/>
+          <p:nvPr/>
+        </p:nvSpPr>
+        <p:spPr>
+          <a:xfrm>
+            <a:off x="4773168" y="3913632"/>
+            <a:ext cx="2029968" cy="50292"/>
+          </a:xfrm>
+          <a:prstGeom prst="rect">
+            <a:avLst/>
+          </a:prstGeom>
+          <a:solidFill>
+            <a:srgbClr val="FF8C00"/>
+          </a:solidFill>
+          <a:ln>
+            <a:noFill/>
+          </a:ln>
+        </p:spPr>
+        <p:style>
+          <a:lnRef idx="1">
+            <a:schemeClr val="accent1"/>
+          </a:lnRef>
+          <a:fillRef idx="3">
+            <a:schemeClr val="accent1"/>
+          </a:fillRef>
+          <a:effectRef idx="2">
+            <a:schemeClr val="accent1"/>
+          </a:effectRef>
+          <a:fontRef idx="minor">
+            <a:schemeClr val="lt1"/>
+          </a:fontRef>
+        </p:style>
+        <p:txBody>
+          <a:bodyPr rtlCol="0" anchor="ctr"/>
+          <a:lstStyle/>
+          <a:p>
+            <a:pPr algn="ctr"/>
+          </a:p>
+        </p:txBody>
+      </p:sp>
+      <p:sp>
+        <p:nvSpPr>
+          <p:cNvPr id="53" name="Oval 52"/>
+          <p:cNvSpPr/>
+          <p:nvPr/>
+        </p:nvSpPr>
+        <p:spPr>
+          <a:xfrm>
+            <a:off x="4882896" y="4096512"/>
+            <a:ext cx="384048" cy="384048"/>
+          </a:xfrm>
+          <a:prstGeom prst="ellipse">
+            <a:avLst/>
+          </a:prstGeom>
+          <a:solidFill>
+            <a:srgbClr val="FF8C00"/>
+          </a:solidFill>
+          <a:ln>
+            <a:noFill/>
+          </a:ln>
+        </p:spPr>
+        <p:style>
+          <a:lnRef idx="1">
+            <a:schemeClr val="accent1"/>
+          </a:lnRef>
+          <a:fillRef idx="3">
+            <a:schemeClr val="accent1"/>
+          </a:fillRef>
+          <a:effectRef idx="2">
+            <a:schemeClr val="accent1"/>
+          </a:effectRef>
+          <a:fontRef idx="minor">
+            <a:schemeClr val="lt1"/>
+          </a:fontRef>
+        </p:style>
+        <p:txBody>
+          <a:bodyPr rtlCol="0" anchor="ctr"/>
+          <a:lstStyle/>
+          <a:p>
+            <a:pPr algn="ctr"/>
+          </a:p>
+        </p:txBody>
+      </p:sp>
+      <p:sp>
+        <p:nvSpPr>
+          <p:cNvPr id="54" name="TextBox 53"/>
+          <p:cNvSpPr txBox="1"/>
+          <p:nvPr/>
+        </p:nvSpPr>
+        <p:spPr>
+          <a:xfrm>
+            <a:off x="4882896" y="4197096"/>
+            <a:ext cx="384048" cy="91440"/>
+          </a:xfrm>
+          <a:prstGeom prst="rect">
+            <a:avLst/>
+          </a:prstGeom>
+          <a:noFill/>
+        </p:spPr>
+        <p:txBody>
+          <a:bodyPr wrap="square" lIns="36576" rIns="36576" tIns="18288" bIns="18288">
+            <a:spAutoFit/>
+          </a:bodyPr>
+          <a:lstStyle/>
+          <a:p>
+            <a:pPr algn="ctr"/>
+            <a:r>
+              <a:rPr sz="819" b="1" i="0">
+                <a:solidFill>
+                  <a:srgbClr val="FFFFFF"/>
+                </a:solidFill>
+                <a:latin typeface="Segoe UI"/>
+              </a:rPr>
+              <a:t>07</a:t>
+            </a:r>
+          </a:p>
+        </p:txBody>
+      </p:sp>
+      <p:sp>
+        <p:nvSpPr>
+          <p:cNvPr id="55" name="TextBox 54"/>
+          <p:cNvSpPr txBox="1"/>
+          <p:nvPr/>
+        </p:nvSpPr>
+        <p:spPr>
+          <a:xfrm>
+            <a:off x="5340096" y="4023360"/>
+            <a:ext cx="1335024" cy="329184"/>
+          </a:xfrm>
+          <a:prstGeom prst="rect">
+            <a:avLst/>
+          </a:prstGeom>
+          <a:noFill/>
+        </p:spPr>
+        <p:txBody>
+          <a:bodyPr wrap="square" lIns="36576" rIns="36576" tIns="18288" bIns="18288">
+            <a:spAutoFit/>
+          </a:bodyPr>
+          <a:lstStyle/>
+          <a:p>
+            <a:pPr algn="l"/>
+            <a:r>
+              <a:rPr sz="1000" b="1" i="0">
+                <a:solidFill>
+                  <a:srgbClr val="FF8C00"/>
+                </a:solidFill>
+                <a:latin typeface="Segoe UI"/>
+              </a:rPr>
+              <a:t>TCF + Compliance</a:t>
+            </a:r>
+          </a:p>
+        </p:txBody>
+      </p:sp>
+      <p:sp>
+        <p:nvSpPr>
+          <p:cNvPr id="56" name="Rectangle 55"/>
+          <p:cNvSpPr/>
+          <p:nvPr/>
+        </p:nvSpPr>
+        <p:spPr>
+          <a:xfrm>
+            <a:off x="4919472" y="4535424"/>
+            <a:ext cx="1737360" cy="10972"/>
+          </a:xfrm>
+          <a:prstGeom prst="rect">
+            <a:avLst/>
+          </a:prstGeom>
+          <a:solidFill>
+            <a:srgbClr val="FF8C00"/>
+          </a:solidFill>
+          <a:ln>
+            <a:noFill/>
+          </a:ln>
+        </p:spPr>
+        <p:style>
+          <a:lnRef idx="1">
+            <a:schemeClr val="accent1"/>
+          </a:lnRef>
+          <a:fillRef idx="3">
+            <a:schemeClr val="accent1"/>
+          </a:fillRef>
+          <a:effectRef idx="2">
+            <a:schemeClr val="accent1"/>
+          </a:effectRef>
+          <a:fontRef idx="minor">
+            <a:schemeClr val="lt1"/>
+          </a:fontRef>
+        </p:style>
+        <p:txBody>
+          <a:bodyPr rtlCol="0" anchor="ctr"/>
+          <a:lstStyle/>
+          <a:p>
+            <a:pPr algn="ctr"/>
+          </a:p>
+        </p:txBody>
+      </p:sp>
+      <p:sp>
+        <p:nvSpPr>
+          <p:cNvPr id="57" name="TextBox 56"/>
+          <p:cNvSpPr txBox="1"/>
+          <p:nvPr/>
+        </p:nvSpPr>
+        <p:spPr>
+          <a:xfrm>
+            <a:off x="4919472" y="4663440"/>
+            <a:ext cx="1737360" cy="658368"/>
+          </a:xfrm>
+          <a:prstGeom prst="rect">
+            <a:avLst/>
+          </a:prstGeom>
+          <a:noFill/>
+        </p:spPr>
+        <p:txBody>
+          <a:bodyPr wrap="square" lIns="36576" rIns="36576" tIns="18288" bIns="18288">
+            <a:spAutoFit/>
+          </a:bodyPr>
+          <a:lstStyle/>
+          <a:p>
+            <a:pPr algn="l"/>
+            <a:r>
+              <a:rPr sz="819" b="0" i="0">
+                <a:solidFill>
+                  <a:srgbClr val="B8D0EC"/>
+                </a:solidFill>
+                <a:latin typeface="Segoe UI"/>
+              </a:rPr>
+              <a:t>Generates TCF and validates collected evidence against compliance expectations.</a:t>
+            </a:r>
+          </a:p>
+        </p:txBody>
+      </p:sp>
+      <p:sp>
+        <p:nvSpPr>
+          <p:cNvPr id="58" name="Rounded Rectangle 57"/>
+          <p:cNvSpPr/>
+          <p:nvPr/>
+        </p:nvSpPr>
+        <p:spPr>
+          <a:xfrm>
+            <a:off x="6986016" y="3913632"/>
+            <a:ext cx="2029968" cy="1664208"/>
+          </a:xfrm>
+          <a:prstGeom prst="roundRect">
+            <a:avLst/>
+          </a:prstGeom>
+          <a:solidFill>
+            <a:srgbClr val="0F2845"/>
+          </a:solidFill>
+          <a:ln>
+            <a:solidFill>
+              <a:srgbClr val="144A70"/>
+            </a:solidFill>
+          </a:ln>
+        </p:spPr>
+        <p:style>
+          <a:lnRef idx="1">
+            <a:schemeClr val="accent1"/>
+          </a:lnRef>
+          <a:fillRef idx="3">
+            <a:schemeClr val="accent1"/>
+          </a:fillRef>
+          <a:effectRef idx="2">
+            <a:schemeClr val="accent1"/>
+          </a:effectRef>
+          <a:fontRef idx="minor">
+            <a:schemeClr val="lt1"/>
+          </a:fontRef>
+        </p:style>
+        <p:txBody>
+          <a:bodyPr rtlCol="0" anchor="ctr"/>
+          <a:lstStyle/>
+          <a:p>
+            <a:pPr algn="ctr"/>
+          </a:p>
+        </p:txBody>
+      </p:sp>
+      <p:sp>
+        <p:nvSpPr>
+          <p:cNvPr id="59" name="Rectangle 58"/>
+          <p:cNvSpPr/>
+          <p:nvPr/>
+        </p:nvSpPr>
+        <p:spPr>
+          <a:xfrm>
+            <a:off x="6986016" y="3913632"/>
+            <a:ext cx="2029968" cy="50292"/>
+          </a:xfrm>
+          <a:prstGeom prst="rect">
+            <a:avLst/>
+          </a:prstGeom>
+          <a:solidFill>
+            <a:srgbClr val="FF3A3A"/>
+          </a:solidFill>
+          <a:ln>
+            <a:noFill/>
+          </a:ln>
+        </p:spPr>
+        <p:style>
+          <a:lnRef idx="1">
+            <a:schemeClr val="accent1"/>
+          </a:lnRef>
+          <a:fillRef idx="3">
+            <a:schemeClr val="accent1"/>
+          </a:fillRef>
+          <a:effectRef idx="2">
+            <a:schemeClr val="accent1"/>
+          </a:effectRef>
+          <a:fontRef idx="minor">
+            <a:schemeClr val="lt1"/>
+          </a:fontRef>
+        </p:style>
+        <p:txBody>
+          <a:bodyPr rtlCol="0" anchor="ctr"/>
+          <a:lstStyle/>
+          <a:p>
+            <a:pPr algn="ctr"/>
+          </a:p>
+        </p:txBody>
+      </p:sp>
+      <p:sp>
+        <p:nvSpPr>
+          <p:cNvPr id="60" name="Oval 59"/>
+          <p:cNvSpPr/>
+          <p:nvPr/>
+        </p:nvSpPr>
+        <p:spPr>
+          <a:xfrm>
+            <a:off x="7095744" y="4096512"/>
+            <a:ext cx="384048" cy="384048"/>
+          </a:xfrm>
+          <a:prstGeom prst="ellipse">
+            <a:avLst/>
+          </a:prstGeom>
+          <a:solidFill>
+            <a:srgbClr val="FF3A3A"/>
+          </a:solidFill>
+          <a:ln>
+            <a:noFill/>
+          </a:ln>
+        </p:spPr>
+        <p:style>
+          <a:lnRef idx="1">
+            <a:schemeClr val="accent1"/>
+          </a:lnRef>
+          <a:fillRef idx="3">
+            <a:schemeClr val="accent1"/>
+          </a:fillRef>
+          <a:effectRef idx="2">
+            <a:schemeClr val="accent1"/>
+          </a:effectRef>
+          <a:fontRef idx="minor">
+            <a:schemeClr val="lt1"/>
+          </a:fontRef>
+        </p:style>
+        <p:txBody>
+          <a:bodyPr rtlCol="0" anchor="ctr"/>
+          <a:lstStyle/>
+          <a:p>
+            <a:pPr algn="ctr"/>
+          </a:p>
+        </p:txBody>
+      </p:sp>
+      <p:sp>
+        <p:nvSpPr>
+          <p:cNvPr id="61" name="TextBox 60"/>
+          <p:cNvSpPr txBox="1"/>
+          <p:nvPr/>
+        </p:nvSpPr>
+        <p:spPr>
+          <a:xfrm>
+            <a:off x="7095744" y="4197096"/>
+            <a:ext cx="384048" cy="91440"/>
+          </a:xfrm>
+          <a:prstGeom prst="rect">
+            <a:avLst/>
+          </a:prstGeom>
+          <a:noFill/>
+        </p:spPr>
+        <p:txBody>
+          <a:bodyPr wrap="square" lIns="36576" rIns="36576" tIns="18288" bIns="18288">
+            <a:spAutoFit/>
+          </a:bodyPr>
+          <a:lstStyle/>
+          <a:p>
+            <a:pPr algn="ctr"/>
+            <a:r>
+              <a:rPr sz="819" b="1" i="0">
+                <a:solidFill>
+                  <a:srgbClr val="FFFFFF"/>
+                </a:solidFill>
+                <a:latin typeface="Segoe UI"/>
+              </a:rPr>
+              <a:t>08</a:t>
+            </a:r>
+          </a:p>
+        </p:txBody>
+      </p:sp>
+      <p:sp>
+        <p:nvSpPr>
+          <p:cNvPr id="62" name="TextBox 61"/>
+          <p:cNvSpPr txBox="1"/>
+          <p:nvPr/>
+        </p:nvSpPr>
+        <p:spPr>
+          <a:xfrm>
+            <a:off x="7552944" y="4023360"/>
+            <a:ext cx="1335024" cy="329184"/>
+          </a:xfrm>
+          <a:prstGeom prst="rect">
+            <a:avLst/>
+          </a:prstGeom>
+          <a:noFill/>
+        </p:spPr>
+        <p:txBody>
+          <a:bodyPr wrap="square" lIns="36576" rIns="36576" tIns="18288" bIns="18288">
+            <a:spAutoFit/>
+          </a:bodyPr>
+          <a:lstStyle/>
+          <a:p>
+            <a:pPr algn="l"/>
+            <a:r>
+              <a:rPr sz="1000" b="1" i="0">
+                <a:solidFill>
+                  <a:srgbClr val="FF3A3A"/>
+                </a:solidFill>
+                <a:latin typeface="Segoe UI"/>
+              </a:rPr>
+              <a:t>First-Time Setup</a:t>
+            </a:r>
+          </a:p>
+        </p:txBody>
+      </p:sp>
+      <p:sp>
+        <p:nvSpPr>
+          <p:cNvPr id="63" name="Rectangle 62"/>
+          <p:cNvSpPr/>
+          <p:nvPr/>
+        </p:nvSpPr>
+        <p:spPr>
+          <a:xfrm>
+            <a:off x="7132320" y="4535424"/>
+            <a:ext cx="1737360" cy="10972"/>
+          </a:xfrm>
+          <a:prstGeom prst="rect">
+            <a:avLst/>
+          </a:prstGeom>
+          <a:solidFill>
+            <a:srgbClr val="FF3A3A"/>
+          </a:solidFill>
+          <a:ln>
+            <a:noFill/>
+          </a:ln>
+        </p:spPr>
+        <p:style>
+          <a:lnRef idx="1">
+            <a:schemeClr val="accent1"/>
+          </a:lnRef>
+          <a:fillRef idx="3">
+            <a:schemeClr val="accent1"/>
+          </a:fillRef>
+          <a:effectRef idx="2">
+            <a:schemeClr val="accent1"/>
+          </a:effectRef>
+          <a:fontRef idx="minor">
+            <a:schemeClr val="lt1"/>
+          </a:fontRef>
+        </p:style>
+        <p:txBody>
+          <a:bodyPr rtlCol="0" anchor="ctr"/>
+          <a:lstStyle/>
+          <a:p>
+            <a:pPr algn="ctr"/>
+          </a:p>
+        </p:txBody>
+      </p:sp>
+      <p:sp>
+        <p:nvSpPr>
+          <p:cNvPr id="64" name="TextBox 63"/>
+          <p:cNvSpPr txBox="1"/>
+          <p:nvPr/>
+        </p:nvSpPr>
+        <p:spPr>
+          <a:xfrm>
+            <a:off x="7132320" y="4663440"/>
+            <a:ext cx="1737360" cy="658368"/>
+          </a:xfrm>
+          <a:prstGeom prst="rect">
+            <a:avLst/>
+          </a:prstGeom>
+          <a:noFill/>
+        </p:spPr>
+        <p:txBody>
+          <a:bodyPr wrap="square" lIns="36576" rIns="36576" tIns="18288" bIns="18288">
+            <a:spAutoFit/>
+          </a:bodyPr>
+          <a:lstStyle/>
+          <a:p>
+            <a:pPr algn="l"/>
+            <a:r>
+              <a:rPr sz="819" b="0" i="0">
+                <a:solidFill>
+                  <a:srgbClr val="B8D0EC"/>
+                </a:solidFill>
+                <a:latin typeface="Segoe UI"/>
+              </a:rPr>
+              <a:t>Optionally use GitHub CLI during setup when available instead of PAT tokens.</a:t>
+            </a:r>
+          </a:p>
+        </p:txBody>
+      </p:sp>
+      <p:sp>
+        <p:nvSpPr>
+          <p:cNvPr id="65" name="Rounded Rectangle 64"/>
+          <p:cNvSpPr/>
+          <p:nvPr/>
+        </p:nvSpPr>
+        <p:spPr>
+          <a:xfrm>
+            <a:off x="347472" y="5925312"/>
+            <a:ext cx="8449056" cy="438912"/>
+          </a:xfrm>
+          <a:prstGeom prst="roundRect">
+            <a:avLst/>
+          </a:prstGeom>
+          <a:solidFill>
+            <a:srgbClr val="0B1F3A"/>
+          </a:solidFill>
+          <a:ln>
+            <a:noFill/>
+          </a:ln>
+        </p:spPr>
+        <p:style>
+          <a:lnRef idx="1">
+            <a:schemeClr val="accent1"/>
+          </a:lnRef>
+          <a:fillRef idx="3">
+            <a:schemeClr val="accent1"/>
+          </a:fillRef>
+          <a:effectRef idx="2">
+            <a:schemeClr val="accent1"/>
+          </a:effectRef>
+          <a:fontRef idx="minor">
+            <a:schemeClr val="lt1"/>
+          </a:fontRef>
+        </p:style>
+        <p:txBody>
+          <a:bodyPr rtlCol="0" anchor="ctr"/>
+          <a:lstStyle/>
+          <a:p>
+            <a:pPr algn="ctr"/>
+          </a:p>
+        </p:txBody>
+      </p:sp>
+      <p:sp>
+        <p:nvSpPr>
+          <p:cNvPr id="66" name="Rectangle 65"/>
+          <p:cNvSpPr/>
+          <p:nvPr/>
+        </p:nvSpPr>
+        <p:spPr>
+          <a:xfrm>
+            <a:off x="347472" y="5925312"/>
+            <a:ext cx="50292" cy="438912"/>
+          </a:xfrm>
+          <a:prstGeom prst="rect">
+            <a:avLst/>
+          </a:prstGeom>
+          <a:solidFill>
+            <a:srgbClr val="F5C518"/>
+          </a:solidFill>
+          <a:ln>
+            <a:noFill/>
+          </a:ln>
+        </p:spPr>
+        <p:style>
+          <a:lnRef idx="1">
+            <a:schemeClr val="accent1"/>
+          </a:lnRef>
+          <a:fillRef idx="3">
+            <a:schemeClr val="accent1"/>
+          </a:fillRef>
+          <a:effectRef idx="2">
+            <a:schemeClr val="accent1"/>
+          </a:effectRef>
+          <a:fontRef idx="minor">
+            <a:schemeClr val="lt1"/>
+          </a:fontRef>
+        </p:style>
+        <p:txBody>
+          <a:bodyPr rtlCol="0" anchor="ctr"/>
+          <a:lstStyle/>
+          <a:p>
+            <a:pPr algn="ctr"/>
+          </a:p>
+        </p:txBody>
+      </p:sp>
+      <p:sp>
+        <p:nvSpPr>
+          <p:cNvPr id="67" name="TextBox 66"/>
+          <p:cNvSpPr txBox="1"/>
+          <p:nvPr/>
+        </p:nvSpPr>
+        <p:spPr>
+          <a:xfrm>
+            <a:off x="530352" y="6053328"/>
+            <a:ext cx="8046720" cy="128016"/>
+          </a:xfrm>
+          <a:prstGeom prst="rect">
+            <a:avLst/>
+          </a:prstGeom>
+          <a:noFill/>
+        </p:spPr>
+        <p:txBody>
+          <a:bodyPr wrap="square" lIns="36576" rIns="36576" tIns="18288" bIns="18288">
+            <a:spAutoFit/>
+          </a:bodyPr>
+          <a:lstStyle/>
+          <a:p>
+            <a:pPr algn="ctr"/>
+            <a:r>
+              <a:rPr sz="919" b="1" i="0">
+                <a:solidFill>
+                  <a:srgbClr val="F5C518"/>
+                </a:solidFill>
+                <a:latin typeface="Segoe UI"/>
+              </a:rPr>
+              <a:t>STQC integration: codebase -&gt; evidence documents -&gt; TCF -&gt; compliance validation -&gt; READY / NOT_READY remediation.</a:t>
+            </a:r>
+          </a:p>
+        </p:txBody>
+      </p:sp>
+      <p:sp>
+        <p:nvSpPr>
+          <p:cNvPr id="68" name="Rectangle 67"/>
           <p:cNvSpPr/>
           <p:nvPr/>
         </p:nvSpPr>
@@ -27916,7 +28889,7 @@
             <a:avLst/>
           </a:prstGeom>
           <a:solidFill>
-            <a:srgbClr val="333333"/>
+            <a:srgbClr val="0E2A4A"/>
           </a:solidFill>
           <a:ln>
             <a:noFill/>
@@ -27941,119 +28914,73 @@
           <a:lstStyle/>
           <a:p>
             <a:pPr algn="ctr"/>
-            <a:endParaRPr/>
-          </a:p>
-        </p:txBody>
-      </p:sp>
-      <p:sp>
-        <p:nvSpPr>
-          <p:cNvPr id="44" name="TextBox 43"/>
+          </a:p>
+        </p:txBody>
+      </p:sp>
+      <p:sp>
+        <p:nvSpPr>
+          <p:cNvPr id="69" name="TextBox 68"/>
           <p:cNvSpPr txBox="1"/>
           <p:nvPr/>
         </p:nvSpPr>
         <p:spPr>
           <a:xfrm>
-            <a:off x="8321040" y="6510528"/>
-            <a:ext cx="731520" cy="274320"/>
+            <a:off x="8275320" y="6565392"/>
+            <a:ext cx="411480" cy="146304"/>
           </a:xfrm>
           <a:prstGeom prst="rect">
             <a:avLst/>
           </a:prstGeom>
           <a:noFill/>
-          <a:ln/>
-        </p:spPr>
-        <p:txBody>
-          <a:bodyPr wrap="square">
+        </p:spPr>
+        <p:txBody>
+          <a:bodyPr wrap="square" lIns="36576" rIns="36576" tIns="18288" bIns="18288">
             <a:spAutoFit/>
           </a:bodyPr>
           <a:lstStyle/>
           <a:p>
             <a:pPr algn="r"/>
             <a:r>
-              <a:rPr sz="900" b="0" i="0">
+              <a:rPr sz="850" b="0" i="0">
                 <a:solidFill>
-                  <a:srgbClr val="B8B8B8"/>
+                  <a:srgbClr val="6080A8"/>
                 </a:solidFill>
-                <a:latin typeface="Arial"/>
+                <a:latin typeface="Segoe UI"/>
               </a:rPr>
-              <a:t>8  /  9</a:t>
+              <a:t>4  /  5</a:t>
             </a:r>
           </a:p>
         </p:txBody>
       </p:sp>
       <p:sp>
         <p:nvSpPr>
-          <p:cNvPr id="45" name="Rectangle 44"/>
-          <p:cNvSpPr/>
-          <p:nvPr/>
-        </p:nvSpPr>
-        <p:spPr>
-          <a:xfrm>
-            <a:off x="0" y="0"/>
-            <a:ext cx="9144000" cy="32004"/>
+          <p:cNvPr id="70" name="TextBox 69"/>
+          <p:cNvSpPr txBox="1"/>
+          <p:nvPr/>
+        </p:nvSpPr>
+        <p:spPr>
+          <a:xfrm>
+            <a:off x="7406640" y="6565392"/>
+            <a:ext cx="777240" cy="146304"/>
           </a:xfrm>
           <a:prstGeom prst="rect">
             <a:avLst/>
           </a:prstGeom>
-          <a:solidFill>
-            <a:srgbClr val="D71920"/>
-          </a:solidFill>
-          <a:ln>
-            <a:noFill/>
-          </a:ln>
-        </p:spPr>
-        <p:style>
-          <a:lnRef idx="1">
-            <a:schemeClr val="accent1"/>
-          </a:lnRef>
-          <a:fillRef idx="3">
-            <a:schemeClr val="accent1"/>
-          </a:fillRef>
-          <a:effectRef idx="2">
-            <a:schemeClr val="accent1"/>
-          </a:effectRef>
-          <a:fontRef idx="minor">
-            <a:schemeClr val="lt1"/>
-          </a:fontRef>
-        </p:style>
-        <p:txBody>
-          <a:bodyPr rtlCol="0" anchor="ctr"/>
-          <a:lstStyle/>
-          <a:p>
-            <a:pPr algn="ctr"/>
-            <a:endParaRPr/>
-          </a:p>
-        </p:txBody>
-      </p:sp>
-      <p:sp>
-        <p:nvSpPr>
-          <p:cNvPr id="46" name="TextBox 45"/>
-          <p:cNvSpPr txBox="1"/>
-          <p:nvPr/>
-        </p:nvSpPr>
-        <p:spPr>
-          <a:xfrm>
-            <a:off x="7699248" y="118872"/>
-            <a:ext cx="1170432" cy="201168"/>
-          </a:xfrm>
-          <a:prstGeom prst="rect">
-            <a:avLst/>
-          </a:prstGeom>
           <a:noFill/>
         </p:spPr>
         <p:txBody>
-          <a:bodyPr wrap="none">
+          <a:bodyPr wrap="square" lIns="36576" rIns="36576" tIns="18288" bIns="18288">
             <a:spAutoFit/>
           </a:bodyPr>
           <a:lstStyle/>
           <a:p>
             <a:pPr algn="r"/>
             <a:r>
-              <a:rPr sz="1000" b="1">
+              <a:rPr sz="850" b="1" i="0">
                 <a:solidFill>
-                  <a:srgbClr val="D71920"/>
+                  <a:srgbClr val="6080A8"/>
                 </a:solidFill>
-                <a:latin typeface="Arial"/>
+                <a:latin typeface="Segoe UI"/>
               </a:rPr>
               <a:t>HONEYWELL</a:t>
             </a:r>

</xml_diff>

<commit_message>
Revert "Update V11 STQC agent capabilities slide"
This reverts commit 94e761cf711fe7430df9181d0fa3dbc1c77c6066.
</commit_message>
<xml_diff>
--- a/AI-Driven Embedded Product Lifecycle OrchestratorV11.pptx
+++ b/AI-Driven Embedded Product Lifecycle OrchestratorV11.pptx
@@ -26259,7 +26259,7 @@
             <a:avLst/>
           </a:prstGeom>
           <a:solidFill>
-            <a:srgbClr val="020A1A"/>
+            <a:srgbClr val="111111"/>
           </a:solidFill>
           <a:ln>
             <a:noFill/>
@@ -26284,6 +26284,7 @@
           <a:lstStyle/>
           <a:p>
             <a:pPr algn="ctr"/>
+            <a:endParaRPr/>
           </a:p>
         </p:txBody>
       </p:sp>
@@ -26302,7 +26303,7 @@
             <a:avLst/>
           </a:prstGeom>
           <a:solidFill>
-            <a:srgbClr val="F5C518"/>
+            <a:srgbClr val="D71920"/>
           </a:solidFill>
           <a:ln>
             <a:noFill/>
@@ -26327,6 +26328,7 @@
           <a:lstStyle/>
           <a:p>
             <a:pPr algn="ctr"/>
+            <a:endParaRPr/>
           </a:p>
         </p:txBody>
       </p:sp>
@@ -26339,13 +26341,13 @@
         <p:spPr>
           <a:xfrm>
             <a:off x="347472" y="438912"/>
-            <a:ext cx="2057400" cy="274320"/>
+            <a:ext cx="2011680" cy="274320"/>
           </a:xfrm>
           <a:prstGeom prst="roundRect">
             <a:avLst/>
           </a:prstGeom>
           <a:solidFill>
-            <a:srgbClr val="F5C518"/>
+            <a:srgbClr val="D71920"/>
           </a:solidFill>
           <a:ln>
             <a:noFill/>
@@ -26370,6 +26372,7 @@
           <a:lstStyle/>
           <a:p>
             <a:pPr algn="ctr"/>
+            <a:endParaRPr/>
           </a:p>
         </p:txBody>
       </p:sp>
@@ -26381,27 +26384,28 @@
         </p:nvSpPr>
         <p:spPr>
           <a:xfrm>
-            <a:off x="347472" y="484632"/>
-            <a:ext cx="2057400" cy="109728"/>
+            <a:off x="347472" y="438912"/>
+            <a:ext cx="2011680" cy="274320"/>
           </a:xfrm>
           <a:prstGeom prst="rect">
             <a:avLst/>
           </a:prstGeom>
           <a:noFill/>
-        </p:spPr>
-        <p:txBody>
-          <a:bodyPr wrap="square" lIns="36576" rIns="36576" tIns="18288" bIns="18288">
+          <a:ln/>
+        </p:spPr>
+        <p:txBody>
+          <a:bodyPr wrap="square">
             <a:spAutoFit/>
           </a:bodyPr>
           <a:lstStyle/>
           <a:p>
             <a:pPr algn="ctr"/>
             <a:r>
-              <a:rPr sz="850" b="1" i="0">
+              <a:rPr sz="900" b="1" i="0">
                 <a:solidFill>
                   <a:srgbClr val="FFFFFF"/>
                 </a:solidFill>
-                <a:latin typeface="Segoe UI"/>
+                <a:latin typeface="Arial"/>
               </a:rPr>
               <a:t>PG5 STQC AGENT</a:t>
             </a:r>
@@ -26417,28 +26421,29 @@
         <p:spPr>
           <a:xfrm>
             <a:off x="347472" y="749808"/>
-            <a:ext cx="8458200" cy="475488"/>
+            <a:ext cx="8229600" cy="461665"/>
           </a:xfrm>
           <a:prstGeom prst="rect">
             <a:avLst/>
           </a:prstGeom>
           <a:noFill/>
-        </p:spPr>
-        <p:txBody>
-          <a:bodyPr wrap="square" lIns="36576" rIns="36576" tIns="18288" bIns="18288">
+          <a:ln/>
+        </p:spPr>
+        <p:txBody>
+          <a:bodyPr wrap="square">
             <a:spAutoFit/>
           </a:bodyPr>
           <a:lstStyle/>
           <a:p>
             <a:pPr algn="l"/>
             <a:r>
-              <a:rPr sz="2250" b="1" i="0">
+              <a:rPr sz="2400" b="1" i="0">
                 <a:solidFill>
                   <a:srgbClr val="FFFFFF"/>
                 </a:solidFill>
-                <a:latin typeface="Segoe UI"/>
+                <a:latin typeface="Arial"/>
               </a:rPr>
-              <a:t>STQC Agent: Memory, Indexing and Certification Evidence</a:t>
+              <a:t>STQC Agent for BIS Certification</a:t>
             </a:r>
           </a:p>
         </p:txBody>
@@ -26451,14 +26456,14 @@
         </p:nvSpPr>
         <p:spPr>
           <a:xfrm>
-            <a:off x="347472" y="1325880"/>
-            <a:ext cx="8449056" cy="14630"/>
+            <a:off x="365760" y="1325880"/>
+            <a:ext cx="8412480" cy="14630"/>
           </a:xfrm>
           <a:prstGeom prst="rect">
             <a:avLst/>
           </a:prstGeom>
           <a:solidFill>
-            <a:srgbClr val="F5C518"/>
+            <a:srgbClr val="D71920"/>
           </a:solidFill>
           <a:ln>
             <a:noFill/>
@@ -26483,6 +26488,7 @@
           <a:lstStyle/>
           <a:p>
             <a:pPr algn="ctr"/>
+            <a:endParaRPr/>
           </a:p>
         </p:txBody>
       </p:sp>
@@ -26495,28 +26501,29 @@
         <p:spPr>
           <a:xfrm>
             <a:off x="347472" y="1417320"/>
-            <a:ext cx="8503920" cy="384048"/>
+            <a:ext cx="8503920" cy="461665"/>
           </a:xfrm>
           <a:prstGeom prst="rect">
             <a:avLst/>
           </a:prstGeom>
           <a:noFill/>
-        </p:spPr>
-        <p:txBody>
-          <a:bodyPr wrap="square" lIns="36576" rIns="36576" tIns="18288" bIns="18288">
+          <a:ln/>
+        </p:spPr>
+        <p:txBody>
+          <a:bodyPr wrap="square">
             <a:spAutoFit/>
           </a:bodyPr>
           <a:lstStyle/>
           <a:p>
             <a:pPr algn="l"/>
             <a:r>
-              <a:rPr sz="1050" b="0" i="1">
+              <a:rPr sz="1200" b="0" i="1" dirty="0">
                 <a:solidFill>
-                  <a:srgbClr val="B8D0EC"/>
+                  <a:srgbClr val="E8E8E8"/>
                 </a:solidFill>
-                <a:latin typeface="Segoe UI"/>
+                <a:latin typeface="Arial"/>
               </a:rPr>
-              <a:t>Extends PG5 beyond evidence generation: agents preserve task memory, execute Jira plans through Q&amp;A, index the codebase, and produce STQC-ready TCF/compliance artifacts.</a:t>
+              <a:t>IoT security and surveillance devices need BIS certification governed by STQC guidelines for in-house designs and BTS sales.</a:t>
             </a:r>
           </a:p>
         </p:txBody>
@@ -26529,19 +26536,17 @@
         </p:nvSpPr>
         <p:spPr>
           <a:xfrm>
-            <a:off x="347472" y="1993392"/>
-            <a:ext cx="2029968" cy="1664208"/>
+            <a:off x="320040" y="2011680"/>
+            <a:ext cx="5029200" cy="1353312"/>
           </a:xfrm>
           <a:prstGeom prst="roundRect">
             <a:avLst/>
           </a:prstGeom>
           <a:solidFill>
-            <a:srgbClr val="0F2845"/>
-          </a:solidFill>
-          <a:ln>
-            <a:solidFill>
-              <a:srgbClr val="144A70"/>
-            </a:solidFill>
+            <a:srgbClr val="333333"/>
+          </a:solidFill>
+          <a:ln>
+            <a:noFill/>
           </a:ln>
         </p:spPr>
         <p:style>
@@ -26563,6 +26568,7 @@
           <a:lstStyle/>
           <a:p>
             <a:pPr algn="ctr"/>
+            <a:endParaRPr/>
           </a:p>
         </p:txBody>
       </p:sp>
@@ -26574,14 +26580,14 @@
         </p:nvSpPr>
         <p:spPr>
           <a:xfrm>
-            <a:off x="347472" y="1993392"/>
-            <a:ext cx="2029968" cy="50292"/>
+            <a:off x="320040" y="2011680"/>
+            <a:ext cx="50292" cy="1353312"/>
           </a:xfrm>
           <a:prstGeom prst="rect">
             <a:avLst/>
           </a:prstGeom>
           <a:solidFill>
-            <a:srgbClr val="00C8F0"/>
+            <a:srgbClr val="2E7D32"/>
           </a:solidFill>
           <a:ln>
             <a:noFill/>
@@ -26606,25 +26612,26 @@
           <a:lstStyle/>
           <a:p>
             <a:pPr algn="ctr"/>
-          </a:p>
-        </p:txBody>
-      </p:sp>
-      <p:sp>
-        <p:nvSpPr>
-          <p:cNvPr id="11" name="Oval 10"/>
-          <p:cNvSpPr/>
-          <p:nvPr/>
-        </p:nvSpPr>
-        <p:spPr>
-          <a:xfrm>
-            <a:off x="457200" y="2176272"/>
-            <a:ext cx="384048" cy="384048"/>
-          </a:xfrm>
-          <a:prstGeom prst="ellipse">
-            <a:avLst/>
-          </a:prstGeom>
-          <a:solidFill>
-            <a:srgbClr val="00C8F0"/>
+            <a:endParaRPr/>
+          </a:p>
+        </p:txBody>
+      </p:sp>
+      <p:sp>
+        <p:nvSpPr>
+          <p:cNvPr id="11" name="Rounded Rectangle 10"/>
+          <p:cNvSpPr/>
+          <p:nvPr/>
+        </p:nvSpPr>
+        <p:spPr>
+          <a:xfrm>
+            <a:off x="475488" y="2395728"/>
+            <a:ext cx="502920" cy="502920"/>
+          </a:xfrm>
+          <a:prstGeom prst="roundRect">
+            <a:avLst/>
+          </a:prstGeom>
+          <a:solidFill>
+            <a:srgbClr val="2E7D32"/>
           </a:solidFill>
           <a:ln>
             <a:noFill/>
@@ -26649,6 +26656,7 @@
           <a:lstStyle/>
           <a:p>
             <a:pPr algn="ctr"/>
+            <a:endParaRPr/>
           </a:p>
         </p:txBody>
       </p:sp>
@@ -26660,29 +26668,30 @@
         </p:nvSpPr>
         <p:spPr>
           <a:xfrm>
-            <a:off x="457200" y="2276856"/>
-            <a:ext cx="384048" cy="91440"/>
+            <a:off x="475488" y="2395728"/>
+            <a:ext cx="502920" cy="502920"/>
           </a:xfrm>
           <a:prstGeom prst="rect">
             <a:avLst/>
           </a:prstGeom>
           <a:noFill/>
-        </p:spPr>
-        <p:txBody>
-          <a:bodyPr wrap="square" lIns="36576" rIns="36576" tIns="18288" bIns="18288">
+          <a:ln/>
+        </p:spPr>
+        <p:txBody>
+          <a:bodyPr wrap="square">
             <a:spAutoFit/>
           </a:bodyPr>
           <a:lstStyle/>
           <a:p>
             <a:pPr algn="ctr"/>
             <a:r>
-              <a:rPr sz="819" b="1" i="0">
+              <a:rPr sz="1600" b="1" i="0">
                 <a:solidFill>
                   <a:srgbClr val="FFFFFF"/>
                 </a:solidFill>
-                <a:latin typeface="Segoe UI"/>
+                <a:latin typeface="Arial"/>
               </a:rPr>
-              <a:t>01</a:t>
+              <a:t>✓</a:t>
             </a:r>
           </a:p>
         </p:txBody>
@@ -26695,132 +26704,90 @@
         </p:nvSpPr>
         <p:spPr>
           <a:xfrm>
-            <a:off x="914400" y="2103120"/>
-            <a:ext cx="1335024" cy="329184"/>
+            <a:off x="1115568" y="2084832"/>
+            <a:ext cx="4114800" cy="502920"/>
           </a:xfrm>
           <a:prstGeom prst="rect">
             <a:avLst/>
           </a:prstGeom>
           <a:noFill/>
-        </p:spPr>
-        <p:txBody>
-          <a:bodyPr wrap="square" lIns="36576" rIns="36576" tIns="18288" bIns="18288">
+          <a:ln/>
+        </p:spPr>
+        <p:txBody>
+          <a:bodyPr wrap="square">
             <a:spAutoFit/>
           </a:bodyPr>
           <a:lstStyle/>
           <a:p>
             <a:pPr algn="l"/>
             <a:r>
-              <a:rPr sz="1000" b="1" i="0">
+              <a:rPr sz="1300" b="1" i="0">
                 <a:solidFill>
-                  <a:srgbClr val="00C8F0"/>
+                  <a:srgbClr val="2E7D32"/>
                 </a:solidFill>
-                <a:latin typeface="Segoe UI"/>
+                <a:latin typeface="Arial"/>
               </a:rPr>
-              <a:t>Task Memory</a:t>
+              <a:t>Creates STQC
+Audit Evidence</a:t>
             </a:r>
           </a:p>
         </p:txBody>
       </p:sp>
       <p:sp>
         <p:nvSpPr>
-          <p:cNvPr id="14" name="Rectangle 13"/>
-          <p:cNvSpPr/>
-          <p:nvPr/>
-        </p:nvSpPr>
-        <p:spPr>
-          <a:xfrm>
-            <a:off x="493776" y="2615184"/>
-            <a:ext cx="1737360" cy="10972"/>
+          <p:cNvPr id="14" name="TextBox 13"/>
+          <p:cNvSpPr txBox="1"/>
+          <p:nvPr/>
+        </p:nvSpPr>
+        <p:spPr>
+          <a:xfrm>
+            <a:off x="1115568" y="2606040"/>
+            <a:ext cx="4069080" cy="685800"/>
           </a:xfrm>
           <a:prstGeom prst="rect">
             <a:avLst/>
           </a:prstGeom>
-          <a:solidFill>
-            <a:srgbClr val="00C8F0"/>
-          </a:solidFill>
-          <a:ln>
-            <a:noFill/>
-          </a:ln>
-        </p:spPr>
-        <p:style>
-          <a:lnRef idx="1">
-            <a:schemeClr val="accent1"/>
-          </a:lnRef>
-          <a:fillRef idx="3">
-            <a:schemeClr val="accent1"/>
-          </a:fillRef>
-          <a:effectRef idx="2">
-            <a:schemeClr val="accent1"/>
-          </a:effectRef>
-          <a:fontRef idx="minor">
-            <a:schemeClr val="lt1"/>
-          </a:fontRef>
-        </p:style>
-        <p:txBody>
-          <a:bodyPr rtlCol="0" anchor="ctr"/>
-          <a:lstStyle/>
-          <a:p>
-            <a:pPr algn="ctr"/>
-          </a:p>
-        </p:txBody>
-      </p:sp>
-      <p:sp>
-        <p:nvSpPr>
-          <p:cNvPr id="15" name="TextBox 14"/>
-          <p:cNvSpPr txBox="1"/>
-          <p:nvPr/>
-        </p:nvSpPr>
-        <p:spPr>
-          <a:xfrm>
-            <a:off x="493776" y="2743200"/>
-            <a:ext cx="1737360" cy="658368"/>
-          </a:xfrm>
-          <a:prstGeom prst="rect">
-            <a:avLst/>
-          </a:prstGeom>
           <a:noFill/>
-        </p:spPr>
-        <p:txBody>
-          <a:bodyPr wrap="square" lIns="36576" rIns="36576" tIns="18288" bIns="18288">
+          <a:ln/>
+        </p:spPr>
+        <p:txBody>
+          <a:bodyPr wrap="square">
             <a:spAutoFit/>
           </a:bodyPr>
           <a:lstStyle/>
           <a:p>
             <a:pPr algn="l"/>
             <a:r>
-              <a:rPr sz="819" b="0" i="0">
+              <a:rPr sz="1150" b="0" i="0">
                 <a:solidFill>
-                  <a:srgbClr val="B8D0EC"/>
+                  <a:srgbClr val="E8E8E8"/>
                 </a:solidFill>
-                <a:latin typeface="Segoe UI"/>
+                <a:latin typeface="Arial"/>
               </a:rPr>
-              <a:t>Agents auto-generate context dump files after each task so future agents resume with full awareness.</a:t>
+              <a:t>Crawls code, configuration and evidence sources to prepare auditor-ready STQC artifacts.</a:t>
             </a:r>
           </a:p>
         </p:txBody>
       </p:sp>
       <p:sp>
         <p:nvSpPr>
-          <p:cNvPr id="16" name="Rounded Rectangle 15"/>
-          <p:cNvSpPr/>
-          <p:nvPr/>
-        </p:nvSpPr>
-        <p:spPr>
-          <a:xfrm>
-            <a:off x="2560320" y="1993392"/>
-            <a:ext cx="2029968" cy="1664208"/>
+          <p:cNvPr id="15" name="Rounded Rectangle 14"/>
+          <p:cNvSpPr/>
+          <p:nvPr/>
+        </p:nvSpPr>
+        <p:spPr>
+          <a:xfrm>
+            <a:off x="320040" y="3520440"/>
+            <a:ext cx="5029200" cy="1353312"/>
           </a:xfrm>
           <a:prstGeom prst="roundRect">
             <a:avLst/>
           </a:prstGeom>
           <a:solidFill>
-            <a:srgbClr val="0F2845"/>
-          </a:solidFill>
-          <a:ln>
-            <a:solidFill>
-              <a:srgbClr val="144A70"/>
-            </a:solidFill>
+            <a:srgbClr val="333333"/>
+          </a:solidFill>
+          <a:ln>
+            <a:noFill/>
           </a:ln>
         </p:spPr>
         <p:style>
@@ -26842,25 +26809,26 @@
           <a:lstStyle/>
           <a:p>
             <a:pPr algn="ctr"/>
-          </a:p>
-        </p:txBody>
-      </p:sp>
-      <p:sp>
-        <p:nvSpPr>
-          <p:cNvPr id="17" name="Rectangle 16"/>
-          <p:cNvSpPr/>
-          <p:nvPr/>
-        </p:nvSpPr>
-        <p:spPr>
-          <a:xfrm>
-            <a:off x="2560320" y="1993392"/>
-            <a:ext cx="2029968" cy="50292"/>
+            <a:endParaRPr/>
+          </a:p>
+        </p:txBody>
+      </p:sp>
+      <p:sp>
+        <p:nvSpPr>
+          <p:cNvPr id="16" name="Rectangle 15"/>
+          <p:cNvSpPr/>
+          <p:nvPr/>
+        </p:nvSpPr>
+        <p:spPr>
+          <a:xfrm>
+            <a:off x="320040" y="3520440"/>
+            <a:ext cx="50292" cy="1353312"/>
           </a:xfrm>
           <a:prstGeom prst="rect">
             <a:avLst/>
           </a:prstGeom>
           <a:solidFill>
-            <a:srgbClr val="0072C6"/>
+            <a:srgbClr val="D71920"/>
           </a:solidFill>
           <a:ln>
             <a:noFill/>
@@ -26885,25 +26853,26 @@
           <a:lstStyle/>
           <a:p>
             <a:pPr algn="ctr"/>
-          </a:p>
-        </p:txBody>
-      </p:sp>
-      <p:sp>
-        <p:nvSpPr>
-          <p:cNvPr id="18" name="Oval 17"/>
-          <p:cNvSpPr/>
-          <p:nvPr/>
-        </p:nvSpPr>
-        <p:spPr>
-          <a:xfrm>
-            <a:off x="2670048" y="2176272"/>
-            <a:ext cx="384048" cy="384048"/>
-          </a:xfrm>
-          <a:prstGeom prst="ellipse">
-            <a:avLst/>
-          </a:prstGeom>
-          <a:solidFill>
-            <a:srgbClr val="0072C6"/>
+            <a:endParaRPr/>
+          </a:p>
+        </p:txBody>
+      </p:sp>
+      <p:sp>
+        <p:nvSpPr>
+          <p:cNvPr id="17" name="Rounded Rectangle 16"/>
+          <p:cNvSpPr/>
+          <p:nvPr/>
+        </p:nvSpPr>
+        <p:spPr>
+          <a:xfrm>
+            <a:off x="475488" y="3904488"/>
+            <a:ext cx="502920" cy="502920"/>
+          </a:xfrm>
+          <a:prstGeom prst="roundRect">
+            <a:avLst/>
+          </a:prstGeom>
+          <a:solidFill>
+            <a:srgbClr val="D71920"/>
           </a:solidFill>
           <a:ln>
             <a:noFill/>
@@ -26928,40 +26897,79 @@
           <a:lstStyle/>
           <a:p>
             <a:pPr algn="ctr"/>
-          </a:p>
-        </p:txBody>
-      </p:sp>
-      <p:sp>
-        <p:nvSpPr>
-          <p:cNvPr id="19" name="TextBox 18"/>
+            <a:endParaRPr/>
+          </a:p>
+        </p:txBody>
+      </p:sp>
+      <p:sp>
+        <p:nvSpPr>
+          <p:cNvPr id="18" name="TextBox 17"/>
           <p:cNvSpPr txBox="1"/>
           <p:nvPr/>
         </p:nvSpPr>
         <p:spPr>
           <a:xfrm>
-            <a:off x="2670048" y="2276856"/>
-            <a:ext cx="384048" cy="91440"/>
+            <a:off x="475488" y="3904488"/>
+            <a:ext cx="502920" cy="502920"/>
           </a:xfrm>
           <a:prstGeom prst="rect">
             <a:avLst/>
           </a:prstGeom>
           <a:noFill/>
-        </p:spPr>
-        <p:txBody>
-          <a:bodyPr wrap="square" lIns="36576" rIns="36576" tIns="18288" bIns="18288">
+          <a:ln/>
+        </p:spPr>
+        <p:txBody>
+          <a:bodyPr wrap="square">
             <a:spAutoFit/>
           </a:bodyPr>
           <a:lstStyle/>
           <a:p>
             <a:pPr algn="ctr"/>
             <a:r>
-              <a:rPr sz="819" b="1" i="0">
+              <a:rPr sz="1600" b="1" i="0">
                 <a:solidFill>
                   <a:srgbClr val="FFFFFF"/>
                 </a:solidFill>
-                <a:latin typeface="Segoe UI"/>
+                <a:latin typeface="Arial"/>
               </a:rPr>
-              <a:t>02</a:t>
+              <a:t>◈</a:t>
+            </a:r>
+          </a:p>
+        </p:txBody>
+      </p:sp>
+      <p:sp>
+        <p:nvSpPr>
+          <p:cNvPr id="19" name="TextBox 18"/>
+          <p:cNvSpPr txBox="1"/>
+          <p:nvPr/>
+        </p:nvSpPr>
+        <p:spPr>
+          <a:xfrm>
+            <a:off x="1115568" y="3593592"/>
+            <a:ext cx="4114800" cy="502920"/>
+          </a:xfrm>
+          <a:prstGeom prst="rect">
+            <a:avLst/>
+          </a:prstGeom>
+          <a:noFill/>
+          <a:ln/>
+        </p:spPr>
+        <p:txBody>
+          <a:bodyPr wrap="square">
+            <a:spAutoFit/>
+          </a:bodyPr>
+          <a:lstStyle/>
+          <a:p>
+            <a:pPr algn="l"/>
+            <a:r>
+              <a:rPr sz="1300" b="1" i="0">
+                <a:solidFill>
+                  <a:srgbClr val="D71920"/>
+                </a:solidFill>
+                <a:latin typeface="Arial"/>
+              </a:rPr>
+              <a:t>Guideline Verdict:
+READY / NOT_READY</a:t>
             </a:r>
           </a:p>
         </p:txBody>
@@ -26974,49 +26982,94 @@
         </p:nvSpPr>
         <p:spPr>
           <a:xfrm>
-            <a:off x="3127248" y="2103120"/>
-            <a:ext cx="1335024" cy="329184"/>
+            <a:off x="1115568" y="4114800"/>
+            <a:ext cx="4069080" cy="685800"/>
           </a:xfrm>
           <a:prstGeom prst="rect">
             <a:avLst/>
           </a:prstGeom>
           <a:noFill/>
-        </p:spPr>
-        <p:txBody>
-          <a:bodyPr wrap="square" lIns="36576" rIns="36576" tIns="18288" bIns="18288">
+          <a:ln/>
+        </p:spPr>
+        <p:txBody>
+          <a:bodyPr wrap="square">
             <a:spAutoFit/>
           </a:bodyPr>
           <a:lstStyle/>
           <a:p>
             <a:pPr algn="l"/>
             <a:r>
-              <a:rPr sz="1000" b="1" i="0">
+              <a:rPr sz="1150" b="0" i="0">
                 <a:solidFill>
-                  <a:srgbClr val="0072C6"/>
+                  <a:srgbClr val="E8E8E8"/>
                 </a:solidFill>
-                <a:latin typeface="Segoe UI"/>
+                <a:latin typeface="Arial"/>
               </a:rPr>
-              <a:t>Plan-Driven Execution</a:t>
+              <a:t>Checks STQC ER guidance, hard rules such as no foreign characters, and submission completeness.</a:t>
             </a:r>
           </a:p>
         </p:txBody>
       </p:sp>
       <p:sp>
         <p:nvSpPr>
-          <p:cNvPr id="21" name="Rectangle 20"/>
-          <p:cNvSpPr/>
-          <p:nvPr/>
-        </p:nvSpPr>
-        <p:spPr>
-          <a:xfrm>
-            <a:off x="2706624" y="2615184"/>
-            <a:ext cx="1737360" cy="10972"/>
+          <p:cNvPr id="21" name="Rounded Rectangle 20"/>
+          <p:cNvSpPr/>
+          <p:nvPr/>
+        </p:nvSpPr>
+        <p:spPr>
+          <a:xfrm>
+            <a:off x="320040" y="5029200"/>
+            <a:ext cx="5029200" cy="1353312"/>
+          </a:xfrm>
+          <a:prstGeom prst="roundRect">
+            <a:avLst/>
+          </a:prstGeom>
+          <a:solidFill>
+            <a:srgbClr val="333333"/>
+          </a:solidFill>
+          <a:ln>
+            <a:noFill/>
+          </a:ln>
+        </p:spPr>
+        <p:style>
+          <a:lnRef idx="1">
+            <a:schemeClr val="accent1"/>
+          </a:lnRef>
+          <a:fillRef idx="3">
+            <a:schemeClr val="accent1"/>
+          </a:fillRef>
+          <a:effectRef idx="2">
+            <a:schemeClr val="accent1"/>
+          </a:effectRef>
+          <a:fontRef idx="minor">
+            <a:schemeClr val="lt1"/>
+          </a:fontRef>
+        </p:style>
+        <p:txBody>
+          <a:bodyPr rtlCol="0" anchor="ctr"/>
+          <a:lstStyle/>
+          <a:p>
+            <a:pPr algn="ctr"/>
+            <a:endParaRPr/>
+          </a:p>
+        </p:txBody>
+      </p:sp>
+      <p:sp>
+        <p:nvSpPr>
+          <p:cNvPr id="22" name="Rectangle 21"/>
+          <p:cNvSpPr/>
+          <p:nvPr/>
+        </p:nvSpPr>
+        <p:spPr>
+          <a:xfrm>
+            <a:off x="320040" y="5029200"/>
+            <a:ext cx="50292" cy="1353312"/>
           </a:xfrm>
           <a:prstGeom prst="rect">
             <a:avLst/>
           </a:prstGeom>
           <a:solidFill>
-            <a:srgbClr val="0072C6"/>
+            <a:srgbClr val="D71920"/>
           </a:solidFill>
           <a:ln>
             <a:noFill/>
@@ -27041,261 +27094,223 @@
           <a:lstStyle/>
           <a:p>
             <a:pPr algn="ctr"/>
-          </a:p>
-        </p:txBody>
-      </p:sp>
-      <p:sp>
-        <p:nvSpPr>
-          <p:cNvPr id="22" name="TextBox 21"/>
+            <a:endParaRPr/>
+          </a:p>
+        </p:txBody>
+      </p:sp>
+      <p:sp>
+        <p:nvSpPr>
+          <p:cNvPr id="23" name="Rounded Rectangle 22"/>
+          <p:cNvSpPr/>
+          <p:nvPr/>
+        </p:nvSpPr>
+        <p:spPr>
+          <a:xfrm>
+            <a:off x="475488" y="5413248"/>
+            <a:ext cx="502920" cy="502920"/>
+          </a:xfrm>
+          <a:prstGeom prst="roundRect">
+            <a:avLst/>
+          </a:prstGeom>
+          <a:solidFill>
+            <a:srgbClr val="D71920"/>
+          </a:solidFill>
+          <a:ln>
+            <a:noFill/>
+          </a:ln>
+        </p:spPr>
+        <p:style>
+          <a:lnRef idx="1">
+            <a:schemeClr val="accent1"/>
+          </a:lnRef>
+          <a:fillRef idx="3">
+            <a:schemeClr val="accent1"/>
+          </a:fillRef>
+          <a:effectRef idx="2">
+            <a:schemeClr val="accent1"/>
+          </a:effectRef>
+          <a:fontRef idx="minor">
+            <a:schemeClr val="lt1"/>
+          </a:fontRef>
+        </p:style>
+        <p:txBody>
+          <a:bodyPr rtlCol="0" anchor="ctr"/>
+          <a:lstStyle/>
+          <a:p>
+            <a:pPr algn="ctr"/>
+            <a:endParaRPr/>
+          </a:p>
+        </p:txBody>
+      </p:sp>
+      <p:sp>
+        <p:nvSpPr>
+          <p:cNvPr id="24" name="TextBox 23"/>
           <p:cNvSpPr txBox="1"/>
           <p:nvPr/>
         </p:nvSpPr>
         <p:spPr>
           <a:xfrm>
-            <a:off x="2706624" y="2743200"/>
-            <a:ext cx="1737360" cy="658368"/>
+            <a:off x="475488" y="5413248"/>
+            <a:ext cx="502920" cy="502920"/>
           </a:xfrm>
           <a:prstGeom prst="rect">
             <a:avLst/>
           </a:prstGeom>
           <a:noFill/>
-        </p:spPr>
-        <p:txBody>
-          <a:bodyPr wrap="square" lIns="36576" rIns="36576" tIns="18288" bIns="18288">
+          <a:ln/>
+        </p:spPr>
+        <p:txBody>
+          <a:bodyPr wrap="square">
             <a:spAutoFit/>
           </a:bodyPr>
           <a:lstStyle/>
           <a:p>
-            <a:pPr algn="l"/>
-            <a:r>
-              <a:rPr sz="819" b="0" i="0">
-                <a:solidFill>
-                  <a:srgbClr val="B8D0EC"/>
-                </a:solidFill>
-                <a:latin typeface="Segoe UI"/>
-              </a:rPr>
-              <a:t>Jira stories run through interactive Q&amp;A to refine scope and ensure precise definition.</a:t>
-            </a:r>
-          </a:p>
-        </p:txBody>
-      </p:sp>
-      <p:sp>
-        <p:nvSpPr>
-          <p:cNvPr id="23" name="Rounded Rectangle 22"/>
-          <p:cNvSpPr/>
-          <p:nvPr/>
-        </p:nvSpPr>
-        <p:spPr>
-          <a:xfrm>
-            <a:off x="4773168" y="1993392"/>
-            <a:ext cx="2029968" cy="1664208"/>
-          </a:xfrm>
-          <a:prstGeom prst="roundRect">
-            <a:avLst/>
-          </a:prstGeom>
-          <a:solidFill>
-            <a:srgbClr val="0F2845"/>
-          </a:solidFill>
-          <a:ln>
-            <a:solidFill>
-              <a:srgbClr val="144A70"/>
-            </a:solidFill>
-          </a:ln>
-        </p:spPr>
-        <p:style>
-          <a:lnRef idx="1">
-            <a:schemeClr val="accent1"/>
-          </a:lnRef>
-          <a:fillRef idx="3">
-            <a:schemeClr val="accent1"/>
-          </a:fillRef>
-          <a:effectRef idx="2">
-            <a:schemeClr val="accent1"/>
-          </a:effectRef>
-          <a:fontRef idx="minor">
-            <a:schemeClr val="lt1"/>
-          </a:fontRef>
-        </p:style>
-        <p:txBody>
-          <a:bodyPr rtlCol="0" anchor="ctr"/>
-          <a:lstStyle/>
-          <a:p>
-            <a:pPr algn="ctr"/>
-          </a:p>
-        </p:txBody>
-      </p:sp>
-      <p:sp>
-        <p:nvSpPr>
-          <p:cNvPr id="24" name="Rectangle 23"/>
-          <p:cNvSpPr/>
-          <p:nvPr/>
-        </p:nvSpPr>
-        <p:spPr>
-          <a:xfrm>
-            <a:off x="4773168" y="1993392"/>
-            <a:ext cx="2029968" cy="50292"/>
-          </a:xfrm>
-          <a:prstGeom prst="rect">
-            <a:avLst/>
-          </a:prstGeom>
-          <a:solidFill>
-            <a:srgbClr val="00A89A"/>
-          </a:solidFill>
-          <a:ln>
-            <a:noFill/>
-          </a:ln>
-        </p:spPr>
-        <p:style>
-          <a:lnRef idx="1">
-            <a:schemeClr val="accent1"/>
-          </a:lnRef>
-          <a:fillRef idx="3">
-            <a:schemeClr val="accent1"/>
-          </a:fillRef>
-          <a:effectRef idx="2">
-            <a:schemeClr val="accent1"/>
-          </a:effectRef>
-          <a:fontRef idx="minor">
-            <a:schemeClr val="lt1"/>
-          </a:fontRef>
-        </p:style>
-        <p:txBody>
-          <a:bodyPr rtlCol="0" anchor="ctr"/>
-          <a:lstStyle/>
-          <a:p>
-            <a:pPr algn="ctr"/>
-          </a:p>
-        </p:txBody>
-      </p:sp>
-      <p:sp>
-        <p:nvSpPr>
-          <p:cNvPr id="25" name="Oval 24"/>
-          <p:cNvSpPr/>
-          <p:nvPr/>
-        </p:nvSpPr>
-        <p:spPr>
-          <a:xfrm>
-            <a:off x="4882896" y="2176272"/>
-            <a:ext cx="384048" cy="384048"/>
-          </a:xfrm>
-          <a:prstGeom prst="ellipse">
-            <a:avLst/>
-          </a:prstGeom>
-          <a:solidFill>
-            <a:srgbClr val="00A89A"/>
-          </a:solidFill>
-          <a:ln>
-            <a:noFill/>
-          </a:ln>
-        </p:spPr>
-        <p:style>
-          <a:lnRef idx="1">
-            <a:schemeClr val="accent1"/>
-          </a:lnRef>
-          <a:fillRef idx="3">
-            <a:schemeClr val="accent1"/>
-          </a:fillRef>
-          <a:effectRef idx="2">
-            <a:schemeClr val="accent1"/>
-          </a:effectRef>
-          <a:fontRef idx="minor">
-            <a:schemeClr val="lt1"/>
-          </a:fontRef>
-        </p:style>
-        <p:txBody>
-          <a:bodyPr rtlCol="0" anchor="ctr"/>
-          <a:lstStyle/>
-          <a:p>
-            <a:pPr algn="ctr"/>
-          </a:p>
-        </p:txBody>
-      </p:sp>
-      <p:sp>
-        <p:nvSpPr>
-          <p:cNvPr id="26" name="TextBox 25"/>
-          <p:cNvSpPr txBox="1"/>
-          <p:nvPr/>
-        </p:nvSpPr>
-        <p:spPr>
-          <a:xfrm>
-            <a:off x="4882896" y="2276856"/>
-            <a:ext cx="384048" cy="91440"/>
-          </a:xfrm>
-          <a:prstGeom prst="rect">
-            <a:avLst/>
-          </a:prstGeom>
-          <a:noFill/>
-        </p:spPr>
-        <p:txBody>
-          <a:bodyPr wrap="square" lIns="36576" rIns="36576" tIns="18288" bIns="18288">
-            <a:spAutoFit/>
-          </a:bodyPr>
-          <a:lstStyle/>
-          <a:p>
             <a:pPr algn="ctr"/>
             <a:r>
-              <a:rPr sz="819" b="1" i="0">
+              <a:rPr sz="1600" b="1" i="0">
                 <a:solidFill>
                   <a:srgbClr val="FFFFFF"/>
                 </a:solidFill>
-                <a:latin typeface="Segoe UI"/>
+                <a:latin typeface="Arial"/>
               </a:rPr>
-              <a:t>03</a:t>
+              <a:t>→</a:t>
             </a:r>
           </a:p>
         </p:txBody>
       </p:sp>
       <p:sp>
         <p:nvSpPr>
-          <p:cNvPr id="27" name="TextBox 26"/>
+          <p:cNvPr id="25" name="TextBox 24"/>
           <p:cNvSpPr txBox="1"/>
           <p:nvPr/>
         </p:nvSpPr>
         <p:spPr>
           <a:xfrm>
-            <a:off x="5340096" y="2103120"/>
-            <a:ext cx="1335024" cy="329184"/>
+            <a:off x="1115568" y="5102352"/>
+            <a:ext cx="4114800" cy="502920"/>
           </a:xfrm>
           <a:prstGeom prst="rect">
             <a:avLst/>
           </a:prstGeom>
           <a:noFill/>
-        </p:spPr>
-        <p:txBody>
-          <a:bodyPr wrap="square" lIns="36576" rIns="36576" tIns="18288" bIns="18288">
+          <a:ln/>
+        </p:spPr>
+        <p:txBody>
+          <a:bodyPr wrap="square">
             <a:spAutoFit/>
           </a:bodyPr>
           <a:lstStyle/>
           <a:p>
             <a:pPr algn="l"/>
             <a:r>
-              <a:rPr sz="1000" b="1" i="0">
+              <a:rPr sz="1300" b="1" i="0">
                 <a:solidFill>
-                  <a:srgbClr val="00A89A"/>
+                  <a:srgbClr val="D71920"/>
                 </a:solidFill>
-                <a:latin typeface="Segoe UI"/>
+                <a:latin typeface="Arial"/>
               </a:rPr>
-              <a:t>Codebase Indexer</a:t>
+              <a:t>Jira Remediation
+Actions</a:t>
             </a:r>
           </a:p>
         </p:txBody>
       </p:sp>
       <p:sp>
         <p:nvSpPr>
+          <p:cNvPr id="26" name="TextBox 25"/>
+          <p:cNvSpPr txBox="1"/>
+          <p:nvPr/>
+        </p:nvSpPr>
+        <p:spPr>
+          <a:xfrm>
+            <a:off x="1115568" y="5623560"/>
+            <a:ext cx="4069080" cy="685800"/>
+          </a:xfrm>
+          <a:prstGeom prst="rect">
+            <a:avLst/>
+          </a:prstGeom>
+          <a:noFill/>
+          <a:ln/>
+        </p:spPr>
+        <p:txBody>
+          <a:bodyPr wrap="square">
+            <a:spAutoFit/>
+          </a:bodyPr>
+          <a:lstStyle/>
+          <a:p>
+            <a:pPr algn="l"/>
+            <a:r>
+              <a:rPr sz="1150" b="0" i="0">
+                <a:solidFill>
+                  <a:srgbClr val="E8E8E8"/>
+                </a:solidFill>
+                <a:latin typeface="Arial"/>
+              </a:rPr>
+              <a:t>Every NOT_READY result highlights the failing section and creates stories or defects to fix it.</a:t>
+            </a:r>
+          </a:p>
+        </p:txBody>
+      </p:sp>
+      <p:sp>
+        <p:nvSpPr>
+          <p:cNvPr id="27" name="Rounded Rectangle 26"/>
+          <p:cNvSpPr/>
+          <p:nvPr/>
+        </p:nvSpPr>
+        <p:spPr>
+          <a:xfrm>
+            <a:off x="5623560" y="1965960"/>
+            <a:ext cx="3182112" cy="4498848"/>
+          </a:xfrm>
+          <a:prstGeom prst="roundRect">
+            <a:avLst/>
+          </a:prstGeom>
+          <a:solidFill>
+            <a:srgbClr val="2B2B2B"/>
+          </a:solidFill>
+          <a:ln>
+            <a:noFill/>
+          </a:ln>
+        </p:spPr>
+        <p:style>
+          <a:lnRef idx="1">
+            <a:schemeClr val="accent1"/>
+          </a:lnRef>
+          <a:fillRef idx="3">
+            <a:schemeClr val="accent1"/>
+          </a:fillRef>
+          <a:effectRef idx="2">
+            <a:schemeClr val="accent1"/>
+          </a:effectRef>
+          <a:fontRef idx="minor">
+            <a:schemeClr val="lt1"/>
+          </a:fontRef>
+        </p:style>
+        <p:txBody>
+          <a:bodyPr rtlCol="0" anchor="ctr"/>
+          <a:lstStyle/>
+          <a:p>
+            <a:pPr algn="ctr"/>
+            <a:endParaRPr/>
+          </a:p>
+        </p:txBody>
+      </p:sp>
+      <p:sp>
+        <p:nvSpPr>
           <p:cNvPr id="28" name="Rectangle 27"/>
           <p:cNvSpPr/>
           <p:nvPr/>
         </p:nvSpPr>
         <p:spPr>
           <a:xfrm>
-            <a:off x="4919472" y="2615184"/>
-            <a:ext cx="1737360" cy="10972"/>
+            <a:off x="5623560" y="1965960"/>
+            <a:ext cx="3182112" cy="50292"/>
           </a:xfrm>
           <a:prstGeom prst="rect">
             <a:avLst/>
           </a:prstGeom>
           <a:solidFill>
-            <a:srgbClr val="00A89A"/>
+            <a:srgbClr val="D71920"/>
           </a:solidFill>
           <a:ln>
             <a:noFill/>
@@ -27320,6 +27335,7 @@
           <a:lstStyle/>
           <a:p>
             <a:pPr algn="ctr"/>
+            <a:endParaRPr/>
           </a:p>
         </p:txBody>
       </p:sp>
@@ -27331,54 +27347,97 @@
         </p:nvSpPr>
         <p:spPr>
           <a:xfrm>
-            <a:off x="4919472" y="2743200"/>
-            <a:ext cx="1737360" cy="658368"/>
+            <a:off x="5623560" y="2029968"/>
+            <a:ext cx="3182112" cy="347472"/>
           </a:xfrm>
           <a:prstGeom prst="rect">
             <a:avLst/>
           </a:prstGeom>
           <a:noFill/>
-        </p:spPr>
-        <p:txBody>
-          <a:bodyPr wrap="square" lIns="36576" rIns="36576" tIns="18288" bIns="18288">
+          <a:ln/>
+        </p:spPr>
+        <p:txBody>
+          <a:bodyPr wrap="square">
             <a:spAutoFit/>
           </a:bodyPr>
           <a:lstStyle/>
           <a:p>
-            <a:pPr algn="l"/>
+            <a:pPr algn="ctr"/>
             <a:r>
-              <a:rPr sz="819" b="0" i="0">
+              <a:rPr sz="1200" b="1" i="0">
                 <a:solidFill>
-                  <a:srgbClr val="B8D0EC"/>
+                  <a:srgbClr val="D71920"/>
                 </a:solidFill>
-                <a:latin typeface="Segoe UI"/>
+                <a:latin typeface="Arial"/>
               </a:rPr>
-              <a:t>Rust backend generates knowledge, indexing and analysis across the codebase.</a:t>
+              <a:t>STQC SUBMISSION GATE</a:t>
             </a:r>
           </a:p>
         </p:txBody>
       </p:sp>
       <p:sp>
         <p:nvSpPr>
-          <p:cNvPr id="30" name="Rounded Rectangle 29"/>
-          <p:cNvSpPr/>
-          <p:nvPr/>
-        </p:nvSpPr>
-        <p:spPr>
-          <a:xfrm>
-            <a:off x="6986016" y="1993392"/>
-            <a:ext cx="2029968" cy="1664208"/>
+          <p:cNvPr id="30" name="Rectangle 29"/>
+          <p:cNvSpPr/>
+          <p:nvPr/>
+        </p:nvSpPr>
+        <p:spPr>
+          <a:xfrm>
+            <a:off x="5623560" y="2423160"/>
+            <a:ext cx="3182112" cy="14630"/>
+          </a:xfrm>
+          <a:prstGeom prst="rect">
+            <a:avLst/>
+          </a:prstGeom>
+          <a:solidFill>
+            <a:srgbClr val="D71920"/>
+          </a:solidFill>
+          <a:ln>
+            <a:noFill/>
+          </a:ln>
+        </p:spPr>
+        <p:style>
+          <a:lnRef idx="1">
+            <a:schemeClr val="accent1"/>
+          </a:lnRef>
+          <a:fillRef idx="3">
+            <a:schemeClr val="accent1"/>
+          </a:fillRef>
+          <a:effectRef idx="2">
+            <a:schemeClr val="accent1"/>
+          </a:effectRef>
+          <a:fontRef idx="minor">
+            <a:schemeClr val="lt1"/>
+          </a:fontRef>
+        </p:style>
+        <p:txBody>
+          <a:bodyPr rtlCol="0" anchor="ctr"/>
+          <a:lstStyle/>
+          <a:p>
+            <a:pPr algn="ctr"/>
+            <a:endParaRPr/>
+          </a:p>
+        </p:txBody>
+      </p:sp>
+      <p:sp>
+        <p:nvSpPr>
+          <p:cNvPr id="31" name="Rounded Rectangle 30"/>
+          <p:cNvSpPr/>
+          <p:nvPr/>
+        </p:nvSpPr>
+        <p:spPr>
+          <a:xfrm>
+            <a:off x="5824728" y="2542032"/>
+            <a:ext cx="2779776" cy="1536192"/>
           </a:xfrm>
           <a:prstGeom prst="roundRect">
             <a:avLst/>
           </a:prstGeom>
           <a:solidFill>
-            <a:srgbClr val="0F2845"/>
-          </a:solidFill>
-          <a:ln>
-            <a:solidFill>
-              <a:srgbClr val="144A70"/>
-            </a:solidFill>
+            <a:srgbClr val="2B2B2B"/>
+          </a:solidFill>
+          <a:ln>
+            <a:noFill/>
           </a:ln>
         </p:spPr>
         <p:style>
@@ -27400,25 +27459,26 @@
           <a:lstStyle/>
           <a:p>
             <a:pPr algn="ctr"/>
-          </a:p>
-        </p:txBody>
-      </p:sp>
-      <p:sp>
-        <p:nvSpPr>
-          <p:cNvPr id="31" name="Rectangle 30"/>
-          <p:cNvSpPr/>
-          <p:nvPr/>
-        </p:nvSpPr>
-        <p:spPr>
-          <a:xfrm>
-            <a:off x="6986016" y="1993392"/>
-            <a:ext cx="2029968" cy="50292"/>
+            <a:endParaRPr/>
+          </a:p>
+        </p:txBody>
+      </p:sp>
+      <p:sp>
+        <p:nvSpPr>
+          <p:cNvPr id="32" name="Rectangle 31"/>
+          <p:cNvSpPr/>
+          <p:nvPr/>
+        </p:nvSpPr>
+        <p:spPr>
+          <a:xfrm>
+            <a:off x="5824728" y="2542032"/>
+            <a:ext cx="2779776" cy="45720"/>
           </a:xfrm>
           <a:prstGeom prst="rect">
             <a:avLst/>
           </a:prstGeom>
           <a:solidFill>
-            <a:srgbClr val="8B5CF6"/>
+            <a:srgbClr val="2E7D32"/>
           </a:solidFill>
           <a:ln>
             <a:noFill/>
@@ -27443,25 +27503,26 @@
           <a:lstStyle/>
           <a:p>
             <a:pPr algn="ctr"/>
-          </a:p>
-        </p:txBody>
-      </p:sp>
-      <p:sp>
-        <p:nvSpPr>
-          <p:cNvPr id="32" name="Oval 31"/>
-          <p:cNvSpPr/>
-          <p:nvPr/>
-        </p:nvSpPr>
-        <p:spPr>
-          <a:xfrm>
-            <a:off x="7095744" y="2176272"/>
-            <a:ext cx="384048" cy="384048"/>
+            <a:endParaRPr/>
+          </a:p>
+        </p:txBody>
+      </p:sp>
+      <p:sp>
+        <p:nvSpPr>
+          <p:cNvPr id="33" name="Oval 32"/>
+          <p:cNvSpPr/>
+          <p:nvPr/>
+        </p:nvSpPr>
+        <p:spPr>
+          <a:xfrm>
+            <a:off x="6629400" y="2706624"/>
+            <a:ext cx="621792" cy="621792"/>
           </a:xfrm>
           <a:prstGeom prst="ellipse">
             <a:avLst/>
           </a:prstGeom>
           <a:solidFill>
-            <a:srgbClr val="8B5CF6"/>
+            <a:srgbClr val="2E7D32"/>
           </a:solidFill>
           <a:ln>
             <a:noFill/>
@@ -27486,119 +27547,79 @@
           <a:lstStyle/>
           <a:p>
             <a:pPr algn="ctr"/>
-          </a:p>
-        </p:txBody>
-      </p:sp>
-      <p:sp>
-        <p:nvSpPr>
-          <p:cNvPr id="33" name="TextBox 32"/>
+            <a:endParaRPr/>
+          </a:p>
+        </p:txBody>
+      </p:sp>
+      <p:sp>
+        <p:nvSpPr>
+          <p:cNvPr id="34" name="TextBox 33"/>
           <p:cNvSpPr txBox="1"/>
           <p:nvPr/>
         </p:nvSpPr>
         <p:spPr>
           <a:xfrm>
-            <a:off x="7095744" y="2276856"/>
-            <a:ext cx="384048" cy="91440"/>
+            <a:off x="6629400" y="2706624"/>
+            <a:ext cx="621792" cy="621792"/>
           </a:xfrm>
           <a:prstGeom prst="rect">
             <a:avLst/>
           </a:prstGeom>
           <a:noFill/>
-        </p:spPr>
-        <p:txBody>
-          <a:bodyPr wrap="square" lIns="36576" rIns="36576" tIns="18288" bIns="18288">
+          <a:ln/>
+        </p:spPr>
+        <p:txBody>
+          <a:bodyPr wrap="square">
             <a:spAutoFit/>
           </a:bodyPr>
           <a:lstStyle/>
           <a:p>
             <a:pPr algn="ctr"/>
             <a:r>
-              <a:rPr sz="819" b="1" i="0">
+              <a:rPr sz="2200" b="1" i="0">
                 <a:solidFill>
                   <a:srgbClr val="FFFFFF"/>
                 </a:solidFill>
-                <a:latin typeface="Segoe UI"/>
+                <a:latin typeface="Arial"/>
               </a:rPr>
-              <a:t>04</a:t>
+              <a:t>✓</a:t>
             </a:r>
           </a:p>
         </p:txBody>
       </p:sp>
       <p:sp>
         <p:nvSpPr>
-          <p:cNvPr id="34" name="TextBox 33"/>
+          <p:cNvPr id="35" name="TextBox 34"/>
           <p:cNvSpPr txBox="1"/>
           <p:nvPr/>
         </p:nvSpPr>
         <p:spPr>
           <a:xfrm>
-            <a:off x="7552944" y="2103120"/>
-            <a:ext cx="1335024" cy="329184"/>
+            <a:off x="7287768" y="2743200"/>
+            <a:ext cx="1316736" cy="461665"/>
           </a:xfrm>
           <a:prstGeom prst="rect">
             <a:avLst/>
           </a:prstGeom>
           <a:noFill/>
-        </p:spPr>
-        <p:txBody>
-          <a:bodyPr wrap="square" lIns="36576" rIns="36576" tIns="18288" bIns="18288">
+          <a:ln/>
+        </p:spPr>
+        <p:txBody>
+          <a:bodyPr wrap="square">
             <a:spAutoFit/>
           </a:bodyPr>
           <a:lstStyle/>
           <a:p>
             <a:pPr algn="l"/>
             <a:r>
-              <a:rPr sz="1000" b="1" i="0">
+              <a:rPr sz="2400" b="1" i="0">
                 <a:solidFill>
-                  <a:srgbClr val="8B5CF6"/>
+                  <a:srgbClr val="2E7D32"/>
                 </a:solidFill>
-                <a:latin typeface="Segoe UI"/>
+                <a:latin typeface="Arial"/>
               </a:rPr>
-              <a:t>Agent Index Files</a:t>
+              <a:t>READY</a:t>
             </a:r>
-          </a:p>
-        </p:txBody>
-      </p:sp>
-      <p:sp>
-        <p:nvSpPr>
-          <p:cNvPr id="35" name="Rectangle 34"/>
-          <p:cNvSpPr/>
-          <p:nvPr/>
-        </p:nvSpPr>
-        <p:spPr>
-          <a:xfrm>
-            <a:off x="7132320" y="2615184"/>
-            <a:ext cx="1737360" cy="10972"/>
-          </a:xfrm>
-          <a:prstGeom prst="rect">
-            <a:avLst/>
-          </a:prstGeom>
-          <a:solidFill>
-            <a:srgbClr val="8B5CF6"/>
-          </a:solidFill>
-          <a:ln>
-            <a:noFill/>
-          </a:ln>
-        </p:spPr>
-        <p:style>
-          <a:lnRef idx="1">
-            <a:schemeClr val="accent1"/>
-          </a:lnRef>
-          <a:fillRef idx="3">
-            <a:schemeClr val="accent1"/>
-          </a:fillRef>
-          <a:effectRef idx="2">
-            <a:schemeClr val="accent1"/>
-          </a:effectRef>
-          <a:fontRef idx="minor">
-            <a:schemeClr val="lt1"/>
-          </a:fontRef>
-        </p:style>
-        <p:txBody>
-          <a:bodyPr rtlCol="0" anchor="ctr"/>
-          <a:lstStyle/>
-          <a:p>
-            <a:pPr algn="ctr"/>
           </a:p>
         </p:txBody>
       </p:sp>
@@ -27610,29 +27631,31 @@
         </p:nvSpPr>
         <p:spPr>
           <a:xfrm>
-            <a:off x="7132320" y="2743200"/>
-            <a:ext cx="1737360" cy="658368"/>
+            <a:off x="5879592" y="3337453"/>
+            <a:ext cx="2651760" cy="685800"/>
           </a:xfrm>
           <a:prstGeom prst="rect">
             <a:avLst/>
           </a:prstGeom>
           <a:noFill/>
-        </p:spPr>
-        <p:txBody>
-          <a:bodyPr wrap="square" lIns="36576" rIns="36576" tIns="18288" bIns="18288">
+          <a:ln/>
+        </p:spPr>
+        <p:txBody>
+          <a:bodyPr wrap="square">
             <a:spAutoFit/>
           </a:bodyPr>
           <a:lstStyle/>
           <a:p>
             <a:pPr algn="l"/>
             <a:r>
-              <a:rPr sz="819" b="0" i="0">
+              <a:rPr sz="1100" b="0" i="0">
                 <a:solidFill>
-                  <a:srgbClr val="B8D0EC"/>
+                  <a:srgbClr val="E8E8E8"/>
                 </a:solidFill>
-                <a:latin typeface="Segoe UI"/>
+                <a:latin typeface="Arial"/>
               </a:rPr>
-              <a:t>Agents create index files during execution to improve codebase structural understanding.</a:t>
+              <a:t>Evidence pack ready.
+Cleared for auditor review.</a:t>
             </a:r>
           </a:p>
         </p:txBody>
@@ -27645,19 +27668,17 @@
         </p:nvSpPr>
         <p:spPr>
           <a:xfrm>
-            <a:off x="347472" y="3913632"/>
-            <a:ext cx="2029968" cy="1664208"/>
+            <a:off x="5824728" y="4224528"/>
+            <a:ext cx="2779776" cy="1536192"/>
           </a:xfrm>
           <a:prstGeom prst="roundRect">
             <a:avLst/>
           </a:prstGeom>
           <a:solidFill>
-            <a:srgbClr val="0F2845"/>
-          </a:solidFill>
-          <a:ln>
-            <a:solidFill>
-              <a:srgbClr val="144A70"/>
-            </a:solidFill>
+            <a:srgbClr val="2B2B2B"/>
+          </a:solidFill>
+          <a:ln>
+            <a:noFill/>
           </a:ln>
         </p:spPr>
         <p:style>
@@ -27679,6 +27700,7 @@
           <a:lstStyle/>
           <a:p>
             <a:pPr algn="ctr"/>
+            <a:endParaRPr/>
           </a:p>
         </p:txBody>
       </p:sp>
@@ -27690,14 +27712,14 @@
         </p:nvSpPr>
         <p:spPr>
           <a:xfrm>
-            <a:off x="347472" y="3913632"/>
-            <a:ext cx="2029968" cy="50292"/>
+            <a:off x="5824728" y="4224528"/>
+            <a:ext cx="2779776" cy="45720"/>
           </a:xfrm>
           <a:prstGeom prst="rect">
             <a:avLst/>
           </a:prstGeom>
           <a:solidFill>
-            <a:srgbClr val="F5C518"/>
+            <a:srgbClr val="D71920"/>
           </a:solidFill>
           <a:ln>
             <a:noFill/>
@@ -27722,6 +27744,7 @@
           <a:lstStyle/>
           <a:p>
             <a:pPr algn="ctr"/>
+            <a:endParaRPr/>
           </a:p>
         </p:txBody>
       </p:sp>
@@ -27733,14 +27756,14 @@
         </p:nvSpPr>
         <p:spPr>
           <a:xfrm>
-            <a:off x="457200" y="4096512"/>
-            <a:ext cx="384048" cy="384048"/>
+            <a:off x="6629400" y="4389120"/>
+            <a:ext cx="621792" cy="621792"/>
           </a:xfrm>
           <a:prstGeom prst="ellipse">
             <a:avLst/>
           </a:prstGeom>
           <a:solidFill>
-            <a:srgbClr val="F5C518"/>
+            <a:srgbClr val="D71920"/>
           </a:solidFill>
           <a:ln>
             <a:noFill/>
@@ -27765,6 +27788,7 @@
           <a:lstStyle/>
           <a:p>
             <a:pPr algn="ctr"/>
+            <a:endParaRPr/>
           </a:p>
         </p:txBody>
       </p:sp>
@@ -27776,29 +27800,30 @@
         </p:nvSpPr>
         <p:spPr>
           <a:xfrm>
-            <a:off x="457200" y="4197096"/>
-            <a:ext cx="384048" cy="91440"/>
+            <a:off x="6629400" y="4389120"/>
+            <a:ext cx="621792" cy="621792"/>
           </a:xfrm>
           <a:prstGeom prst="rect">
             <a:avLst/>
           </a:prstGeom>
           <a:noFill/>
-        </p:spPr>
-        <p:txBody>
-          <a:bodyPr wrap="square" lIns="36576" rIns="36576" tIns="18288" bIns="18288">
+          <a:ln/>
+        </p:spPr>
+        <p:txBody>
+          <a:bodyPr wrap="square">
             <a:spAutoFit/>
           </a:bodyPr>
           <a:lstStyle/>
           <a:p>
             <a:pPr algn="ctr"/>
             <a:r>
-              <a:rPr sz="819" b="1" i="0">
+              <a:rPr sz="2200" b="1" i="0">
                 <a:solidFill>
                   <a:srgbClr val="FFFFFF"/>
                 </a:solidFill>
-                <a:latin typeface="Segoe UI"/>
+                <a:latin typeface="Arial"/>
               </a:rPr>
-              <a:t>05</a:t>
+              <a:t>✕</a:t>
             </a:r>
           </a:p>
         </p:txBody>
@@ -27811,132 +27836,90 @@
         </p:nvSpPr>
         <p:spPr>
           <a:xfrm>
-            <a:off x="914400" y="4023360"/>
-            <a:ext cx="1335024" cy="329184"/>
+            <a:off x="7287768" y="4425696"/>
+            <a:ext cx="1417320" cy="384048"/>
           </a:xfrm>
           <a:prstGeom prst="rect">
             <a:avLst/>
           </a:prstGeom>
           <a:noFill/>
-        </p:spPr>
-        <p:txBody>
-          <a:bodyPr wrap="square" lIns="36576" rIns="36576" tIns="18288" bIns="18288">
+          <a:ln/>
+        </p:spPr>
+        <p:txBody>
+          <a:bodyPr wrap="square">
             <a:spAutoFit/>
           </a:bodyPr>
           <a:lstStyle/>
           <a:p>
             <a:pPr algn="l"/>
             <a:r>
-              <a:rPr sz="1000" b="1" i="0">
+              <a:rPr sz="1800" b="1" i="0">
                 <a:solidFill>
-                  <a:srgbClr val="F5C518"/>
+                  <a:srgbClr val="D71920"/>
                 </a:solidFill>
-                <a:latin typeface="Segoe UI"/>
+                <a:latin typeface="Arial"/>
               </a:rPr>
-              <a:t>Certification Module</a:t>
+              <a:t>NOT READY</a:t>
             </a:r>
           </a:p>
         </p:txBody>
       </p:sp>
       <p:sp>
         <p:nvSpPr>
-          <p:cNvPr id="42" name="Rectangle 41"/>
-          <p:cNvSpPr/>
-          <p:nvPr/>
-        </p:nvSpPr>
-        <p:spPr>
-          <a:xfrm>
-            <a:off x="493776" y="4535424"/>
-            <a:ext cx="1737360" cy="10972"/>
+          <p:cNvPr id="42" name="TextBox 41"/>
+          <p:cNvSpPr txBox="1"/>
+          <p:nvPr/>
+        </p:nvSpPr>
+        <p:spPr>
+          <a:xfrm>
+            <a:off x="5888736" y="5060357"/>
+            <a:ext cx="2651760" cy="685800"/>
           </a:xfrm>
           <a:prstGeom prst="rect">
             <a:avLst/>
           </a:prstGeom>
-          <a:solidFill>
-            <a:srgbClr val="F5C518"/>
-          </a:solidFill>
-          <a:ln>
-            <a:noFill/>
-          </a:ln>
-        </p:spPr>
-        <p:style>
-          <a:lnRef idx="1">
-            <a:schemeClr val="accent1"/>
-          </a:lnRef>
-          <a:fillRef idx="3">
-            <a:schemeClr val="accent1"/>
-          </a:fillRef>
-          <a:effectRef idx="2">
-            <a:schemeClr val="accent1"/>
-          </a:effectRef>
-          <a:fontRef idx="minor">
-            <a:schemeClr val="lt1"/>
-          </a:fontRef>
-        </p:style>
-        <p:txBody>
-          <a:bodyPr rtlCol="0" anchor="ctr"/>
-          <a:lstStyle/>
-          <a:p>
-            <a:pPr algn="ctr"/>
-          </a:p>
-        </p:txBody>
-      </p:sp>
-      <p:sp>
-        <p:nvSpPr>
-          <p:cNvPr id="43" name="TextBox 42"/>
-          <p:cNvSpPr txBox="1"/>
-          <p:nvPr/>
-        </p:nvSpPr>
-        <p:spPr>
-          <a:xfrm>
-            <a:off x="493776" y="4663440"/>
-            <a:ext cx="1737360" cy="658368"/>
-          </a:xfrm>
-          <a:prstGeom prst="rect">
-            <a:avLst/>
-          </a:prstGeom>
           <a:noFill/>
-        </p:spPr>
-        <p:txBody>
-          <a:bodyPr wrap="square" lIns="36576" rIns="36576" tIns="18288" bIns="18288">
+          <a:ln/>
+        </p:spPr>
+        <p:txBody>
+          <a:bodyPr wrap="square">
             <a:spAutoFit/>
           </a:bodyPr>
           <a:lstStyle/>
           <a:p>
             <a:pPr algn="l"/>
             <a:r>
-              <a:rPr sz="819" b="0" i="0">
+              <a:rPr sz="1100" b="0" i="0">
                 <a:solidFill>
-                  <a:srgbClr val="B8D0EC"/>
+                  <a:srgbClr val="E8E8E8"/>
                 </a:solidFill>
-                <a:latin typeface="Segoe UI"/>
+                <a:latin typeface="Arial"/>
               </a:rPr>
-              <a:t>Pluggable framework extendible beyond STQC to certifications such as DO178C.</a:t>
+              <a:t>Guideline gaps found.
+Create Jira stories.</a:t>
             </a:r>
           </a:p>
         </p:txBody>
       </p:sp>
       <p:sp>
         <p:nvSpPr>
-          <p:cNvPr id="44" name="Rounded Rectangle 43"/>
-          <p:cNvSpPr/>
-          <p:nvPr/>
-        </p:nvSpPr>
-        <p:spPr>
-          <a:xfrm>
-            <a:off x="2560320" y="3913632"/>
-            <a:ext cx="2029968" cy="1664208"/>
-          </a:xfrm>
-          <a:prstGeom prst="roundRect">
-            <a:avLst/>
-          </a:prstGeom>
-          <a:solidFill>
-            <a:srgbClr val="0F2845"/>
-          </a:solidFill>
-          <a:ln>
-            <a:solidFill>
-              <a:srgbClr val="144A70"/>
-            </a:solidFill>
+          <p:cNvPr id="43" name="Rectangle 42"/>
+          <p:cNvSpPr/>
+          <p:nvPr/>
+        </p:nvSpPr>
+        <p:spPr>
+          <a:xfrm>
+            <a:off x="0" y="6473952"/>
+            <a:ext cx="9144000" cy="384048"/>
+          </a:xfrm>
+          <a:prstGeom prst="rect">
+            <a:avLst/>
+          </a:prstGeom>
+          <a:solidFill>
+            <a:srgbClr val="333333"/>
+          </a:solidFill>
+          <a:ln>
+            <a:noFill/>
           </a:ln>
         </p:spPr>
         <p:style>
@@ -27958,140 +27941,100 @@
           <a:lstStyle/>
           <a:p>
             <a:pPr algn="ctr"/>
-          </a:p>
-        </p:txBody>
-      </p:sp>
-      <p:sp>
-        <p:nvSpPr>
-          <p:cNvPr id="45" name="Rectangle 44"/>
-          <p:cNvSpPr/>
-          <p:nvPr/>
-        </p:nvSpPr>
-        <p:spPr>
-          <a:xfrm>
-            <a:off x="2560320" y="3913632"/>
-            <a:ext cx="2029968" cy="50292"/>
+            <a:endParaRPr/>
+          </a:p>
+        </p:txBody>
+      </p:sp>
+      <p:sp>
+        <p:nvSpPr>
+          <p:cNvPr id="44" name="TextBox 43"/>
+          <p:cNvSpPr txBox="1"/>
+          <p:nvPr/>
+        </p:nvSpPr>
+        <p:spPr>
+          <a:xfrm>
+            <a:off x="8321040" y="6510528"/>
+            <a:ext cx="731520" cy="274320"/>
           </a:xfrm>
           <a:prstGeom prst="rect">
             <a:avLst/>
           </a:prstGeom>
-          <a:solidFill>
-            <a:srgbClr val="00D48A"/>
-          </a:solidFill>
-          <a:ln>
-            <a:noFill/>
-          </a:ln>
-        </p:spPr>
-        <p:style>
-          <a:lnRef idx="1">
-            <a:schemeClr val="accent1"/>
-          </a:lnRef>
-          <a:fillRef idx="3">
-            <a:schemeClr val="accent1"/>
-          </a:fillRef>
-          <a:effectRef idx="2">
-            <a:schemeClr val="accent1"/>
-          </a:effectRef>
-          <a:fontRef idx="minor">
-            <a:schemeClr val="lt1"/>
-          </a:fontRef>
-        </p:style>
-        <p:txBody>
-          <a:bodyPr rtlCol="0" anchor="ctr"/>
-          <a:lstStyle/>
-          <a:p>
-            <a:pPr algn="ctr"/>
-          </a:p>
-        </p:txBody>
-      </p:sp>
-      <p:sp>
-        <p:nvSpPr>
-          <p:cNvPr id="46" name="Oval 45"/>
-          <p:cNvSpPr/>
-          <p:nvPr/>
-        </p:nvSpPr>
-        <p:spPr>
-          <a:xfrm>
-            <a:off x="2670048" y="4096512"/>
-            <a:ext cx="384048" cy="384048"/>
-          </a:xfrm>
-          <a:prstGeom prst="ellipse">
-            <a:avLst/>
-          </a:prstGeom>
-          <a:solidFill>
-            <a:srgbClr val="00D48A"/>
-          </a:solidFill>
-          <a:ln>
-            <a:noFill/>
-          </a:ln>
-        </p:spPr>
-        <p:style>
-          <a:lnRef idx="1">
-            <a:schemeClr val="accent1"/>
-          </a:lnRef>
-          <a:fillRef idx="3">
-            <a:schemeClr val="accent1"/>
-          </a:fillRef>
-          <a:effectRef idx="2">
-            <a:schemeClr val="accent1"/>
-          </a:effectRef>
-          <a:fontRef idx="minor">
-            <a:schemeClr val="lt1"/>
-          </a:fontRef>
-        </p:style>
-        <p:txBody>
-          <a:bodyPr rtlCol="0" anchor="ctr"/>
-          <a:lstStyle/>
-          <a:p>
-            <a:pPr algn="ctr"/>
-          </a:p>
-        </p:txBody>
-      </p:sp>
-      <p:sp>
-        <p:nvSpPr>
-          <p:cNvPr id="47" name="TextBox 46"/>
-          <p:cNvSpPr txBox="1"/>
-          <p:nvPr/>
-        </p:nvSpPr>
-        <p:spPr>
-          <a:xfrm>
-            <a:off x="2670048" y="4197096"/>
-            <a:ext cx="384048" cy="91440"/>
-          </a:xfrm>
-          <a:prstGeom prst="rect">
-            <a:avLst/>
-          </a:prstGeom>
           <a:noFill/>
-        </p:spPr>
-        <p:txBody>
-          <a:bodyPr wrap="square" lIns="36576" rIns="36576" tIns="18288" bIns="18288">
+          <a:ln/>
+        </p:spPr>
+        <p:txBody>
+          <a:bodyPr wrap="square">
             <a:spAutoFit/>
           </a:bodyPr>
           <a:lstStyle/>
           <a:p>
+            <a:pPr algn="r"/>
+            <a:r>
+              <a:rPr sz="900" b="0" i="0">
+                <a:solidFill>
+                  <a:srgbClr val="B8B8B8"/>
+                </a:solidFill>
+                <a:latin typeface="Arial"/>
+              </a:rPr>
+              <a:t>8  /  9</a:t>
+            </a:r>
+          </a:p>
+        </p:txBody>
+      </p:sp>
+      <p:sp>
+        <p:nvSpPr>
+          <p:cNvPr id="45" name="Rectangle 44"/>
+          <p:cNvSpPr/>
+          <p:nvPr/>
+        </p:nvSpPr>
+        <p:spPr>
+          <a:xfrm>
+            <a:off x="0" y="0"/>
+            <a:ext cx="9144000" cy="32004"/>
+          </a:xfrm>
+          <a:prstGeom prst="rect">
+            <a:avLst/>
+          </a:prstGeom>
+          <a:solidFill>
+            <a:srgbClr val="D71920"/>
+          </a:solidFill>
+          <a:ln>
+            <a:noFill/>
+          </a:ln>
+        </p:spPr>
+        <p:style>
+          <a:lnRef idx="1">
+            <a:schemeClr val="accent1"/>
+          </a:lnRef>
+          <a:fillRef idx="3">
+            <a:schemeClr val="accent1"/>
+          </a:fillRef>
+          <a:effectRef idx="2">
+            <a:schemeClr val="accent1"/>
+          </a:effectRef>
+          <a:fontRef idx="minor">
+            <a:schemeClr val="lt1"/>
+          </a:fontRef>
+        </p:style>
+        <p:txBody>
+          <a:bodyPr rtlCol="0" anchor="ctr"/>
+          <a:lstStyle/>
+          <a:p>
             <a:pPr algn="ctr"/>
-            <a:r>
-              <a:rPr sz="819" b="1" i="0">
-                <a:solidFill>
-                  <a:srgbClr val="FFFFFF"/>
-                </a:solidFill>
-                <a:latin typeface="Segoe UI"/>
-              </a:rPr>
-              <a:t>06</a:t>
-            </a:r>
-          </a:p>
-        </p:txBody>
-      </p:sp>
-      <p:sp>
-        <p:nvSpPr>
-          <p:cNvPr id="48" name="TextBox 47"/>
+            <a:endParaRPr/>
+          </a:p>
+        </p:txBody>
+      </p:sp>
+      <p:sp>
+        <p:nvSpPr>
+          <p:cNvPr id="46" name="TextBox 45"/>
           <p:cNvSpPr txBox="1"/>
           <p:nvPr/>
         </p:nvSpPr>
         <p:spPr>
           <a:xfrm>
-            <a:off x="3127248" y="4023360"/>
-            <a:ext cx="1335024" cy="329184"/>
+            <a:off x="7699248" y="118872"/>
+            <a:ext cx="1170432" cy="201168"/>
           </a:xfrm>
           <a:prstGeom prst="rect">
             <a:avLst/>
@@ -28099,888 +28042,18 @@
           <a:noFill/>
         </p:spPr>
         <p:txBody>
-          <a:bodyPr wrap="square" lIns="36576" rIns="36576" tIns="18288" bIns="18288">
+          <a:bodyPr wrap="none">
             <a:spAutoFit/>
           </a:bodyPr>
           <a:lstStyle/>
           <a:p>
-            <a:pPr algn="l"/>
-            <a:r>
-              <a:rPr sz="1000" b="1" i="0">
-                <a:solidFill>
-                  <a:srgbClr val="00D48A"/>
-                </a:solidFill>
-                <a:latin typeface="Segoe UI"/>
-              </a:rPr>
-              <a:t>STQC Evidence Docs</a:t>
-            </a:r>
-          </a:p>
-        </p:txBody>
-      </p:sp>
-      <p:sp>
-        <p:nvSpPr>
-          <p:cNvPr id="49" name="Rectangle 48"/>
-          <p:cNvSpPr/>
-          <p:nvPr/>
-        </p:nvSpPr>
-        <p:spPr>
-          <a:xfrm>
-            <a:off x="2706624" y="4535424"/>
-            <a:ext cx="1737360" cy="10972"/>
-          </a:xfrm>
-          <a:prstGeom prst="rect">
-            <a:avLst/>
-          </a:prstGeom>
-          <a:solidFill>
-            <a:srgbClr val="00D48A"/>
-          </a:solidFill>
-          <a:ln>
-            <a:noFill/>
-          </a:ln>
-        </p:spPr>
-        <p:style>
-          <a:lnRef idx="1">
-            <a:schemeClr val="accent1"/>
-          </a:lnRef>
-          <a:fillRef idx="3">
-            <a:schemeClr val="accent1"/>
-          </a:fillRef>
-          <a:effectRef idx="2">
-            <a:schemeClr val="accent1"/>
-          </a:effectRef>
-          <a:fontRef idx="minor">
-            <a:schemeClr val="lt1"/>
-          </a:fontRef>
-        </p:style>
-        <p:txBody>
-          <a:bodyPr rtlCol="0" anchor="ctr"/>
-          <a:lstStyle/>
-          <a:p>
-            <a:pPr algn="ctr"/>
-          </a:p>
-        </p:txBody>
-      </p:sp>
-      <p:sp>
-        <p:nvSpPr>
-          <p:cNvPr id="50" name="TextBox 49"/>
-          <p:cNvSpPr txBox="1"/>
-          <p:nvPr/>
-        </p:nvSpPr>
-        <p:spPr>
-          <a:xfrm>
-            <a:off x="2706624" y="4663440"/>
-            <a:ext cx="1737360" cy="658368"/>
-          </a:xfrm>
-          <a:prstGeom prst="rect">
-            <a:avLst/>
-          </a:prstGeom>
-          <a:noFill/>
-        </p:spPr>
-        <p:txBody>
-          <a:bodyPr wrap="square" lIns="36576" rIns="36576" tIns="18288" bIns="18288">
-            <a:spAutoFit/>
-          </a:bodyPr>
-          <a:lstStyle/>
-          <a:p>
-            <a:pPr algn="l"/>
-            <a:r>
-              <a:rPr sz="819" b="0" i="0">
-                <a:solidFill>
-                  <a:srgbClr val="B8D0EC"/>
-                </a:solidFill>
-                <a:latin typeface="Segoe UI"/>
-              </a:rPr>
-              <a:t>Reads the codebase and produces evidence in ready-to-use document format.</a:t>
-            </a:r>
-          </a:p>
-        </p:txBody>
-      </p:sp>
-      <p:sp>
-        <p:nvSpPr>
-          <p:cNvPr id="51" name="Rounded Rectangle 50"/>
-          <p:cNvSpPr/>
-          <p:nvPr/>
-        </p:nvSpPr>
-        <p:spPr>
-          <a:xfrm>
-            <a:off x="4773168" y="3913632"/>
-            <a:ext cx="2029968" cy="1664208"/>
-          </a:xfrm>
-          <a:prstGeom prst="roundRect">
-            <a:avLst/>
-          </a:prstGeom>
-          <a:solidFill>
-            <a:srgbClr val="0F2845"/>
-          </a:solidFill>
-          <a:ln>
-            <a:solidFill>
-              <a:srgbClr val="144A70"/>
-            </a:solidFill>
-          </a:ln>
-        </p:spPr>
-        <p:style>
-          <a:lnRef idx="1">
-            <a:schemeClr val="accent1"/>
-          </a:lnRef>
-          <a:fillRef idx="3">
-            <a:schemeClr val="accent1"/>
-          </a:fillRef>
-          <a:effectRef idx="2">
-            <a:schemeClr val="accent1"/>
-          </a:effectRef>
-          <a:fontRef idx="minor">
-            <a:schemeClr val="lt1"/>
-          </a:fontRef>
-        </p:style>
-        <p:txBody>
-          <a:bodyPr rtlCol="0" anchor="ctr"/>
-          <a:lstStyle/>
-          <a:p>
-            <a:pPr algn="ctr"/>
-          </a:p>
-        </p:txBody>
-      </p:sp>
-      <p:sp>
-        <p:nvSpPr>
-          <p:cNvPr id="52" name="Rectangle 51"/>
-          <p:cNvSpPr/>
-          <p:nvPr/>
-        </p:nvSpPr>
-        <p:spPr>
-          <a:xfrm>
-            <a:off x="4773168" y="3913632"/>
-            <a:ext cx="2029968" cy="50292"/>
-          </a:xfrm>
-          <a:prstGeom prst="rect">
-            <a:avLst/>
-          </a:prstGeom>
-          <a:solidFill>
-            <a:srgbClr val="FF8C00"/>
-          </a:solidFill>
-          <a:ln>
-            <a:noFill/>
-          </a:ln>
-        </p:spPr>
-        <p:style>
-          <a:lnRef idx="1">
-            <a:schemeClr val="accent1"/>
-          </a:lnRef>
-          <a:fillRef idx="3">
-            <a:schemeClr val="accent1"/>
-          </a:fillRef>
-          <a:effectRef idx="2">
-            <a:schemeClr val="accent1"/>
-          </a:effectRef>
-          <a:fontRef idx="minor">
-            <a:schemeClr val="lt1"/>
-          </a:fontRef>
-        </p:style>
-        <p:txBody>
-          <a:bodyPr rtlCol="0" anchor="ctr"/>
-          <a:lstStyle/>
-          <a:p>
-            <a:pPr algn="ctr"/>
-          </a:p>
-        </p:txBody>
-      </p:sp>
-      <p:sp>
-        <p:nvSpPr>
-          <p:cNvPr id="53" name="Oval 52"/>
-          <p:cNvSpPr/>
-          <p:nvPr/>
-        </p:nvSpPr>
-        <p:spPr>
-          <a:xfrm>
-            <a:off x="4882896" y="4096512"/>
-            <a:ext cx="384048" cy="384048"/>
-          </a:xfrm>
-          <a:prstGeom prst="ellipse">
-            <a:avLst/>
-          </a:prstGeom>
-          <a:solidFill>
-            <a:srgbClr val="FF8C00"/>
-          </a:solidFill>
-          <a:ln>
-            <a:noFill/>
-          </a:ln>
-        </p:spPr>
-        <p:style>
-          <a:lnRef idx="1">
-            <a:schemeClr val="accent1"/>
-          </a:lnRef>
-          <a:fillRef idx="3">
-            <a:schemeClr val="accent1"/>
-          </a:fillRef>
-          <a:effectRef idx="2">
-            <a:schemeClr val="accent1"/>
-          </a:effectRef>
-          <a:fontRef idx="minor">
-            <a:schemeClr val="lt1"/>
-          </a:fontRef>
-        </p:style>
-        <p:txBody>
-          <a:bodyPr rtlCol="0" anchor="ctr"/>
-          <a:lstStyle/>
-          <a:p>
-            <a:pPr algn="ctr"/>
-          </a:p>
-        </p:txBody>
-      </p:sp>
-      <p:sp>
-        <p:nvSpPr>
-          <p:cNvPr id="54" name="TextBox 53"/>
-          <p:cNvSpPr txBox="1"/>
-          <p:nvPr/>
-        </p:nvSpPr>
-        <p:spPr>
-          <a:xfrm>
-            <a:off x="4882896" y="4197096"/>
-            <a:ext cx="384048" cy="91440"/>
-          </a:xfrm>
-          <a:prstGeom prst="rect">
-            <a:avLst/>
-          </a:prstGeom>
-          <a:noFill/>
-        </p:spPr>
-        <p:txBody>
-          <a:bodyPr wrap="square" lIns="36576" rIns="36576" tIns="18288" bIns="18288">
-            <a:spAutoFit/>
-          </a:bodyPr>
-          <a:lstStyle/>
-          <a:p>
-            <a:pPr algn="ctr"/>
-            <a:r>
-              <a:rPr sz="819" b="1" i="0">
-                <a:solidFill>
-                  <a:srgbClr val="FFFFFF"/>
-                </a:solidFill>
-                <a:latin typeface="Segoe UI"/>
-              </a:rPr>
-              <a:t>07</a:t>
-            </a:r>
-          </a:p>
-        </p:txBody>
-      </p:sp>
-      <p:sp>
-        <p:nvSpPr>
-          <p:cNvPr id="55" name="TextBox 54"/>
-          <p:cNvSpPr txBox="1"/>
-          <p:nvPr/>
-        </p:nvSpPr>
-        <p:spPr>
-          <a:xfrm>
-            <a:off x="5340096" y="4023360"/>
-            <a:ext cx="1335024" cy="329184"/>
-          </a:xfrm>
-          <a:prstGeom prst="rect">
-            <a:avLst/>
-          </a:prstGeom>
-          <a:noFill/>
-        </p:spPr>
-        <p:txBody>
-          <a:bodyPr wrap="square" lIns="36576" rIns="36576" tIns="18288" bIns="18288">
-            <a:spAutoFit/>
-          </a:bodyPr>
-          <a:lstStyle/>
-          <a:p>
-            <a:pPr algn="l"/>
-            <a:r>
-              <a:rPr sz="1000" b="1" i="0">
-                <a:solidFill>
-                  <a:srgbClr val="FF8C00"/>
-                </a:solidFill>
-                <a:latin typeface="Segoe UI"/>
-              </a:rPr>
-              <a:t>TCF + Compliance</a:t>
-            </a:r>
-          </a:p>
-        </p:txBody>
-      </p:sp>
-      <p:sp>
-        <p:nvSpPr>
-          <p:cNvPr id="56" name="Rectangle 55"/>
-          <p:cNvSpPr/>
-          <p:nvPr/>
-        </p:nvSpPr>
-        <p:spPr>
-          <a:xfrm>
-            <a:off x="4919472" y="4535424"/>
-            <a:ext cx="1737360" cy="10972"/>
-          </a:xfrm>
-          <a:prstGeom prst="rect">
-            <a:avLst/>
-          </a:prstGeom>
-          <a:solidFill>
-            <a:srgbClr val="FF8C00"/>
-          </a:solidFill>
-          <a:ln>
-            <a:noFill/>
-          </a:ln>
-        </p:spPr>
-        <p:style>
-          <a:lnRef idx="1">
-            <a:schemeClr val="accent1"/>
-          </a:lnRef>
-          <a:fillRef idx="3">
-            <a:schemeClr val="accent1"/>
-          </a:fillRef>
-          <a:effectRef idx="2">
-            <a:schemeClr val="accent1"/>
-          </a:effectRef>
-          <a:fontRef idx="minor">
-            <a:schemeClr val="lt1"/>
-          </a:fontRef>
-        </p:style>
-        <p:txBody>
-          <a:bodyPr rtlCol="0" anchor="ctr"/>
-          <a:lstStyle/>
-          <a:p>
-            <a:pPr algn="ctr"/>
-          </a:p>
-        </p:txBody>
-      </p:sp>
-      <p:sp>
-        <p:nvSpPr>
-          <p:cNvPr id="57" name="TextBox 56"/>
-          <p:cNvSpPr txBox="1"/>
-          <p:nvPr/>
-        </p:nvSpPr>
-        <p:spPr>
-          <a:xfrm>
-            <a:off x="4919472" y="4663440"/>
-            <a:ext cx="1737360" cy="658368"/>
-          </a:xfrm>
-          <a:prstGeom prst="rect">
-            <a:avLst/>
-          </a:prstGeom>
-          <a:noFill/>
-        </p:spPr>
-        <p:txBody>
-          <a:bodyPr wrap="square" lIns="36576" rIns="36576" tIns="18288" bIns="18288">
-            <a:spAutoFit/>
-          </a:bodyPr>
-          <a:lstStyle/>
-          <a:p>
-            <a:pPr algn="l"/>
-            <a:r>
-              <a:rPr sz="819" b="0" i="0">
-                <a:solidFill>
-                  <a:srgbClr val="B8D0EC"/>
-                </a:solidFill>
-                <a:latin typeface="Segoe UI"/>
-              </a:rPr>
-              <a:t>Generates TCF and validates collected evidence against compliance expectations.</a:t>
-            </a:r>
-          </a:p>
-        </p:txBody>
-      </p:sp>
-      <p:sp>
-        <p:nvSpPr>
-          <p:cNvPr id="58" name="Rounded Rectangle 57"/>
-          <p:cNvSpPr/>
-          <p:nvPr/>
-        </p:nvSpPr>
-        <p:spPr>
-          <a:xfrm>
-            <a:off x="6986016" y="3913632"/>
-            <a:ext cx="2029968" cy="1664208"/>
-          </a:xfrm>
-          <a:prstGeom prst="roundRect">
-            <a:avLst/>
-          </a:prstGeom>
-          <a:solidFill>
-            <a:srgbClr val="0F2845"/>
-          </a:solidFill>
-          <a:ln>
-            <a:solidFill>
-              <a:srgbClr val="144A70"/>
-            </a:solidFill>
-          </a:ln>
-        </p:spPr>
-        <p:style>
-          <a:lnRef idx="1">
-            <a:schemeClr val="accent1"/>
-          </a:lnRef>
-          <a:fillRef idx="3">
-            <a:schemeClr val="accent1"/>
-          </a:fillRef>
-          <a:effectRef idx="2">
-            <a:schemeClr val="accent1"/>
-          </a:effectRef>
-          <a:fontRef idx="minor">
-            <a:schemeClr val="lt1"/>
-          </a:fontRef>
-        </p:style>
-        <p:txBody>
-          <a:bodyPr rtlCol="0" anchor="ctr"/>
-          <a:lstStyle/>
-          <a:p>
-            <a:pPr algn="ctr"/>
-          </a:p>
-        </p:txBody>
-      </p:sp>
-      <p:sp>
-        <p:nvSpPr>
-          <p:cNvPr id="59" name="Rectangle 58"/>
-          <p:cNvSpPr/>
-          <p:nvPr/>
-        </p:nvSpPr>
-        <p:spPr>
-          <a:xfrm>
-            <a:off x="6986016" y="3913632"/>
-            <a:ext cx="2029968" cy="50292"/>
-          </a:xfrm>
-          <a:prstGeom prst="rect">
-            <a:avLst/>
-          </a:prstGeom>
-          <a:solidFill>
-            <a:srgbClr val="FF3A3A"/>
-          </a:solidFill>
-          <a:ln>
-            <a:noFill/>
-          </a:ln>
-        </p:spPr>
-        <p:style>
-          <a:lnRef idx="1">
-            <a:schemeClr val="accent1"/>
-          </a:lnRef>
-          <a:fillRef idx="3">
-            <a:schemeClr val="accent1"/>
-          </a:fillRef>
-          <a:effectRef idx="2">
-            <a:schemeClr val="accent1"/>
-          </a:effectRef>
-          <a:fontRef idx="minor">
-            <a:schemeClr val="lt1"/>
-          </a:fontRef>
-        </p:style>
-        <p:txBody>
-          <a:bodyPr rtlCol="0" anchor="ctr"/>
-          <a:lstStyle/>
-          <a:p>
-            <a:pPr algn="ctr"/>
-          </a:p>
-        </p:txBody>
-      </p:sp>
-      <p:sp>
-        <p:nvSpPr>
-          <p:cNvPr id="60" name="Oval 59"/>
-          <p:cNvSpPr/>
-          <p:nvPr/>
-        </p:nvSpPr>
-        <p:spPr>
-          <a:xfrm>
-            <a:off x="7095744" y="4096512"/>
-            <a:ext cx="384048" cy="384048"/>
-          </a:xfrm>
-          <a:prstGeom prst="ellipse">
-            <a:avLst/>
-          </a:prstGeom>
-          <a:solidFill>
-            <a:srgbClr val="FF3A3A"/>
-          </a:solidFill>
-          <a:ln>
-            <a:noFill/>
-          </a:ln>
-        </p:spPr>
-        <p:style>
-          <a:lnRef idx="1">
-            <a:schemeClr val="accent1"/>
-          </a:lnRef>
-          <a:fillRef idx="3">
-            <a:schemeClr val="accent1"/>
-          </a:fillRef>
-          <a:effectRef idx="2">
-            <a:schemeClr val="accent1"/>
-          </a:effectRef>
-          <a:fontRef idx="minor">
-            <a:schemeClr val="lt1"/>
-          </a:fontRef>
-        </p:style>
-        <p:txBody>
-          <a:bodyPr rtlCol="0" anchor="ctr"/>
-          <a:lstStyle/>
-          <a:p>
-            <a:pPr algn="ctr"/>
-          </a:p>
-        </p:txBody>
-      </p:sp>
-      <p:sp>
-        <p:nvSpPr>
-          <p:cNvPr id="61" name="TextBox 60"/>
-          <p:cNvSpPr txBox="1"/>
-          <p:nvPr/>
-        </p:nvSpPr>
-        <p:spPr>
-          <a:xfrm>
-            <a:off x="7095744" y="4197096"/>
-            <a:ext cx="384048" cy="91440"/>
-          </a:xfrm>
-          <a:prstGeom prst="rect">
-            <a:avLst/>
-          </a:prstGeom>
-          <a:noFill/>
-        </p:spPr>
-        <p:txBody>
-          <a:bodyPr wrap="square" lIns="36576" rIns="36576" tIns="18288" bIns="18288">
-            <a:spAutoFit/>
-          </a:bodyPr>
-          <a:lstStyle/>
-          <a:p>
-            <a:pPr algn="ctr"/>
-            <a:r>
-              <a:rPr sz="819" b="1" i="0">
-                <a:solidFill>
-                  <a:srgbClr val="FFFFFF"/>
-                </a:solidFill>
-                <a:latin typeface="Segoe UI"/>
-              </a:rPr>
-              <a:t>08</a:t>
-            </a:r>
-          </a:p>
-        </p:txBody>
-      </p:sp>
-      <p:sp>
-        <p:nvSpPr>
-          <p:cNvPr id="62" name="TextBox 61"/>
-          <p:cNvSpPr txBox="1"/>
-          <p:nvPr/>
-        </p:nvSpPr>
-        <p:spPr>
-          <a:xfrm>
-            <a:off x="7552944" y="4023360"/>
-            <a:ext cx="1335024" cy="329184"/>
-          </a:xfrm>
-          <a:prstGeom prst="rect">
-            <a:avLst/>
-          </a:prstGeom>
-          <a:noFill/>
-        </p:spPr>
-        <p:txBody>
-          <a:bodyPr wrap="square" lIns="36576" rIns="36576" tIns="18288" bIns="18288">
-            <a:spAutoFit/>
-          </a:bodyPr>
-          <a:lstStyle/>
-          <a:p>
-            <a:pPr algn="l"/>
-            <a:r>
-              <a:rPr sz="1000" b="1" i="0">
-                <a:solidFill>
-                  <a:srgbClr val="FF3A3A"/>
-                </a:solidFill>
-                <a:latin typeface="Segoe UI"/>
-              </a:rPr>
-              <a:t>First-Time Setup</a:t>
-            </a:r>
-          </a:p>
-        </p:txBody>
-      </p:sp>
-      <p:sp>
-        <p:nvSpPr>
-          <p:cNvPr id="63" name="Rectangle 62"/>
-          <p:cNvSpPr/>
-          <p:nvPr/>
-        </p:nvSpPr>
-        <p:spPr>
-          <a:xfrm>
-            <a:off x="7132320" y="4535424"/>
-            <a:ext cx="1737360" cy="10972"/>
-          </a:xfrm>
-          <a:prstGeom prst="rect">
-            <a:avLst/>
-          </a:prstGeom>
-          <a:solidFill>
-            <a:srgbClr val="FF3A3A"/>
-          </a:solidFill>
-          <a:ln>
-            <a:noFill/>
-          </a:ln>
-        </p:spPr>
-        <p:style>
-          <a:lnRef idx="1">
-            <a:schemeClr val="accent1"/>
-          </a:lnRef>
-          <a:fillRef idx="3">
-            <a:schemeClr val="accent1"/>
-          </a:fillRef>
-          <a:effectRef idx="2">
-            <a:schemeClr val="accent1"/>
-          </a:effectRef>
-          <a:fontRef idx="minor">
-            <a:schemeClr val="lt1"/>
-          </a:fontRef>
-        </p:style>
-        <p:txBody>
-          <a:bodyPr rtlCol="0" anchor="ctr"/>
-          <a:lstStyle/>
-          <a:p>
-            <a:pPr algn="ctr"/>
-          </a:p>
-        </p:txBody>
-      </p:sp>
-      <p:sp>
-        <p:nvSpPr>
-          <p:cNvPr id="64" name="TextBox 63"/>
-          <p:cNvSpPr txBox="1"/>
-          <p:nvPr/>
-        </p:nvSpPr>
-        <p:spPr>
-          <a:xfrm>
-            <a:off x="7132320" y="4663440"/>
-            <a:ext cx="1737360" cy="658368"/>
-          </a:xfrm>
-          <a:prstGeom prst="rect">
-            <a:avLst/>
-          </a:prstGeom>
-          <a:noFill/>
-        </p:spPr>
-        <p:txBody>
-          <a:bodyPr wrap="square" lIns="36576" rIns="36576" tIns="18288" bIns="18288">
-            <a:spAutoFit/>
-          </a:bodyPr>
-          <a:lstStyle/>
-          <a:p>
-            <a:pPr algn="l"/>
-            <a:r>
-              <a:rPr sz="819" b="0" i="0">
-                <a:solidFill>
-                  <a:srgbClr val="B8D0EC"/>
-                </a:solidFill>
-                <a:latin typeface="Segoe UI"/>
-              </a:rPr>
-              <a:t>Optionally use GitHub CLI during setup when available instead of PAT tokens.</a:t>
-            </a:r>
-          </a:p>
-        </p:txBody>
-      </p:sp>
-      <p:sp>
-        <p:nvSpPr>
-          <p:cNvPr id="65" name="Rounded Rectangle 64"/>
-          <p:cNvSpPr/>
-          <p:nvPr/>
-        </p:nvSpPr>
-        <p:spPr>
-          <a:xfrm>
-            <a:off x="347472" y="5925312"/>
-            <a:ext cx="8449056" cy="438912"/>
-          </a:xfrm>
-          <a:prstGeom prst="roundRect">
-            <a:avLst/>
-          </a:prstGeom>
-          <a:solidFill>
-            <a:srgbClr val="0B1F3A"/>
-          </a:solidFill>
-          <a:ln>
-            <a:noFill/>
-          </a:ln>
-        </p:spPr>
-        <p:style>
-          <a:lnRef idx="1">
-            <a:schemeClr val="accent1"/>
-          </a:lnRef>
-          <a:fillRef idx="3">
-            <a:schemeClr val="accent1"/>
-          </a:fillRef>
-          <a:effectRef idx="2">
-            <a:schemeClr val="accent1"/>
-          </a:effectRef>
-          <a:fontRef idx="minor">
-            <a:schemeClr val="lt1"/>
-          </a:fontRef>
-        </p:style>
-        <p:txBody>
-          <a:bodyPr rtlCol="0" anchor="ctr"/>
-          <a:lstStyle/>
-          <a:p>
-            <a:pPr algn="ctr"/>
-          </a:p>
-        </p:txBody>
-      </p:sp>
-      <p:sp>
-        <p:nvSpPr>
-          <p:cNvPr id="66" name="Rectangle 65"/>
-          <p:cNvSpPr/>
-          <p:nvPr/>
-        </p:nvSpPr>
-        <p:spPr>
-          <a:xfrm>
-            <a:off x="347472" y="5925312"/>
-            <a:ext cx="50292" cy="438912"/>
-          </a:xfrm>
-          <a:prstGeom prst="rect">
-            <a:avLst/>
-          </a:prstGeom>
-          <a:solidFill>
-            <a:srgbClr val="F5C518"/>
-          </a:solidFill>
-          <a:ln>
-            <a:noFill/>
-          </a:ln>
-        </p:spPr>
-        <p:style>
-          <a:lnRef idx="1">
-            <a:schemeClr val="accent1"/>
-          </a:lnRef>
-          <a:fillRef idx="3">
-            <a:schemeClr val="accent1"/>
-          </a:fillRef>
-          <a:effectRef idx="2">
-            <a:schemeClr val="accent1"/>
-          </a:effectRef>
-          <a:fontRef idx="minor">
-            <a:schemeClr val="lt1"/>
-          </a:fontRef>
-        </p:style>
-        <p:txBody>
-          <a:bodyPr rtlCol="0" anchor="ctr"/>
-          <a:lstStyle/>
-          <a:p>
-            <a:pPr algn="ctr"/>
-          </a:p>
-        </p:txBody>
-      </p:sp>
-      <p:sp>
-        <p:nvSpPr>
-          <p:cNvPr id="67" name="TextBox 66"/>
-          <p:cNvSpPr txBox="1"/>
-          <p:nvPr/>
-        </p:nvSpPr>
-        <p:spPr>
-          <a:xfrm>
-            <a:off x="530352" y="6053328"/>
-            <a:ext cx="8046720" cy="128016"/>
-          </a:xfrm>
-          <a:prstGeom prst="rect">
-            <a:avLst/>
-          </a:prstGeom>
-          <a:noFill/>
-        </p:spPr>
-        <p:txBody>
-          <a:bodyPr wrap="square" lIns="36576" rIns="36576" tIns="18288" bIns="18288">
-            <a:spAutoFit/>
-          </a:bodyPr>
-          <a:lstStyle/>
-          <a:p>
-            <a:pPr algn="ctr"/>
-            <a:r>
-              <a:rPr sz="919" b="1" i="0">
-                <a:solidFill>
-                  <a:srgbClr val="F5C518"/>
-                </a:solidFill>
-                <a:latin typeface="Segoe UI"/>
-              </a:rPr>
-              <a:t>STQC integration: codebase -&gt; evidence documents -&gt; TCF -&gt; compliance validation -&gt; READY / NOT_READY remediation.</a:t>
-            </a:r>
-          </a:p>
-        </p:txBody>
-      </p:sp>
-      <p:sp>
-        <p:nvSpPr>
-          <p:cNvPr id="68" name="Rectangle 67"/>
-          <p:cNvSpPr/>
-          <p:nvPr/>
-        </p:nvSpPr>
-        <p:spPr>
-          <a:xfrm>
-            <a:off x="0" y="6473952"/>
-            <a:ext cx="9144000" cy="384048"/>
-          </a:xfrm>
-          <a:prstGeom prst="rect">
-            <a:avLst/>
-          </a:prstGeom>
-          <a:solidFill>
-            <a:srgbClr val="0E2A4A"/>
-          </a:solidFill>
-          <a:ln>
-            <a:noFill/>
-          </a:ln>
-        </p:spPr>
-        <p:style>
-          <a:lnRef idx="1">
-            <a:schemeClr val="accent1"/>
-          </a:lnRef>
-          <a:fillRef idx="3">
-            <a:schemeClr val="accent1"/>
-          </a:fillRef>
-          <a:effectRef idx="2">
-            <a:schemeClr val="accent1"/>
-          </a:effectRef>
-          <a:fontRef idx="minor">
-            <a:schemeClr val="lt1"/>
-          </a:fontRef>
-        </p:style>
-        <p:txBody>
-          <a:bodyPr rtlCol="0" anchor="ctr"/>
-          <a:lstStyle/>
-          <a:p>
-            <a:pPr algn="ctr"/>
-          </a:p>
-        </p:txBody>
-      </p:sp>
-      <p:sp>
-        <p:nvSpPr>
-          <p:cNvPr id="69" name="TextBox 68"/>
-          <p:cNvSpPr txBox="1"/>
-          <p:nvPr/>
-        </p:nvSpPr>
-        <p:spPr>
-          <a:xfrm>
-            <a:off x="8275320" y="6565392"/>
-            <a:ext cx="411480" cy="146304"/>
-          </a:xfrm>
-          <a:prstGeom prst="rect">
-            <a:avLst/>
-          </a:prstGeom>
-          <a:noFill/>
-        </p:spPr>
-        <p:txBody>
-          <a:bodyPr wrap="square" lIns="36576" rIns="36576" tIns="18288" bIns="18288">
-            <a:spAutoFit/>
-          </a:bodyPr>
-          <a:lstStyle/>
-          <a:p>
             <a:pPr algn="r"/>
             <a:r>
-              <a:rPr sz="850" b="0" i="0">
+              <a:rPr sz="1000" b="1">
                 <a:solidFill>
-                  <a:srgbClr val="6080A8"/>
+                  <a:srgbClr val="D71920"/>
                 </a:solidFill>
-                <a:latin typeface="Segoe UI"/>
-              </a:rPr>
-              <a:t>4  /  5</a:t>
-            </a:r>
-          </a:p>
-        </p:txBody>
-      </p:sp>
-      <p:sp>
-        <p:nvSpPr>
-          <p:cNvPr id="70" name="TextBox 69"/>
-          <p:cNvSpPr txBox="1"/>
-          <p:nvPr/>
-        </p:nvSpPr>
-        <p:spPr>
-          <a:xfrm>
-            <a:off x="7406640" y="6565392"/>
-            <a:ext cx="777240" cy="146304"/>
-          </a:xfrm>
-          <a:prstGeom prst="rect">
-            <a:avLst/>
-          </a:prstGeom>
-          <a:noFill/>
-        </p:spPr>
-        <p:txBody>
-          <a:bodyPr wrap="square" lIns="36576" rIns="36576" tIns="18288" bIns="18288">
-            <a:spAutoFit/>
-          </a:bodyPr>
-          <a:lstStyle/>
-          <a:p>
-            <a:pPr algn="r"/>
-            <a:r>
-              <a:rPr sz="850" b="1" i="0">
-                <a:solidFill>
-                  <a:srgbClr val="6080A8"/>
-                </a:solidFill>
-                <a:latin typeface="Segoe UI"/>
+                <a:latin typeface="Arial"/>
               </a:rPr>
               <a:t>HONEYWELL</a:t>
             </a:r>

</xml_diff>